<commit_message>
White gram-positive deck: cover, agenda, Objetivo divider + objective
Four slides per request (white format): title slide, 5-item agenda,
Objetivo section divider, and objective-statement slide with three
emphasis cards (virulencia, evasion inmunitaria, dano tisular).

Co-Authored-By: Claude Opus 4.8 <noreply@anthropic.com>
Claude-Session: https://claude.ai/code/session_01Xvkr5H24hZZBXgabDYzMMQ
</commit_message>
<xml_diff>
--- a/Cocos_grampositivos_BLANCO.pptx
+++ b/Cocos_grampositivos_BLANCO.pptx
@@ -7,9 +7,11 @@
   <p:sldIdLst>
     <p:sldId id="256" r:id="rId2"/>
     <p:sldId id="257" r:id="rId3"/>
+    <p:sldId id="258" r:id="rId4"/>
+    <p:sldId id="259" r:id="rId5"/>
   </p:sldIdLst>
   <p:notesMasterIdLst>
-    <p:notesMasterId r:id="rId4"/>
+    <p:notesMasterId r:id="rId6"/>
   </p:notesMasterIdLst>
   <p:sldSz cx="9144000" cy="5143500"/>
   <p:notesSz cx="5143500" cy="9144000"/>
@@ -503,7 +505,7 @@
           <a:p>
             <a:r>
               <a:rPr lang="en-US" dirty="0"/>
-              <a:t>Portada en formato blanco. Ilustracion original: racimo dorado (Staphylococcus) y cadena roja (Streptococcus).</a:t>
+              <a:t>Portada. Infecciones por grampositivos: de la colonizacion al choque septico. Ilustracion original: racimo dorado (Staphylococcus) y cadena roja (Streptococcus).</a:t>
             </a:r>
             <a:endParaRPr lang="en-US" dirty="0"/>
           </a:p>
@@ -591,7 +593,7 @@
           <a:p>
             <a:r>
               <a:rPr lang="en-US" dirty="0"/>
-              <a:t>Ejemplo de diapositiva de contenido en formato blanco: arbol de clasificación de cocos grampositivos.</a:t>
+              <a:t>Agenda: objetivo, anatomia, fisiologia, fisiopatologia y conclusion.</a:t>
             </a:r>
             <a:endParaRPr lang="en-US" dirty="0"/>
           </a:p>
@@ -615,6 +617,182 @@
             <a:fld id="{F7021451-1387-4CA6-816F-3879F97B5CBC}" type="slidenum">
               <a:rPr lang="en-US"/>
               <a:t>2</a:t>
+            </a:fld>
+            <a:endParaRPr lang="en-US"/>
+          </a:p>
+        </p:txBody>
+      </p:sp>
+    </p:spTree>
+    <p:extLst>
+      <p:ext uri="{BB962C8B-B14F-4D97-AF65-F5344CB8AC3E}">
+        <p14:creationId xmlns:p14="http://schemas.microsoft.com/office/powerpoint/2010/main" val="1024086991"/>
+      </p:ext>
+    </p:extLst>
+  </p:cSld>
+  <p:clrMapOvr>
+    <a:masterClrMapping/>
+  </p:clrMapOvr>
+</p:notes>
+</file>
+
+<file path=ppt/notesSlides/notesSlide3.xml><?xml version="1.0" encoding="utf-8"?>
+<p:notes xmlns:a="http://schemas.openxmlformats.org/drawingml/2006/main" xmlns:r="http://schemas.openxmlformats.org/officeDocument/2006/relationships" xmlns:p="http://schemas.openxmlformats.org/presentationml/2006/main">
+  <p:cSld>
+    <p:spTree>
+      <p:nvGrpSpPr>
+        <p:cNvPr id="1" name=""/>
+        <p:cNvGrpSpPr/>
+        <p:nvPr/>
+      </p:nvGrpSpPr>
+      <p:grpSpPr>
+        <a:xfrm>
+          <a:off x="0" y="0"/>
+          <a:ext cx="0" cy="0"/>
+          <a:chOff x="0" y="0"/>
+          <a:chExt cx="0" cy="0"/>
+        </a:xfrm>
+      </p:grpSpPr>
+      <p:sp>
+        <p:nvSpPr>
+          <p:cNvPr id="2" name="Slide Image Placeholder 1"/>
+          <p:cNvSpPr>
+            <a:spLocks noGrp="1" noRot="1" noChangeAspect="1"/>
+          </p:cNvSpPr>
+          <p:nvPr>
+            <p:ph type="sldImg"/>
+          </p:nvPr>
+        </p:nvSpPr>
+        <p:spPr/>
+      </p:sp>
+      <p:sp>
+        <p:nvSpPr>
+          <p:cNvPr id="3" name="Notes Placeholder 2"/>
+          <p:cNvSpPr>
+            <a:spLocks noGrp="1"/>
+          </p:cNvSpPr>
+          <p:nvPr>
+            <p:ph type="body" idx="1"/>
+          </p:nvPr>
+        </p:nvSpPr>
+        <p:spPr/>
+        <p:txBody>
+          <a:bodyPr/>
+          <a:lstStyle/>
+          <a:p>
+            <a:r>
+              <a:rPr lang="en-US" dirty="0"/>
+              <a:t/>
+            </a:r>
+            <a:endParaRPr lang="en-US" dirty="0"/>
+          </a:p>
+        </p:txBody>
+      </p:sp>
+      <p:sp>
+        <p:nvSpPr>
+          <p:cNvPr id="4" name="Slide Number Placeholder 3"/>
+          <p:cNvSpPr>
+            <a:spLocks noGrp="1"/>
+          </p:cNvSpPr>
+          <p:nvPr>
+            <p:ph type="sldNum" sz="quarter" idx="10"/>
+          </p:nvPr>
+        </p:nvSpPr>
+        <p:spPr/>
+        <p:txBody>
+          <a:bodyPr/>
+          <a:lstStyle/>
+          <a:p>
+            <a:fld id="{F7021451-1387-4CA6-816F-3879F97B5CBC}" type="slidenum">
+              <a:rPr lang="en-US"/>
+              <a:t>3</a:t>
+            </a:fld>
+            <a:endParaRPr lang="en-US"/>
+          </a:p>
+        </p:txBody>
+      </p:sp>
+    </p:spTree>
+    <p:extLst>
+      <p:ext uri="{BB962C8B-B14F-4D97-AF65-F5344CB8AC3E}">
+        <p14:creationId xmlns:p14="http://schemas.microsoft.com/office/powerpoint/2010/main" val="1024086991"/>
+      </p:ext>
+    </p:extLst>
+  </p:cSld>
+  <p:clrMapOvr>
+    <a:masterClrMapping/>
+  </p:clrMapOvr>
+</p:notes>
+</file>
+
+<file path=ppt/notesSlides/notesSlide4.xml><?xml version="1.0" encoding="utf-8"?>
+<p:notes xmlns:a="http://schemas.openxmlformats.org/drawingml/2006/main" xmlns:r="http://schemas.openxmlformats.org/officeDocument/2006/relationships" xmlns:p="http://schemas.openxmlformats.org/presentationml/2006/main">
+  <p:cSld>
+    <p:spTree>
+      <p:nvGrpSpPr>
+        <p:cNvPr id="1" name=""/>
+        <p:cNvGrpSpPr/>
+        <p:nvPr/>
+      </p:nvGrpSpPr>
+      <p:grpSpPr>
+        <a:xfrm>
+          <a:off x="0" y="0"/>
+          <a:ext cx="0" cy="0"/>
+          <a:chOff x="0" y="0"/>
+          <a:chExt cx="0" cy="0"/>
+        </a:xfrm>
+      </p:grpSpPr>
+      <p:sp>
+        <p:nvSpPr>
+          <p:cNvPr id="2" name="Slide Image Placeholder 1"/>
+          <p:cNvSpPr>
+            <a:spLocks noGrp="1" noRot="1" noChangeAspect="1"/>
+          </p:cNvSpPr>
+          <p:nvPr>
+            <p:ph type="sldImg"/>
+          </p:nvPr>
+        </p:nvSpPr>
+        <p:spPr/>
+      </p:sp>
+      <p:sp>
+        <p:nvSpPr>
+          <p:cNvPr id="3" name="Notes Placeholder 2"/>
+          <p:cNvSpPr>
+            <a:spLocks noGrp="1"/>
+          </p:cNvSpPr>
+          <p:nvPr>
+            <p:ph type="body" idx="1"/>
+          </p:nvPr>
+        </p:nvSpPr>
+        <p:spPr/>
+        <p:txBody>
+          <a:bodyPr/>
+          <a:lstStyle/>
+          <a:p>
+            <a:r>
+              <a:rPr lang="en-US" dirty="0"/>
+              <a:t>Objetivo general: comprender los mecanismos fisiopatologicos de las infecciones por grampositivos, con enfasis en virulencia, evasion inmunitaria y dano tisular.</a:t>
+            </a:r>
+            <a:endParaRPr lang="en-US" dirty="0"/>
+          </a:p>
+        </p:txBody>
+      </p:sp>
+      <p:sp>
+        <p:nvSpPr>
+          <p:cNvPr id="4" name="Slide Number Placeholder 3"/>
+          <p:cNvSpPr>
+            <a:spLocks noGrp="1"/>
+          </p:cNvSpPr>
+          <p:nvPr>
+            <p:ph type="sldNum" sz="quarter" idx="10"/>
+          </p:nvPr>
+        </p:nvSpPr>
+        <p:spPr/>
+        <p:txBody>
+          <a:bodyPr/>
+          <a:lstStyle/>
+          <a:p>
+            <a:fld id="{F7021451-1387-4CA6-816F-3879F97B5CBC}" type="slidenum">
+              <a:rPr lang="en-US"/>
+              <a:t>4</a:t>
             </a:fld>
             <a:endParaRPr lang="en-US"/>
           </a:p>
@@ -1068,7 +1246,7 @@
         </p:nvSpPr>
         <p:spPr>
           <a:xfrm>
-            <a:off x="6675120" y="1097280"/>
+            <a:off x="6629400" y="1051560"/>
             <a:ext cx="475488" cy="475488"/>
           </a:xfrm>
           <a:prstGeom prst="ellipse">
@@ -1093,7 +1271,7 @@
         </p:nvSpPr>
         <p:spPr>
           <a:xfrm>
-            <a:off x="7132320" y="1188720"/>
+            <a:off x="7086600" y="1143000"/>
             <a:ext cx="475488" cy="475488"/>
           </a:xfrm>
           <a:prstGeom prst="ellipse">
@@ -1118,7 +1296,7 @@
         </p:nvSpPr>
         <p:spPr>
           <a:xfrm>
-            <a:off x="6903720" y="1554480"/>
+            <a:off x="6858000" y="1508760"/>
             <a:ext cx="475488" cy="475488"/>
           </a:xfrm>
           <a:prstGeom prst="ellipse">
@@ -1143,7 +1321,7 @@
         </p:nvSpPr>
         <p:spPr>
           <a:xfrm>
-            <a:off x="7360920" y="1600200"/>
+            <a:off x="7315200" y="1554480"/>
             <a:ext cx="475488" cy="475488"/>
           </a:xfrm>
           <a:prstGeom prst="ellipse">
@@ -1168,7 +1346,7 @@
         </p:nvSpPr>
         <p:spPr>
           <a:xfrm>
-            <a:off x="6766560" y="1965960"/>
+            <a:off x="6720840" y="1920240"/>
             <a:ext cx="475488" cy="475488"/>
           </a:xfrm>
           <a:prstGeom prst="ellipse">
@@ -1193,7 +1371,7 @@
         </p:nvSpPr>
         <p:spPr>
           <a:xfrm>
-            <a:off x="7223760" y="2011680"/>
+            <a:off x="7178040" y="1965960"/>
             <a:ext cx="475488" cy="475488"/>
           </a:xfrm>
           <a:prstGeom prst="ellipse">
@@ -1218,7 +1396,7 @@
         </p:nvSpPr>
         <p:spPr>
           <a:xfrm>
-            <a:off x="7543800" y="1280160"/>
+            <a:off x="7498080" y="1234440"/>
             <a:ext cx="475488" cy="475488"/>
           </a:xfrm>
           <a:prstGeom prst="ellipse">
@@ -1243,7 +1421,7 @@
         </p:nvSpPr>
         <p:spPr>
           <a:xfrm>
-            <a:off x="7589520" y="1783080"/>
+            <a:off x="7543800" y="1737360"/>
             <a:ext cx="475488" cy="475488"/>
           </a:xfrm>
           <a:prstGeom prst="ellipse">
@@ -1268,7 +1446,7 @@
         </p:nvSpPr>
         <p:spPr>
           <a:xfrm>
-            <a:off x="6583680" y="3200400"/>
+            <a:off x="6537960" y="3200400"/>
             <a:ext cx="402336" cy="402336"/>
           </a:xfrm>
           <a:prstGeom prst="ellipse">
@@ -1293,7 +1471,7 @@
         </p:nvSpPr>
         <p:spPr>
           <a:xfrm>
-            <a:off x="6858000" y="3364992"/>
+            <a:off x="6812280" y="3364992"/>
             <a:ext cx="402336" cy="402336"/>
           </a:xfrm>
           <a:prstGeom prst="ellipse">
@@ -1318,7 +1496,7 @@
         </p:nvSpPr>
         <p:spPr>
           <a:xfrm>
-            <a:off x="7132320" y="3529584"/>
+            <a:off x="7086600" y="3529584"/>
             <a:ext cx="402336" cy="402336"/>
           </a:xfrm>
           <a:prstGeom prst="ellipse">
@@ -1343,7 +1521,7 @@
         </p:nvSpPr>
         <p:spPr>
           <a:xfrm>
-            <a:off x="7406640" y="3694176"/>
+            <a:off x="7360920" y="3694176"/>
             <a:ext cx="402336" cy="402336"/>
           </a:xfrm>
           <a:prstGeom prst="ellipse">
@@ -1368,7 +1546,7 @@
         </p:nvSpPr>
         <p:spPr>
           <a:xfrm>
-            <a:off x="7680960" y="3858768"/>
+            <a:off x="7635240" y="3858768"/>
             <a:ext cx="402336" cy="402336"/>
           </a:xfrm>
           <a:prstGeom prst="ellipse">
@@ -1393,7 +1571,7 @@
         </p:nvSpPr>
         <p:spPr>
           <a:xfrm>
-            <a:off x="7955280" y="4023360"/>
+            <a:off x="7909560" y="4023360"/>
             <a:ext cx="402336" cy="402336"/>
           </a:xfrm>
           <a:prstGeom prst="ellipse">
@@ -1418,7 +1596,7 @@
         </p:nvSpPr>
         <p:spPr>
           <a:xfrm>
-            <a:off x="8229600" y="4187952"/>
+            <a:off x="8183880" y="4187952"/>
             <a:ext cx="402336" cy="402336"/>
           </a:xfrm>
           <a:prstGeom prst="ellipse">
@@ -1444,7 +1622,7 @@
         <p:spPr>
           <a:xfrm>
             <a:off x="548640" y="914400"/>
-            <a:ext cx="5669280" cy="365760"/>
+            <a:ext cx="5760720" cy="365760"/>
           </a:xfrm>
           <a:prstGeom prst="rect">
             <a:avLst/>
@@ -1460,7 +1638,7 @@
               <a:buNone/>
             </a:pPr>
             <a:r>
-              <a:rPr lang="en-US" sz="1600" b="1" spc="500" kern="0" dirty="0">
+              <a:rPr lang="en-US" sz="1500" b="1" spc="400" kern="0" dirty="0">
                 <a:solidFill>
                   <a:srgbClr val="6A4CCF"/>
                 </a:solidFill>
@@ -1468,9 +1646,9 @@
                 <a:ea typeface="Calibri" pitchFamily="34" charset="-122"/>
                 <a:cs typeface="Calibri" pitchFamily="34" charset="-120"/>
               </a:rPr>
-              <a:t>COCOS GRAMPOSITIVOS</a:t>
-            </a:r>
-            <a:endParaRPr lang="en-US" sz="1600" dirty="0"/>
+              <a:t>INFECCIONES POR GRAMPOSITIVOS</a:t>
+            </a:r>
+            <a:endParaRPr lang="en-US" sz="1500" dirty="0"/>
           </a:p>
         </p:txBody>
       </p:sp>
@@ -1483,7 +1661,7 @@
         <p:spPr>
           <a:xfrm>
             <a:off x="548640" y="1325880"/>
-            <a:ext cx="5852160" cy="777240"/>
+            <a:ext cx="5852160" cy="914400"/>
           </a:xfrm>
           <a:prstGeom prst="rect">
             <a:avLst/>
@@ -1499,7 +1677,7 @@
               <a:buNone/>
             </a:pPr>
             <a:r>
-              <a:rPr lang="en-US" sz="4600" b="1" dirty="0">
+              <a:rPr lang="en-US" sz="5200" b="1" dirty="0">
                 <a:solidFill>
                   <a:srgbClr val="15193A"/>
                 </a:solidFill>
@@ -1507,9 +1685,9 @@
                 <a:ea typeface="Calibri" pitchFamily="34" charset="-122"/>
                 <a:cs typeface="Calibri" pitchFamily="34" charset="-120"/>
               </a:rPr>
-              <a:t>Clasificación y</a:t>
-            </a:r>
-            <a:endParaRPr lang="en-US" sz="4600" dirty="0"/>
+              <a:t>Grampositivos</a:t>
+            </a:r>
+            <a:endParaRPr lang="en-US" sz="5200" dirty="0"/>
           </a:p>
         </p:txBody>
       </p:sp>
@@ -1521,8 +1699,8 @@
         </p:nvSpPr>
         <p:spPr>
           <a:xfrm>
-            <a:off x="548640" y="2103120"/>
-            <a:ext cx="5852160" cy="777240"/>
+            <a:off x="548640" y="2377440"/>
+            <a:ext cx="5760720" cy="822960"/>
           </a:xfrm>
           <a:prstGeom prst="rect">
             <a:avLst/>
@@ -1531,53 +1709,14 @@
           <a:ln/>
         </p:spPr>
         <p:txBody>
-          <a:bodyPr wrap="square" lIns="0" tIns="0" rIns="0" bIns="0" rtlCol="0" anchor="b"/>
+          <a:bodyPr wrap="square" lIns="0" tIns="0" rIns="0" bIns="0" rtlCol="0" anchor="t"/>
           <a:lstStyle/>
           <a:p>
             <a:pPr indent="0" marL="0">
               <a:buNone/>
             </a:pPr>
             <a:r>
-              <a:rPr lang="en-US" sz="4600" b="1" dirty="0">
-                <a:solidFill>
-                  <a:srgbClr val="15193A"/>
-                </a:solidFill>
-                <a:latin typeface="Calibri" pitchFamily="34" charset="0"/>
-                <a:ea typeface="Calibri" pitchFamily="34" charset="-122"/>
-                <a:cs typeface="Calibri" pitchFamily="34" charset="-120"/>
-              </a:rPr>
-              <a:t>fisiopatología</a:t>
-            </a:r>
-            <a:endParaRPr lang="en-US" sz="4600" dirty="0"/>
-          </a:p>
-        </p:txBody>
-      </p:sp>
-      <p:sp>
-        <p:nvSpPr>
-          <p:cNvPr id="20" name="Text 18"/>
-          <p:cNvSpPr txBox="1"/>
-          <p:nvPr/>
-        </p:nvSpPr>
-        <p:spPr>
-          <a:xfrm>
-            <a:off x="548640" y="3017520"/>
-            <a:ext cx="5486400" cy="457200"/>
-          </a:xfrm>
-          <a:prstGeom prst="rect">
-            <a:avLst/>
-          </a:prstGeom>
-          <a:noFill/>
-          <a:ln/>
-        </p:spPr>
-        <p:txBody>
-          <a:bodyPr wrap="square" lIns="0" tIns="0" rIns="0" bIns="0" rtlCol="0" anchor="t"/>
-          <a:lstStyle/>
-          <a:p>
-            <a:pPr indent="0" marL="0">
-              <a:buNone/>
-            </a:pPr>
-            <a:r>
-              <a:rPr lang="en-US" sz="2100" dirty="0">
+              <a:rPr lang="en-US" sz="2400" dirty="0">
                 <a:solidFill>
                   <a:srgbClr val="A66A00"/>
                 </a:solidFill>
@@ -1585,22 +1724,22 @@
                 <a:ea typeface="Calibri" pitchFamily="34" charset="-122"/>
                 <a:cs typeface="Calibri" pitchFamily="34" charset="-120"/>
               </a:rPr>
-              <a:t>Del laboratorio a la clínica</a:t>
-            </a:r>
-            <a:endParaRPr lang="en-US" sz="2100" dirty="0"/>
-          </a:p>
-        </p:txBody>
-      </p:sp>
-      <p:sp>
-        <p:nvSpPr>
-          <p:cNvPr id="21" name="Text 19"/>
+              <a:t>De la colonización al choque séptico</a:t>
+            </a:r>
+            <a:endParaRPr lang="en-US" sz="2400" dirty="0"/>
+          </a:p>
+        </p:txBody>
+      </p:sp>
+      <p:sp>
+        <p:nvSpPr>
+          <p:cNvPr id="20" name="Text 18"/>
           <p:cNvSpPr txBox="1"/>
           <p:nvPr/>
         </p:nvSpPr>
         <p:spPr>
           <a:xfrm>
-            <a:off x="548640" y="3886200"/>
-            <a:ext cx="5486400" cy="411480"/>
+            <a:off x="548640" y="3794760"/>
+            <a:ext cx="5669280" cy="411480"/>
           </a:xfrm>
           <a:prstGeom prst="rect">
             <a:avLst/>
@@ -1624,7 +1763,7 @@
                 <a:ea typeface="Calibri" pitchFamily="34" charset="-122"/>
                 <a:cs typeface="Calibri" pitchFamily="34" charset="-120"/>
               </a:rPr>
-              <a:t>Nestor Fabian Sanabria Duarte</a:t>
+              <a:t>Néstor Fabián Sanabria Duarte</a:t>
             </a:r>
             <a:endParaRPr lang="en-US" sz="2200" dirty="0"/>
           </a:p>
@@ -1632,14 +1771,14 @@
       </p:sp>
       <p:sp>
         <p:nvSpPr>
-          <p:cNvPr id="22" name="Text 20"/>
+          <p:cNvPr id="21" name="Text 19"/>
           <p:cNvSpPr txBox="1"/>
           <p:nvPr/>
         </p:nvSpPr>
         <p:spPr>
           <a:xfrm>
-            <a:off x="548640" y="4279392"/>
-            <a:ext cx="6400800" cy="320040"/>
+            <a:off x="548640" y="4187952"/>
+            <a:ext cx="5943600" cy="320040"/>
           </a:xfrm>
           <a:prstGeom prst="rect">
             <a:avLst/>
@@ -1655,7 +1794,7 @@
               <a:buNone/>
             </a:pPr>
             <a:r>
-              <a:rPr lang="en-US" sz="1400" dirty="0">
+              <a:rPr lang="en-US" sz="1500" dirty="0">
                 <a:solidFill>
                   <a:srgbClr val="51597F"/>
                 </a:solidFill>
@@ -1663,7 +1802,46 @@
                 <a:ea typeface="Calibri" pitchFamily="34" charset="-122"/>
                 <a:cs typeface="Calibri" pitchFamily="34" charset="-120"/>
               </a:rPr>
-              <a:t>Residente de III año - Especialización en medicina interna</a:t>
+              <a:t>Residente de Medicina Interna</a:t>
+            </a:r>
+            <a:endParaRPr lang="en-US" sz="1500" dirty="0"/>
+          </a:p>
+        </p:txBody>
+      </p:sp>
+      <p:sp>
+        <p:nvSpPr>
+          <p:cNvPr id="22" name="Text 20"/>
+          <p:cNvSpPr txBox="1"/>
+          <p:nvPr/>
+        </p:nvSpPr>
+        <p:spPr>
+          <a:xfrm>
+            <a:off x="548640" y="4480560"/>
+            <a:ext cx="5943600" cy="292608"/>
+          </a:xfrm>
+          <a:prstGeom prst="rect">
+            <a:avLst/>
+          </a:prstGeom>
+          <a:noFill/>
+          <a:ln/>
+        </p:spPr>
+        <p:txBody>
+          <a:bodyPr wrap="square" lIns="0" tIns="0" rIns="0" bIns="0" rtlCol="0" anchor="t"/>
+          <a:lstStyle/>
+          <a:p>
+            <a:pPr indent="0" marL="0">
+              <a:buNone/>
+            </a:pPr>
+            <a:r>
+              <a:rPr lang="en-US" sz="1400" dirty="0">
+                <a:solidFill>
+                  <a:srgbClr val="9AA0C0"/>
+                </a:solidFill>
+                <a:latin typeface="Calibri" pitchFamily="34" charset="0"/>
+                <a:ea typeface="Calibri" pitchFamily="34" charset="-122"/>
+                <a:cs typeface="Calibri" pitchFamily="34" charset="-120"/>
+              </a:rPr>
+              <a:t>Universidad Libre</a:t>
             </a:r>
             <a:endParaRPr lang="en-US" sz="1400" dirty="0"/>
           </a:p>
@@ -1728,13 +1906,13 @@
             <a:r>
               <a:rPr lang="en-US" sz="1300" b="1" spc="300" kern="0" dirty="0">
                 <a:solidFill>
-                  <a:srgbClr val="A66A00"/>
+                  <a:srgbClr val="6A4CCF"/>
                 </a:solidFill>
                 <a:latin typeface="Calibri" pitchFamily="34" charset="0"/>
                 <a:ea typeface="Calibri" pitchFamily="34" charset="-122"/>
                 <a:cs typeface="Calibri" pitchFamily="34" charset="-120"/>
               </a:rPr>
-              <a:t>CLASIFICACIÓN</a:t>
+              <a:t>AGENDA</a:t>
             </a:r>
             <a:endParaRPr lang="en-US" sz="1300" dirty="0"/>
           </a:p>
@@ -1773,7 +1951,7 @@
                 <a:ea typeface="Calibri" pitchFamily="34" charset="-122"/>
                 <a:cs typeface="Calibri" pitchFamily="34" charset="-120"/>
               </a:rPr>
-              <a:t>Árbol práctico: de la catalasa al género</a:t>
+              <a:t>Ruta de la exposición</a:t>
             </a:r>
             <a:endParaRPr lang="en-US" sz="3000" dirty="0"/>
           </a:p>
@@ -1787,16 +1965,22 @@
         </p:nvSpPr>
         <p:spPr>
           <a:xfrm>
-            <a:off x="457200" y="4507992"/>
-            <a:ext cx="8229600" cy="0"/>
-          </a:xfrm>
-          <a:prstGeom prst="line">
-            <a:avLst/>
-          </a:prstGeom>
-          <a:noFill/>
-          <a:ln w="9525">
+            <a:off x="365760" y="1554480"/>
+            <a:ext cx="1572768" cy="1920240"/>
+          </a:xfrm>
+          <a:prstGeom prst="roundRect">
+            <a:avLst>
+              <a:gd name="adj" fmla="val 5814"/>
+            </a:avLst>
+          </a:prstGeom>
+          <a:solidFill>
+            <a:srgbClr val="A78BFA">
+              <a:alpha val="10000"/>
+            </a:srgbClr>
+          </a:solidFill>
+          <a:ln w="19050">
             <a:solidFill>
-              <a:srgbClr val="D7DCEF"/>
+              <a:srgbClr val="A78BFA"/>
             </a:solidFill>
             <a:prstDash val="solid"/>
           </a:ln>
@@ -1810,8 +1994,8 @@
         </p:nvSpPr>
         <p:spPr>
           <a:xfrm>
-            <a:off x="457200" y="4553712"/>
-            <a:ext cx="7818120" cy="502920"/>
+            <a:off x="365760" y="1737360"/>
+            <a:ext cx="1572768" cy="731520"/>
           </a:xfrm>
           <a:prstGeom prst="rect">
             <a:avLst/>
@@ -1823,78 +2007,34 @@
           <a:bodyPr wrap="square" lIns="0" tIns="0" rIns="0" bIns="0" rtlCol="0" anchor="ctr"/>
           <a:lstStyle/>
           <a:p>
-            <a:pPr indent="0" marL="0">
+            <a:pPr algn="ctr" indent="0" marL="0">
               <a:buNone/>
             </a:pPr>
             <a:r>
-              <a:rPr lang="en-US" sz="900" dirty="0">
+              <a:rPr lang="en-US" sz="3800" b="1" dirty="0">
                 <a:solidFill>
-                  <a:srgbClr val="51597F"/>
+                  <a:srgbClr val="6A4CCF"/>
                 </a:solidFill>
                 <a:latin typeface="Calibri" pitchFamily="34" charset="0"/>
                 <a:ea typeface="Calibri" pitchFamily="34" charset="-122"/>
                 <a:cs typeface="Calibri" pitchFamily="34" charset="-120"/>
               </a:rPr>
-              <a:t>1. Cheung GYC, Bae JS, Otto M. Pathogenicity and virulence of Staphylococcus aureus. Virulence. 2021;12(1):547-69.</a:t>
-            </a:r>
-            <a:endParaRPr lang="en-US" sz="900" dirty="0"/>
-          </a:p>
-          <a:p>
-            <a:pPr indent="0" marL="0">
-              <a:buNone/>
-            </a:pPr>
-            <a:r>
-              <a:rPr lang="en-US" sz="900" dirty="0">
-                <a:solidFill>
-                  <a:srgbClr val="51597F"/>
-                </a:solidFill>
-                <a:latin typeface="Calibri" pitchFamily="34" charset="0"/>
-                <a:ea typeface="Calibri" pitchFamily="34" charset="-122"/>
-                <a:cs typeface="Calibri" pitchFamily="34" charset="-120"/>
-              </a:rPr>
-              <a:t>2. Brouwer S, Rivera-Hernandez T, Curren BF, Harbison-Price N, De Oliveira DMP, Jespersen MG, et al. Pathogenesis, epidemiology and control of Group A Streptococcus infection. Nat Rev Microbiol. 2023;21(7):431-47.</a:t>
-            </a:r>
-            <a:endParaRPr lang="en-US" sz="900" dirty="0"/>
-          </a:p>
-        </p:txBody>
-      </p:sp>
-      <p:sp>
-        <p:nvSpPr>
-          <p:cNvPr id="6" name="Shape 4"/>
-          <p:cNvSpPr/>
-          <p:nvPr/>
-        </p:nvSpPr>
-        <p:spPr>
-          <a:xfrm>
-            <a:off x="3291840" y="1143000"/>
-            <a:ext cx="2560320" cy="502920"/>
-          </a:xfrm>
-          <a:prstGeom prst="roundRect">
-            <a:avLst>
-              <a:gd name="adj" fmla="val 18182"/>
-            </a:avLst>
-          </a:prstGeom>
-          <a:solidFill>
-            <a:srgbClr val="A78BFA"/>
-          </a:solidFill>
-          <a:ln w="12700">
-            <a:solidFill>
-              <a:srgbClr val="A78BFA"/>
-            </a:solidFill>
-            <a:prstDash val="solid"/>
-          </a:ln>
-        </p:spPr>
-      </p:sp>
-      <p:sp>
-        <p:nvSpPr>
-          <p:cNvPr id="7" name="Text 5"/>
+              <a:t>01</a:t>
+            </a:r>
+            <a:endParaRPr lang="en-US" sz="3800" dirty="0"/>
+          </a:p>
+        </p:txBody>
+      </p:sp>
+      <p:sp>
+        <p:nvSpPr>
+          <p:cNvPr id="6" name="Text 4"/>
           <p:cNvSpPr txBox="1"/>
           <p:nvPr/>
         </p:nvSpPr>
         <p:spPr>
           <a:xfrm>
-            <a:off x="3346704" y="1143000"/>
-            <a:ext cx="2450592" cy="502920"/>
+            <a:off x="347472" y="2514600"/>
+            <a:ext cx="1609344" cy="777240"/>
           </a:xfrm>
           <a:prstGeom prst="rect">
             <a:avLst/>
@@ -1903,265 +2043,7 @@
           <a:ln/>
         </p:spPr>
         <p:txBody>
-          <a:bodyPr wrap="square" lIns="0" tIns="0" rIns="0" bIns="0" rtlCol="0" anchor="ctr"/>
-          <a:lstStyle/>
-          <a:p>
-            <a:pPr algn="ctr" indent="0" marL="0">
-              <a:buNone/>
-            </a:pPr>
-            <a:r>
-              <a:rPr lang="en-US" sz="1700" b="1" dirty="0">
-                <a:solidFill>
-                  <a:srgbClr val="15193A"/>
-                </a:solidFill>
-                <a:latin typeface="Calibri" pitchFamily="34" charset="0"/>
-                <a:ea typeface="Calibri" pitchFamily="34" charset="-122"/>
-                <a:cs typeface="Calibri" pitchFamily="34" charset="-120"/>
-              </a:rPr>
-              <a:t>Cocos grampositivos</a:t>
-            </a:r>
-            <a:endParaRPr lang="en-US" sz="1700" dirty="0"/>
-          </a:p>
-        </p:txBody>
-      </p:sp>
-      <p:sp>
-        <p:nvSpPr>
-          <p:cNvPr id="8" name="Shape 6"/>
-          <p:cNvSpPr/>
-          <p:nvPr/>
-        </p:nvSpPr>
-        <p:spPr>
-          <a:xfrm flipH="1">
-            <a:off x="2286000" y="1645920"/>
-            <a:ext cx="1737360" cy="365760"/>
-          </a:xfrm>
-          <a:prstGeom prst="line">
-            <a:avLst/>
-          </a:prstGeom>
-          <a:noFill/>
-          <a:ln w="31750">
-            <a:solidFill>
-              <a:srgbClr val="A66A00"/>
-            </a:solidFill>
-            <a:prstDash val="solid"/>
-            <a:tailEnd type="triangle"/>
-          </a:ln>
-        </p:spPr>
-      </p:sp>
-      <p:sp>
-        <p:nvSpPr>
-          <p:cNvPr id="9" name="Shape 7"/>
-          <p:cNvSpPr/>
-          <p:nvPr/>
-        </p:nvSpPr>
-        <p:spPr>
-          <a:xfrm>
-            <a:off x="5120640" y="1645920"/>
-            <a:ext cx="1645920" cy="365760"/>
-          </a:xfrm>
-          <a:prstGeom prst="line">
-            <a:avLst/>
-          </a:prstGeom>
-          <a:noFill/>
-          <a:ln w="31750">
-            <a:solidFill>
-              <a:srgbClr val="0C8368"/>
-            </a:solidFill>
-            <a:prstDash val="solid"/>
-            <a:tailEnd type="triangle"/>
-          </a:ln>
-        </p:spPr>
-      </p:sp>
-      <p:sp>
-        <p:nvSpPr>
-          <p:cNvPr id="10" name="Text 8"/>
-          <p:cNvSpPr txBox="1"/>
-          <p:nvPr/>
-        </p:nvSpPr>
-        <p:spPr>
-          <a:xfrm>
-            <a:off x="2103120" y="1664208"/>
-            <a:ext cx="1828800" cy="274320"/>
-          </a:xfrm>
-          <a:prstGeom prst="rect">
-            <a:avLst/>
-          </a:prstGeom>
-          <a:noFill/>
-          <a:ln/>
-        </p:spPr>
-        <p:txBody>
           <a:bodyPr wrap="square" lIns="0" tIns="0" rIns="0" bIns="0" rtlCol="0" anchor="t"/>
-          <a:lstStyle/>
-          <a:p>
-            <a:pPr algn="ctr" indent="0" marL="0">
-              <a:buNone/>
-            </a:pPr>
-            <a:r>
-              <a:rPr lang="en-US" sz="1300" b="1" dirty="0">
-                <a:solidFill>
-                  <a:srgbClr val="A66A00"/>
-                </a:solidFill>
-                <a:latin typeface="Calibri" pitchFamily="34" charset="0"/>
-                <a:ea typeface="Calibri" pitchFamily="34" charset="-122"/>
-                <a:cs typeface="Calibri" pitchFamily="34" charset="-120"/>
-              </a:rPr>
-              <a:t>Catalasa +</a:t>
-            </a:r>
-            <a:endParaRPr lang="en-US" sz="1300" dirty="0"/>
-          </a:p>
-        </p:txBody>
-      </p:sp>
-      <p:sp>
-        <p:nvSpPr>
-          <p:cNvPr id="11" name="Text 9"/>
-          <p:cNvSpPr txBox="1"/>
-          <p:nvPr/>
-        </p:nvSpPr>
-        <p:spPr>
-          <a:xfrm>
-            <a:off x="5212080" y="1664208"/>
-            <a:ext cx="1828800" cy="274320"/>
-          </a:xfrm>
-          <a:prstGeom prst="rect">
-            <a:avLst/>
-          </a:prstGeom>
-          <a:noFill/>
-          <a:ln/>
-        </p:spPr>
-        <p:txBody>
-          <a:bodyPr wrap="square" lIns="0" tIns="0" rIns="0" bIns="0" rtlCol="0" anchor="t"/>
-          <a:lstStyle/>
-          <a:p>
-            <a:pPr algn="ctr" indent="0" marL="0">
-              <a:buNone/>
-            </a:pPr>
-            <a:r>
-              <a:rPr lang="en-US" sz="1300" b="1" dirty="0">
-                <a:solidFill>
-                  <a:srgbClr val="0C8368"/>
-                </a:solidFill>
-                <a:latin typeface="Calibri" pitchFamily="34" charset="0"/>
-                <a:ea typeface="Calibri" pitchFamily="34" charset="-122"/>
-                <a:cs typeface="Calibri" pitchFamily="34" charset="-120"/>
-              </a:rPr>
-              <a:t>Catalasa -</a:t>
-            </a:r>
-            <a:endParaRPr lang="en-US" sz="1300" dirty="0"/>
-          </a:p>
-        </p:txBody>
-      </p:sp>
-      <p:sp>
-        <p:nvSpPr>
-          <p:cNvPr id="12" name="Shape 10"/>
-          <p:cNvSpPr/>
-          <p:nvPr/>
-        </p:nvSpPr>
-        <p:spPr>
-          <a:xfrm>
-            <a:off x="1188720" y="2057400"/>
-            <a:ext cx="2194560" cy="502920"/>
-          </a:xfrm>
-          <a:prstGeom prst="roundRect">
-            <a:avLst>
-              <a:gd name="adj" fmla="val 18182"/>
-            </a:avLst>
-          </a:prstGeom>
-          <a:solidFill>
-            <a:srgbClr val="F2B43C"/>
-          </a:solidFill>
-          <a:ln w="12700">
-            <a:solidFill>
-              <a:srgbClr val="F2B43C"/>
-            </a:solidFill>
-            <a:prstDash val="solid"/>
-          </a:ln>
-        </p:spPr>
-      </p:sp>
-      <p:sp>
-        <p:nvSpPr>
-          <p:cNvPr id="13" name="Text 11"/>
-          <p:cNvSpPr txBox="1"/>
-          <p:nvPr/>
-        </p:nvSpPr>
-        <p:spPr>
-          <a:xfrm>
-            <a:off x="1243584" y="2057400"/>
-            <a:ext cx="2084832" cy="502920"/>
-          </a:xfrm>
-          <a:prstGeom prst="rect">
-            <a:avLst/>
-          </a:prstGeom>
-          <a:noFill/>
-          <a:ln/>
-        </p:spPr>
-        <p:txBody>
-          <a:bodyPr wrap="square" lIns="0" tIns="0" rIns="0" bIns="0" rtlCol="0" anchor="ctr"/>
-          <a:lstStyle/>
-          <a:p>
-            <a:pPr algn="ctr" indent="0" marL="0">
-              <a:buNone/>
-            </a:pPr>
-            <a:r>
-              <a:rPr lang="en-US" sz="1600" b="1" dirty="0">
-                <a:solidFill>
-                  <a:srgbClr val="15193A"/>
-                </a:solidFill>
-                <a:latin typeface="Calibri" pitchFamily="34" charset="0"/>
-                <a:ea typeface="Calibri" pitchFamily="34" charset="-122"/>
-                <a:cs typeface="Calibri" pitchFamily="34" charset="-120"/>
-              </a:rPr>
-              <a:t>Staphylococcus</a:t>
-            </a:r>
-            <a:endParaRPr lang="en-US" sz="1600" dirty="0"/>
-          </a:p>
-        </p:txBody>
-      </p:sp>
-      <p:sp>
-        <p:nvSpPr>
-          <p:cNvPr id="14" name="Shape 12"/>
-          <p:cNvSpPr/>
-          <p:nvPr/>
-        </p:nvSpPr>
-        <p:spPr>
-          <a:xfrm>
-            <a:off x="5760720" y="2057400"/>
-            <a:ext cx="2194560" cy="502920"/>
-          </a:xfrm>
-          <a:prstGeom prst="roundRect">
-            <a:avLst>
-              <a:gd name="adj" fmla="val 18182"/>
-            </a:avLst>
-          </a:prstGeom>
-          <a:solidFill>
-            <a:srgbClr val="2EC4B6"/>
-          </a:solidFill>
-          <a:ln w="12700">
-            <a:solidFill>
-              <a:srgbClr val="2EC4B6"/>
-            </a:solidFill>
-            <a:prstDash val="solid"/>
-          </a:ln>
-        </p:spPr>
-      </p:sp>
-      <p:sp>
-        <p:nvSpPr>
-          <p:cNvPr id="15" name="Text 13"/>
-          <p:cNvSpPr txBox="1"/>
-          <p:nvPr/>
-        </p:nvSpPr>
-        <p:spPr>
-          <a:xfrm>
-            <a:off x="5815584" y="2057400"/>
-            <a:ext cx="2084832" cy="502920"/>
-          </a:xfrm>
-          <a:prstGeom prst="rect">
-            <a:avLst/>
-          </a:prstGeom>
-          <a:noFill/>
-          <a:ln/>
-        </p:spPr>
-        <p:txBody>
-          <a:bodyPr wrap="square" lIns="0" tIns="0" rIns="0" bIns="0" rtlCol="0" anchor="ctr"/>
           <a:lstStyle/>
           <a:p>
             <a:pPr algn="ctr" indent="0" marL="0">
@@ -2176,7 +2058,7 @@
                 <a:ea typeface="Calibri" pitchFamily="34" charset="-122"/>
                 <a:cs typeface="Calibri" pitchFamily="34" charset="-120"/>
               </a:rPr>
-              <a:t>Strepto / Enterococcus</a:t>
+              <a:t>Objetivo</a:t>
             </a:r>
             <a:endParaRPr lang="en-US" sz="1500" dirty="0"/>
           </a:p>
@@ -2184,70 +2066,24 @@
       </p:sp>
       <p:sp>
         <p:nvSpPr>
-          <p:cNvPr id="16" name="Shape 14"/>
+          <p:cNvPr id="7" name="Shape 5"/>
           <p:cNvSpPr/>
           <p:nvPr/>
         </p:nvSpPr>
         <p:spPr>
-          <a:xfrm flipH="1">
-            <a:off x="1280160" y="2560320"/>
-            <a:ext cx="457200" cy="320040"/>
-          </a:xfrm>
-          <a:prstGeom prst="line">
-            <a:avLst/>
-          </a:prstGeom>
-          <a:noFill/>
-          <a:ln w="31750">
-            <a:solidFill>
-              <a:srgbClr val="A66A00"/>
-            </a:solidFill>
-            <a:prstDash val="solid"/>
-            <a:tailEnd type="triangle"/>
-          </a:ln>
-        </p:spPr>
-      </p:sp>
-      <p:sp>
-        <p:nvSpPr>
-          <p:cNvPr id="17" name="Shape 15"/>
-          <p:cNvSpPr/>
-          <p:nvPr/>
-        </p:nvSpPr>
-        <p:spPr>
-          <a:xfrm>
-            <a:off x="2743200" y="2560320"/>
-            <a:ext cx="365760" cy="320040"/>
-          </a:xfrm>
-          <a:prstGeom prst="line">
-            <a:avLst/>
-          </a:prstGeom>
-          <a:noFill/>
-          <a:ln w="31750">
-            <a:solidFill>
-              <a:srgbClr val="A66A00"/>
-            </a:solidFill>
-            <a:prstDash val="solid"/>
-            <a:tailEnd type="triangle"/>
-          </a:ln>
-        </p:spPr>
-      </p:sp>
-      <p:sp>
-        <p:nvSpPr>
-          <p:cNvPr id="18" name="Shape 16"/>
-          <p:cNvSpPr/>
-          <p:nvPr/>
-        </p:nvSpPr>
-        <p:spPr>
-          <a:xfrm>
-            <a:off x="457200" y="2926080"/>
-            <a:ext cx="1828800" cy="868680"/>
+          <a:xfrm>
+            <a:off x="2066544" y="1554480"/>
+            <a:ext cx="1572768" cy="1920240"/>
           </a:xfrm>
           <a:prstGeom prst="roundRect">
             <a:avLst>
-              <a:gd name="adj" fmla="val 10526"/>
+              <a:gd name="adj" fmla="val 5814"/>
             </a:avLst>
           </a:prstGeom>
           <a:solidFill>
-            <a:srgbClr val="ECEFF9"/>
+            <a:srgbClr val="F2B43C">
+              <a:alpha val="10000"/>
+            </a:srgbClr>
           </a:solidFill>
           <a:ln w="19050">
             <a:solidFill>
@@ -2259,14 +2095,14 @@
       </p:sp>
       <p:sp>
         <p:nvSpPr>
-          <p:cNvPr id="19" name="Text 17"/>
+          <p:cNvPr id="8" name="Text 6"/>
           <p:cNvSpPr txBox="1"/>
           <p:nvPr/>
         </p:nvSpPr>
         <p:spPr>
           <a:xfrm>
-            <a:off x="566928" y="2926080"/>
-            <a:ext cx="1645920" cy="868680"/>
+            <a:off x="2066544" y="1737360"/>
+            <a:ext cx="1572768" cy="731520"/>
           </a:xfrm>
           <a:prstGeom prst="rect">
             <a:avLst/>
@@ -2278,11 +2114,50 @@
           <a:bodyPr wrap="square" lIns="0" tIns="0" rIns="0" bIns="0" rtlCol="0" anchor="ctr"/>
           <a:lstStyle/>
           <a:p>
-            <a:pPr indent="0" marL="0">
+            <a:pPr algn="ctr" indent="0" marL="0">
               <a:buNone/>
             </a:pPr>
             <a:r>
-              <a:rPr lang="en-US" sz="1300" dirty="0">
+              <a:rPr lang="en-US" sz="3800" b="1" dirty="0">
+                <a:solidFill>
+                  <a:srgbClr val="A66A00"/>
+                </a:solidFill>
+                <a:latin typeface="Calibri" pitchFamily="34" charset="0"/>
+                <a:ea typeface="Calibri" pitchFamily="34" charset="-122"/>
+                <a:cs typeface="Calibri" pitchFamily="34" charset="-120"/>
+              </a:rPr>
+              <a:t>02</a:t>
+            </a:r>
+            <a:endParaRPr lang="en-US" sz="3800" dirty="0"/>
+          </a:p>
+        </p:txBody>
+      </p:sp>
+      <p:sp>
+        <p:nvSpPr>
+          <p:cNvPr id="9" name="Text 7"/>
+          <p:cNvSpPr txBox="1"/>
+          <p:nvPr/>
+        </p:nvSpPr>
+        <p:spPr>
+          <a:xfrm>
+            <a:off x="2048256" y="2514600"/>
+            <a:ext cx="1609344" cy="777240"/>
+          </a:xfrm>
+          <a:prstGeom prst="rect">
+            <a:avLst/>
+          </a:prstGeom>
+          <a:noFill/>
+          <a:ln/>
+        </p:spPr>
+        <p:txBody>
+          <a:bodyPr wrap="square" lIns="0" tIns="0" rIns="0" bIns="0" rtlCol="0" anchor="t"/>
+          <a:lstStyle/>
+          <a:p>
+            <a:pPr algn="ctr" indent="0" marL="0">
+              <a:buNone/>
+            </a:pPr>
+            <a:r>
+              <a:rPr lang="en-US" sz="1500" b="1" dirty="0">
                 <a:solidFill>
                   <a:srgbClr val="15193A"/>
                 </a:solidFill>
@@ -2290,16 +2165,106 @@
                 <a:ea typeface="Calibri" pitchFamily="34" charset="-122"/>
                 <a:cs typeface="Calibri" pitchFamily="34" charset="-120"/>
               </a:rPr>
-              <a:t>Coagulasa +</a:t>
-            </a:r>
-            <a:endParaRPr lang="en-US" sz="1300" dirty="0"/>
-          </a:p>
-          <a:p>
-            <a:pPr indent="0" marL="0">
+              <a:t>Anatomía</a:t>
+            </a:r>
+            <a:endParaRPr lang="en-US" sz="1500" dirty="0"/>
+          </a:p>
+        </p:txBody>
+      </p:sp>
+      <p:sp>
+        <p:nvSpPr>
+          <p:cNvPr id="10" name="Shape 8"/>
+          <p:cNvSpPr/>
+          <p:nvPr/>
+        </p:nvSpPr>
+        <p:spPr>
+          <a:xfrm>
+            <a:off x="3767328" y="1554480"/>
+            <a:ext cx="1572768" cy="1920240"/>
+          </a:xfrm>
+          <a:prstGeom prst="roundRect">
+            <a:avLst>
+              <a:gd name="adj" fmla="val 5814"/>
+            </a:avLst>
+          </a:prstGeom>
+          <a:solidFill>
+            <a:srgbClr val="2EC4B6">
+              <a:alpha val="10000"/>
+            </a:srgbClr>
+          </a:solidFill>
+          <a:ln w="19050">
+            <a:solidFill>
+              <a:srgbClr val="2EC4B6"/>
+            </a:solidFill>
+            <a:prstDash val="solid"/>
+          </a:ln>
+        </p:spPr>
+      </p:sp>
+      <p:sp>
+        <p:nvSpPr>
+          <p:cNvPr id="11" name="Text 9"/>
+          <p:cNvSpPr txBox="1"/>
+          <p:nvPr/>
+        </p:nvSpPr>
+        <p:spPr>
+          <a:xfrm>
+            <a:off x="3767328" y="1737360"/>
+            <a:ext cx="1572768" cy="731520"/>
+          </a:xfrm>
+          <a:prstGeom prst="rect">
+            <a:avLst/>
+          </a:prstGeom>
+          <a:noFill/>
+          <a:ln/>
+        </p:spPr>
+        <p:txBody>
+          <a:bodyPr wrap="square" lIns="0" tIns="0" rIns="0" bIns="0" rtlCol="0" anchor="ctr"/>
+          <a:lstStyle/>
+          <a:p>
+            <a:pPr algn="ctr" indent="0" marL="0">
               <a:buNone/>
             </a:pPr>
             <a:r>
-              <a:rPr lang="en-US" sz="1300" dirty="0">
+              <a:rPr lang="en-US" sz="3800" b="1" dirty="0">
+                <a:solidFill>
+                  <a:srgbClr val="0C8368"/>
+                </a:solidFill>
+                <a:latin typeface="Calibri" pitchFamily="34" charset="0"/>
+                <a:ea typeface="Calibri" pitchFamily="34" charset="-122"/>
+                <a:cs typeface="Calibri" pitchFamily="34" charset="-120"/>
+              </a:rPr>
+              <a:t>03</a:t>
+            </a:r>
+            <a:endParaRPr lang="en-US" sz="3800" dirty="0"/>
+          </a:p>
+        </p:txBody>
+      </p:sp>
+      <p:sp>
+        <p:nvSpPr>
+          <p:cNvPr id="12" name="Text 10"/>
+          <p:cNvSpPr txBox="1"/>
+          <p:nvPr/>
+        </p:nvSpPr>
+        <p:spPr>
+          <a:xfrm>
+            <a:off x="3749040" y="2514600"/>
+            <a:ext cx="1609344" cy="777240"/>
+          </a:xfrm>
+          <a:prstGeom prst="rect">
+            <a:avLst/>
+          </a:prstGeom>
+          <a:noFill/>
+          <a:ln/>
+        </p:spPr>
+        <p:txBody>
+          <a:bodyPr wrap="square" lIns="0" tIns="0" rIns="0" bIns="0" rtlCol="0" anchor="t"/>
+          <a:lstStyle/>
+          <a:p>
+            <a:pPr algn="ctr" indent="0" marL="0">
+              <a:buNone/>
+            </a:pPr>
+            <a:r>
+              <a:rPr lang="en-US" sz="1500" b="1" dirty="0">
                 <a:solidFill>
                   <a:srgbClr val="15193A"/>
                 </a:solidFill>
@@ -2307,34 +2272,36 @@
                 <a:ea typeface="Calibri" pitchFamily="34" charset="-122"/>
                 <a:cs typeface="Calibri" pitchFamily="34" charset="-120"/>
               </a:rPr>
-              <a:t>S. aureus</a:t>
-            </a:r>
-            <a:endParaRPr lang="en-US" sz="1300" dirty="0"/>
-          </a:p>
-        </p:txBody>
-      </p:sp>
-      <p:sp>
-        <p:nvSpPr>
-          <p:cNvPr id="20" name="Shape 18"/>
+              <a:t>Fisiología</a:t>
+            </a:r>
+            <a:endParaRPr lang="en-US" sz="1500" dirty="0"/>
+          </a:p>
+        </p:txBody>
+      </p:sp>
+      <p:sp>
+        <p:nvSpPr>
+          <p:cNvPr id="13" name="Shape 11"/>
           <p:cNvSpPr/>
           <p:nvPr/>
         </p:nvSpPr>
         <p:spPr>
           <a:xfrm>
-            <a:off x="2468880" y="2926080"/>
-            <a:ext cx="1828800" cy="868680"/>
+            <a:off x="5468112" y="1554480"/>
+            <a:ext cx="1572768" cy="1920240"/>
           </a:xfrm>
           <a:prstGeom prst="roundRect">
             <a:avLst>
-              <a:gd name="adj" fmla="val 10526"/>
+              <a:gd name="adj" fmla="val 5814"/>
             </a:avLst>
           </a:prstGeom>
           <a:solidFill>
-            <a:srgbClr val="ECEFF9"/>
+            <a:srgbClr val="F2546B">
+              <a:alpha val="10000"/>
+            </a:srgbClr>
           </a:solidFill>
           <a:ln w="19050">
             <a:solidFill>
-              <a:srgbClr val="F2B43C"/>
+              <a:srgbClr val="F2546B"/>
             </a:solidFill>
             <a:prstDash val="solid"/>
           </a:ln>
@@ -2342,14 +2309,14 @@
       </p:sp>
       <p:sp>
         <p:nvSpPr>
-          <p:cNvPr id="21" name="Text 19"/>
+          <p:cNvPr id="14" name="Text 12"/>
           <p:cNvSpPr txBox="1"/>
           <p:nvPr/>
         </p:nvSpPr>
         <p:spPr>
           <a:xfrm>
-            <a:off x="2578608" y="2926080"/>
-            <a:ext cx="1645920" cy="868680"/>
+            <a:off x="5468112" y="1737360"/>
+            <a:ext cx="1572768" cy="731520"/>
           </a:xfrm>
           <a:prstGeom prst="rect">
             <a:avLst/>
@@ -2361,11 +2328,50 @@
           <a:bodyPr wrap="square" lIns="0" tIns="0" rIns="0" bIns="0" rtlCol="0" anchor="ctr"/>
           <a:lstStyle/>
           <a:p>
-            <a:pPr indent="0" marL="0">
+            <a:pPr algn="ctr" indent="0" marL="0">
               <a:buNone/>
             </a:pPr>
             <a:r>
-              <a:rPr lang="en-US" sz="1100" dirty="0">
+              <a:rPr lang="en-US" sz="3800" b="1" dirty="0">
+                <a:solidFill>
+                  <a:srgbClr val="C81E43"/>
+                </a:solidFill>
+                <a:latin typeface="Calibri" pitchFamily="34" charset="0"/>
+                <a:ea typeface="Calibri" pitchFamily="34" charset="-122"/>
+                <a:cs typeface="Calibri" pitchFamily="34" charset="-120"/>
+              </a:rPr>
+              <a:t>04</a:t>
+            </a:r>
+            <a:endParaRPr lang="en-US" sz="3800" dirty="0"/>
+          </a:p>
+        </p:txBody>
+      </p:sp>
+      <p:sp>
+        <p:nvSpPr>
+          <p:cNvPr id="15" name="Text 13"/>
+          <p:cNvSpPr txBox="1"/>
+          <p:nvPr/>
+        </p:nvSpPr>
+        <p:spPr>
+          <a:xfrm>
+            <a:off x="5449824" y="2514600"/>
+            <a:ext cx="1609344" cy="777240"/>
+          </a:xfrm>
+          <a:prstGeom prst="rect">
+            <a:avLst/>
+          </a:prstGeom>
+          <a:noFill/>
+          <a:ln/>
+        </p:spPr>
+        <p:txBody>
+          <a:bodyPr wrap="square" lIns="0" tIns="0" rIns="0" bIns="0" rtlCol="0" anchor="t"/>
+          <a:lstStyle/>
+          <a:p>
+            <a:pPr algn="ctr" indent="0" marL="0">
+              <a:buNone/>
+            </a:pPr>
+            <a:r>
+              <a:rPr lang="en-US" sz="1500" b="1" dirty="0">
                 <a:solidFill>
                   <a:srgbClr val="15193A"/>
                 </a:solidFill>
@@ -2373,16 +2379,106 @@
                 <a:ea typeface="Calibri" pitchFamily="34" charset="-122"/>
                 <a:cs typeface="Calibri" pitchFamily="34" charset="-120"/>
               </a:rPr>
-              <a:t>Coagulasa -</a:t>
-            </a:r>
-            <a:endParaRPr lang="en-US" sz="1100" dirty="0"/>
-          </a:p>
-          <a:p>
-            <a:pPr indent="0" marL="0">
+              <a:t>Fisiopatología</a:t>
+            </a:r>
+            <a:endParaRPr lang="en-US" sz="1500" dirty="0"/>
+          </a:p>
+        </p:txBody>
+      </p:sp>
+      <p:sp>
+        <p:nvSpPr>
+          <p:cNvPr id="16" name="Shape 14"/>
+          <p:cNvSpPr/>
+          <p:nvPr/>
+        </p:nvSpPr>
+        <p:spPr>
+          <a:xfrm>
+            <a:off x="7168896" y="1554480"/>
+            <a:ext cx="1572768" cy="1920240"/>
+          </a:xfrm>
+          <a:prstGeom prst="roundRect">
+            <a:avLst>
+              <a:gd name="adj" fmla="val 5814"/>
+            </a:avLst>
+          </a:prstGeom>
+          <a:solidFill>
+            <a:srgbClr val="4CC9F0">
+              <a:alpha val="10000"/>
+            </a:srgbClr>
+          </a:solidFill>
+          <a:ln w="19050">
+            <a:solidFill>
+              <a:srgbClr val="4CC9F0"/>
+            </a:solidFill>
+            <a:prstDash val="solid"/>
+          </a:ln>
+        </p:spPr>
+      </p:sp>
+      <p:sp>
+        <p:nvSpPr>
+          <p:cNvPr id="17" name="Text 15"/>
+          <p:cNvSpPr txBox="1"/>
+          <p:nvPr/>
+        </p:nvSpPr>
+        <p:spPr>
+          <a:xfrm>
+            <a:off x="7168896" y="1737360"/>
+            <a:ext cx="1572768" cy="731520"/>
+          </a:xfrm>
+          <a:prstGeom prst="rect">
+            <a:avLst/>
+          </a:prstGeom>
+          <a:noFill/>
+          <a:ln/>
+        </p:spPr>
+        <p:txBody>
+          <a:bodyPr wrap="square" lIns="0" tIns="0" rIns="0" bIns="0" rtlCol="0" anchor="ctr"/>
+          <a:lstStyle/>
+          <a:p>
+            <a:pPr algn="ctr" indent="0" marL="0">
               <a:buNone/>
             </a:pPr>
             <a:r>
-              <a:rPr lang="en-US" sz="1100" dirty="0">
+              <a:rPr lang="en-US" sz="3800" b="1" dirty="0">
+                <a:solidFill>
+                  <a:srgbClr val="0A6F98"/>
+                </a:solidFill>
+                <a:latin typeface="Calibri" pitchFamily="34" charset="0"/>
+                <a:ea typeface="Calibri" pitchFamily="34" charset="-122"/>
+                <a:cs typeface="Calibri" pitchFamily="34" charset="-120"/>
+              </a:rPr>
+              <a:t>05</a:t>
+            </a:r>
+            <a:endParaRPr lang="en-US" sz="3800" dirty="0"/>
+          </a:p>
+        </p:txBody>
+      </p:sp>
+      <p:sp>
+        <p:nvSpPr>
+          <p:cNvPr id="18" name="Text 16"/>
+          <p:cNvSpPr txBox="1"/>
+          <p:nvPr/>
+        </p:nvSpPr>
+        <p:spPr>
+          <a:xfrm>
+            <a:off x="7150608" y="2514600"/>
+            <a:ext cx="1609344" cy="777240"/>
+          </a:xfrm>
+          <a:prstGeom prst="rect">
+            <a:avLst/>
+          </a:prstGeom>
+          <a:noFill/>
+          <a:ln/>
+        </p:spPr>
+        <p:txBody>
+          <a:bodyPr wrap="square" lIns="0" tIns="0" rIns="0" bIns="0" rtlCol="0" anchor="t"/>
+          <a:lstStyle/>
+          <a:p>
+            <a:pPr algn="ctr" indent="0" marL="0">
+              <a:buNone/>
+            </a:pPr>
+            <a:r>
+              <a:rPr lang="en-US" sz="1500" b="1" dirty="0">
                 <a:solidFill>
                   <a:srgbClr val="15193A"/>
                 </a:solidFill>
@@ -2390,291 +2486,9 @@
                 <a:ea typeface="Calibri" pitchFamily="34" charset="-122"/>
                 <a:cs typeface="Calibri" pitchFamily="34" charset="-120"/>
               </a:rPr>
-              <a:t>S. epidermidis, lugdunensis, saprophyticus</a:t>
-            </a:r>
-            <a:endParaRPr lang="en-US" sz="1100" dirty="0"/>
-          </a:p>
-        </p:txBody>
-      </p:sp>
-      <p:sp>
-        <p:nvSpPr>
-          <p:cNvPr id="22" name="Shape 20"/>
-          <p:cNvSpPr/>
-          <p:nvPr/>
-        </p:nvSpPr>
-        <p:spPr>
-          <a:xfrm flipH="1">
-            <a:off x="5760720" y="2560320"/>
-            <a:ext cx="548640" cy="320040"/>
-          </a:xfrm>
-          <a:prstGeom prst="line">
-            <a:avLst/>
-          </a:prstGeom>
-          <a:noFill/>
-          <a:ln w="31750">
-            <a:solidFill>
-              <a:srgbClr val="0C8368"/>
-            </a:solidFill>
-            <a:prstDash val="solid"/>
-            <a:tailEnd type="triangle"/>
-          </a:ln>
-        </p:spPr>
-      </p:sp>
-      <p:sp>
-        <p:nvSpPr>
-          <p:cNvPr id="23" name="Shape 21"/>
-          <p:cNvSpPr/>
-          <p:nvPr/>
-        </p:nvSpPr>
-        <p:spPr>
-          <a:xfrm>
-            <a:off x="7406640" y="2560320"/>
-            <a:ext cx="548640" cy="320040"/>
-          </a:xfrm>
-          <a:prstGeom prst="line">
-            <a:avLst/>
-          </a:prstGeom>
-          <a:noFill/>
-          <a:ln w="31750">
-            <a:solidFill>
-              <a:srgbClr val="C81E43"/>
-            </a:solidFill>
-            <a:prstDash val="solid"/>
-            <a:tailEnd type="triangle"/>
-          </a:ln>
-        </p:spPr>
-      </p:sp>
-      <p:sp>
-        <p:nvSpPr>
-          <p:cNvPr id="24" name="Shape 22"/>
-          <p:cNvSpPr/>
-          <p:nvPr/>
-        </p:nvSpPr>
-        <p:spPr>
-          <a:xfrm>
-            <a:off x="4846320" y="2926080"/>
-            <a:ext cx="1737360" cy="868680"/>
-          </a:xfrm>
-          <a:prstGeom prst="roundRect">
-            <a:avLst>
-              <a:gd name="adj" fmla="val 10526"/>
-            </a:avLst>
-          </a:prstGeom>
-          <a:solidFill>
-            <a:srgbClr val="ECEFF9"/>
-          </a:solidFill>
-          <a:ln w="19050">
-            <a:solidFill>
-              <a:srgbClr val="2EC4B6"/>
-            </a:solidFill>
-            <a:prstDash val="solid"/>
-          </a:ln>
-        </p:spPr>
-      </p:sp>
-      <p:sp>
-        <p:nvSpPr>
-          <p:cNvPr id="25" name="Text 23"/>
-          <p:cNvSpPr txBox="1"/>
-          <p:nvPr/>
-        </p:nvSpPr>
-        <p:spPr>
-          <a:xfrm>
-            <a:off x="4956048" y="2926080"/>
-            <a:ext cx="1554480" cy="868680"/>
-          </a:xfrm>
-          <a:prstGeom prst="rect">
-            <a:avLst/>
-          </a:prstGeom>
-          <a:noFill/>
-          <a:ln/>
-        </p:spPr>
-        <p:txBody>
-          <a:bodyPr wrap="square" lIns="0" tIns="0" rIns="0" bIns="0" rtlCol="0" anchor="ctr"/>
-          <a:lstStyle/>
-          <a:p>
-            <a:pPr indent="0" marL="0">
-              <a:buNone/>
-            </a:pPr>
-            <a:r>
-              <a:rPr lang="en-US" sz="1100" dirty="0">
-                <a:solidFill>
-                  <a:srgbClr val="15193A"/>
-                </a:solidFill>
-                <a:latin typeface="Calibri" pitchFamily="34" charset="0"/>
-                <a:ea typeface="Calibri" pitchFamily="34" charset="-122"/>
-                <a:cs typeface="Calibri" pitchFamily="34" charset="-120"/>
-              </a:rPr>
-              <a:t>Hemólisis + grupo de Lancefield</a:t>
-            </a:r>
-            <a:endParaRPr lang="en-US" sz="1100" dirty="0"/>
-          </a:p>
-          <a:p>
-            <a:pPr indent="0" marL="0">
-              <a:buNone/>
-            </a:pPr>
-            <a:r>
-              <a:rPr lang="en-US" sz="1100" dirty="0">
-                <a:solidFill>
-                  <a:srgbClr val="15193A"/>
-                </a:solidFill>
-                <a:latin typeface="Calibri" pitchFamily="34" charset="0"/>
-                <a:ea typeface="Calibri" pitchFamily="34" charset="-122"/>
-                <a:cs typeface="Calibri" pitchFamily="34" charset="-120"/>
-              </a:rPr>
-              <a:t>Streptococcus</a:t>
-            </a:r>
-            <a:endParaRPr lang="en-US" sz="1100" dirty="0"/>
-          </a:p>
-        </p:txBody>
-      </p:sp>
-      <p:sp>
-        <p:nvSpPr>
-          <p:cNvPr id="26" name="Shape 24"/>
-          <p:cNvSpPr/>
-          <p:nvPr/>
-        </p:nvSpPr>
-        <p:spPr>
-          <a:xfrm>
-            <a:off x="6766560" y="2926080"/>
-            <a:ext cx="1920240" cy="868680"/>
-          </a:xfrm>
-          <a:prstGeom prst="roundRect">
-            <a:avLst>
-              <a:gd name="adj" fmla="val 10526"/>
-            </a:avLst>
-          </a:prstGeom>
-          <a:solidFill>
-            <a:srgbClr val="ECEFF9"/>
-          </a:solidFill>
-          <a:ln w="19050">
-            <a:solidFill>
-              <a:srgbClr val="F2546B"/>
-            </a:solidFill>
-            <a:prstDash val="solid"/>
-          </a:ln>
-        </p:spPr>
-      </p:sp>
-      <p:sp>
-        <p:nvSpPr>
-          <p:cNvPr id="27" name="Text 25"/>
-          <p:cNvSpPr txBox="1"/>
-          <p:nvPr/>
-        </p:nvSpPr>
-        <p:spPr>
-          <a:xfrm>
-            <a:off x="6876288" y="2926080"/>
-            <a:ext cx="1737360" cy="868680"/>
-          </a:xfrm>
-          <a:prstGeom prst="rect">
-            <a:avLst/>
-          </a:prstGeom>
-          <a:noFill/>
-          <a:ln/>
-        </p:spPr>
-        <p:txBody>
-          <a:bodyPr wrap="square" lIns="0" tIns="0" rIns="0" bIns="0" rtlCol="0" anchor="ctr"/>
-          <a:lstStyle/>
-          <a:p>
-            <a:pPr indent="0" marL="0">
-              <a:buNone/>
-            </a:pPr>
-            <a:r>
-              <a:rPr lang="en-US" sz="1100" dirty="0">
-                <a:solidFill>
-                  <a:srgbClr val="15193A"/>
-                </a:solidFill>
-                <a:latin typeface="Calibri" pitchFamily="34" charset="0"/>
-                <a:ea typeface="Calibri" pitchFamily="34" charset="-122"/>
-                <a:cs typeface="Calibri" pitchFamily="34" charset="-120"/>
-              </a:rPr>
-              <a:t>PYR +, bilis-esculina, 6,5% NaCl</a:t>
-            </a:r>
-            <a:endParaRPr lang="en-US" sz="1100" dirty="0"/>
-          </a:p>
-          <a:p>
-            <a:pPr indent="0" marL="0">
-              <a:buNone/>
-            </a:pPr>
-            <a:r>
-              <a:rPr lang="en-US" sz="1100" dirty="0">
-                <a:solidFill>
-                  <a:srgbClr val="15193A"/>
-                </a:solidFill>
-                <a:latin typeface="Calibri" pitchFamily="34" charset="0"/>
-                <a:ea typeface="Calibri" pitchFamily="34" charset="-122"/>
-                <a:cs typeface="Calibri" pitchFamily="34" charset="-120"/>
-              </a:rPr>
-              <a:t>Enterococcus</a:t>
-            </a:r>
-            <a:endParaRPr lang="en-US" sz="1100" dirty="0"/>
-          </a:p>
-        </p:txBody>
-      </p:sp>
-      <p:sp>
-        <p:nvSpPr>
-          <p:cNvPr id="28" name="Shape 26"/>
-          <p:cNvSpPr/>
-          <p:nvPr/>
-        </p:nvSpPr>
-        <p:spPr>
-          <a:xfrm>
-            <a:off x="457200" y="3977640"/>
-            <a:ext cx="8229600" cy="457200"/>
-          </a:xfrm>
-          <a:prstGeom prst="roundRect">
-            <a:avLst>
-              <a:gd name="adj" fmla="val 20000"/>
-            </a:avLst>
-          </a:prstGeom>
-          <a:solidFill>
-            <a:srgbClr val="4CC9F0">
-              <a:alpha val="10000"/>
-            </a:srgbClr>
-          </a:solidFill>
-          <a:ln w="19050">
-            <a:solidFill>
-              <a:srgbClr val="4CC9F0"/>
-            </a:solidFill>
-            <a:prstDash val="solid"/>
-          </a:ln>
-        </p:spPr>
-      </p:sp>
-      <p:sp>
-        <p:nvSpPr>
-          <p:cNvPr id="29" name="Text 27"/>
-          <p:cNvSpPr txBox="1"/>
-          <p:nvPr/>
-        </p:nvSpPr>
-        <p:spPr>
-          <a:xfrm>
-            <a:off x="512064" y="3977640"/>
-            <a:ext cx="8119872" cy="457200"/>
-          </a:xfrm>
-          <a:prstGeom prst="rect">
-            <a:avLst/>
-          </a:prstGeom>
-          <a:noFill/>
-          <a:ln/>
-        </p:spPr>
-        <p:txBody>
-          <a:bodyPr wrap="square" lIns="0" tIns="0" rIns="0" bIns="0" rtlCol="0" anchor="ctr"/>
-          <a:lstStyle/>
-          <a:p>
-            <a:pPr algn="ctr" indent="0" marL="0">
-              <a:buNone/>
-            </a:pPr>
-            <a:r>
-              <a:rPr lang="en-US" sz="1400" b="1" dirty="0">
-                <a:solidFill>
-                  <a:srgbClr val="15193A"/>
-                </a:solidFill>
-                <a:latin typeface="Calibri" pitchFamily="34" charset="0"/>
-                <a:ea typeface="Calibri" pitchFamily="34" charset="-122"/>
-                <a:cs typeface="Calibri" pitchFamily="34" charset="-120"/>
-              </a:rPr>
-              <a:t>Pruebas clave: catalasa, coagulasa, hemólisis, antígeno de Lancefield, PYR y bilis-esculina</a:t>
-            </a:r>
-            <a:endParaRPr lang="en-US" sz="1400" dirty="0"/>
+              <a:t>Conclusión</a:t>
+            </a:r>
+            <a:endParaRPr lang="en-US" sz="1500" dirty="0"/>
           </a:p>
         </p:txBody>
       </p:sp>
@@ -2721,6 +2535,947 @@
             <a:fld id="{F7021451-1387-4CA6-816F-3879F97B5CBC}" type="slidenum">
               <a:rPr b="0" lang="en-US"/>
               <a:t>2</a:t>
+            </a:fld>
+            <a:endParaRPr lang="en-US"/>
+          </a:p>
+        </p:txBody>
+      </p:sp>
+    </p:spTree>
+  </p:cSld>
+  <p:clrMapOvr>
+    <a:masterClrMapping/>
+  </p:clrMapOvr>
+</p:sld>
+</file>
+
+<file path=ppt/slides/slide3.xml><?xml version="1.0" encoding="utf-8"?>
+<p:sld xmlns:a="http://schemas.openxmlformats.org/drawingml/2006/main" xmlns:r="http://schemas.openxmlformats.org/officeDocument/2006/relationships" xmlns:p="http://schemas.openxmlformats.org/presentationml/2006/main">
+  <p:cSld name="Slide 3">
+    <p:bg>
+      <p:bgPr>
+        <a:solidFill>
+          <a:srgbClr val="FFFFFF"/>
+        </a:solidFill>
+      </p:bgPr>
+    </p:bg>
+    <p:spTree>
+      <p:nvGrpSpPr>
+        <p:cNvPr id="1" name=""/>
+        <p:cNvGrpSpPr/>
+        <p:nvPr/>
+      </p:nvGrpSpPr>
+      <p:grpSpPr>
+        <a:xfrm>
+          <a:off x="0" y="0"/>
+          <a:ext cx="0" cy="0"/>
+          <a:chOff x="0" y="0"/>
+          <a:chExt cx="0" cy="0"/>
+        </a:xfrm>
+      </p:grpSpPr>
+      <p:sp>
+        <p:nvSpPr>
+          <p:cNvPr id="2" name="Shape 0"/>
+          <p:cNvSpPr/>
+          <p:nvPr/>
+        </p:nvSpPr>
+        <p:spPr>
+          <a:xfrm>
+            <a:off x="548640" y="1828800"/>
+            <a:ext cx="109728" cy="1280160"/>
+          </a:xfrm>
+          <a:prstGeom prst="rect">
+            <a:avLst/>
+          </a:prstGeom>
+          <a:solidFill>
+            <a:srgbClr val="A78BFA"/>
+          </a:solidFill>
+          <a:ln w="12700">
+            <a:solidFill>
+              <a:srgbClr val="A78BFA"/>
+            </a:solidFill>
+            <a:prstDash val="solid"/>
+          </a:ln>
+        </p:spPr>
+      </p:sp>
+      <p:sp>
+        <p:nvSpPr>
+          <p:cNvPr id="3" name="Text 1"/>
+          <p:cNvSpPr txBox="1"/>
+          <p:nvPr/>
+        </p:nvSpPr>
+        <p:spPr>
+          <a:xfrm>
+            <a:off x="868680" y="1280160"/>
+            <a:ext cx="3657600" cy="914400"/>
+          </a:xfrm>
+          <a:prstGeom prst="rect">
+            <a:avLst/>
+          </a:prstGeom>
+          <a:noFill/>
+          <a:ln/>
+        </p:spPr>
+        <p:txBody>
+          <a:bodyPr wrap="square" lIns="0" tIns="0" rIns="0" bIns="0" rtlCol="0" anchor="b"/>
+          <a:lstStyle/>
+          <a:p>
+            <a:pPr indent="0" marL="0">
+              <a:buNone/>
+            </a:pPr>
+            <a:r>
+              <a:rPr lang="en-US" sz="5600" b="1" dirty="0">
+                <a:solidFill>
+                  <a:srgbClr val="6A4CCF"/>
+                </a:solidFill>
+                <a:latin typeface="Calibri" pitchFamily="34" charset="0"/>
+                <a:ea typeface="Calibri" pitchFamily="34" charset="-122"/>
+                <a:cs typeface="Calibri" pitchFamily="34" charset="-120"/>
+              </a:rPr>
+              <a:t>01</a:t>
+            </a:r>
+            <a:endParaRPr lang="en-US" sz="5600" dirty="0"/>
+          </a:p>
+        </p:txBody>
+      </p:sp>
+      <p:sp>
+        <p:nvSpPr>
+          <p:cNvPr id="4" name="Text 2"/>
+          <p:cNvSpPr txBox="1"/>
+          <p:nvPr/>
+        </p:nvSpPr>
+        <p:spPr>
+          <a:xfrm>
+            <a:off x="868680" y="2194560"/>
+            <a:ext cx="7498080" cy="914400"/>
+          </a:xfrm>
+          <a:prstGeom prst="rect">
+            <a:avLst/>
+          </a:prstGeom>
+          <a:noFill/>
+          <a:ln/>
+        </p:spPr>
+        <p:txBody>
+          <a:bodyPr wrap="square" lIns="0" tIns="0" rIns="0" bIns="0" rtlCol="0" anchor="ctr"/>
+          <a:lstStyle/>
+          <a:p>
+            <a:pPr indent="0" marL="0">
+              <a:buNone/>
+            </a:pPr>
+            <a:r>
+              <a:rPr lang="en-US" sz="4800" b="1" dirty="0">
+                <a:solidFill>
+                  <a:srgbClr val="15193A"/>
+                </a:solidFill>
+                <a:latin typeface="Calibri" pitchFamily="34" charset="0"/>
+                <a:ea typeface="Calibri" pitchFamily="34" charset="-122"/>
+                <a:cs typeface="Calibri" pitchFamily="34" charset="-120"/>
+              </a:rPr>
+              <a:t>Objetivo</a:t>
+            </a:r>
+            <a:endParaRPr lang="en-US" sz="4800" dirty="0"/>
+          </a:p>
+        </p:txBody>
+      </p:sp>
+      <p:sp>
+        <p:nvSpPr>
+          <p:cNvPr id="5" name="Text 3"/>
+          <p:cNvSpPr txBox="1"/>
+          <p:nvPr/>
+        </p:nvSpPr>
+        <p:spPr>
+          <a:xfrm>
+            <a:off x="886968" y="3200400"/>
+            <a:ext cx="6858000" cy="640080"/>
+          </a:xfrm>
+          <a:prstGeom prst="rect">
+            <a:avLst/>
+          </a:prstGeom>
+          <a:noFill/>
+          <a:ln/>
+        </p:spPr>
+        <p:txBody>
+          <a:bodyPr wrap="square" lIns="0" tIns="0" rIns="0" bIns="0" rtlCol="0" anchor="t"/>
+          <a:lstStyle/>
+          <a:p>
+            <a:pPr indent="0" marL="0">
+              <a:buNone/>
+            </a:pPr>
+            <a:r>
+              <a:rPr lang="en-US" sz="2000" dirty="0">
+                <a:solidFill>
+                  <a:srgbClr val="51597F"/>
+                </a:solidFill>
+                <a:latin typeface="Calibri" pitchFamily="34" charset="0"/>
+                <a:ea typeface="Calibri" pitchFamily="34" charset="-122"/>
+                <a:cs typeface="Calibri" pitchFamily="34" charset="-120"/>
+              </a:rPr>
+              <a:t>Qué queremos comprender</a:t>
+            </a:r>
+            <a:endParaRPr lang="en-US" sz="2000" dirty="0"/>
+          </a:p>
+        </p:txBody>
+      </p:sp>
+    </p:spTree>
+  </p:cSld>
+  <p:clrMapOvr>
+    <a:masterClrMapping/>
+  </p:clrMapOvr>
+</p:sld>
+</file>
+
+<file path=ppt/slides/slide4.xml><?xml version="1.0" encoding="utf-8"?>
+<p:sld xmlns:a="http://schemas.openxmlformats.org/drawingml/2006/main" xmlns:r="http://schemas.openxmlformats.org/officeDocument/2006/relationships" xmlns:p="http://schemas.openxmlformats.org/presentationml/2006/main">
+  <p:cSld name="Slide 4">
+    <p:bg>
+      <p:bgPr>
+        <a:solidFill>
+          <a:srgbClr val="FFFFFF"/>
+        </a:solidFill>
+      </p:bgPr>
+    </p:bg>
+    <p:spTree>
+      <p:nvGrpSpPr>
+        <p:cNvPr id="1" name=""/>
+        <p:cNvGrpSpPr/>
+        <p:nvPr/>
+      </p:nvGrpSpPr>
+      <p:grpSpPr>
+        <a:xfrm>
+          <a:off x="0" y="0"/>
+          <a:ext cx="0" cy="0"/>
+          <a:chOff x="0" y="0"/>
+          <a:chExt cx="0" cy="0"/>
+        </a:xfrm>
+      </p:grpSpPr>
+      <p:sp>
+        <p:nvSpPr>
+          <p:cNvPr id="2" name="Text 0"/>
+          <p:cNvSpPr txBox="1"/>
+          <p:nvPr/>
+        </p:nvSpPr>
+        <p:spPr>
+          <a:xfrm>
+            <a:off x="457200" y="201168"/>
+            <a:ext cx="7863840" cy="274320"/>
+          </a:xfrm>
+          <a:prstGeom prst="rect">
+            <a:avLst/>
+          </a:prstGeom>
+          <a:noFill/>
+          <a:ln/>
+        </p:spPr>
+        <p:txBody>
+          <a:bodyPr wrap="square" lIns="0" tIns="0" rIns="0" bIns="0" rtlCol="0" anchor="ctr"/>
+          <a:lstStyle/>
+          <a:p>
+            <a:pPr indent="0" marL="0">
+              <a:buNone/>
+            </a:pPr>
+            <a:r>
+              <a:rPr lang="en-US" sz="1300" b="1" spc="300" kern="0" dirty="0">
+                <a:solidFill>
+                  <a:srgbClr val="6A4CCF"/>
+                </a:solidFill>
+                <a:latin typeface="Calibri" pitchFamily="34" charset="0"/>
+                <a:ea typeface="Calibri" pitchFamily="34" charset="-122"/>
+                <a:cs typeface="Calibri" pitchFamily="34" charset="-120"/>
+              </a:rPr>
+              <a:t>01 - OBJETIVO</a:t>
+            </a:r>
+            <a:endParaRPr lang="en-US" sz="1300" dirty="0"/>
+          </a:p>
+        </p:txBody>
+      </p:sp>
+      <p:sp>
+        <p:nvSpPr>
+          <p:cNvPr id="3" name="Text 1"/>
+          <p:cNvSpPr txBox="1"/>
+          <p:nvPr/>
+        </p:nvSpPr>
+        <p:spPr>
+          <a:xfrm>
+            <a:off x="457200" y="457200"/>
+            <a:ext cx="8229600" cy="658368"/>
+          </a:xfrm>
+          <a:prstGeom prst="rect">
+            <a:avLst/>
+          </a:prstGeom>
+          <a:noFill/>
+          <a:ln/>
+        </p:spPr>
+        <p:txBody>
+          <a:bodyPr wrap="square" lIns="0" tIns="0" rIns="0" bIns="0" rtlCol="0" anchor="ctr"/>
+          <a:lstStyle/>
+          <a:p>
+            <a:pPr indent="0" marL="0">
+              <a:buNone/>
+            </a:pPr>
+            <a:r>
+              <a:rPr lang="en-US" sz="3000" b="1" dirty="0">
+                <a:solidFill>
+                  <a:srgbClr val="15193A"/>
+                </a:solidFill>
+                <a:latin typeface="Calibri" pitchFamily="34" charset="0"/>
+                <a:ea typeface="Calibri" pitchFamily="34" charset="-122"/>
+                <a:cs typeface="Calibri" pitchFamily="34" charset="-120"/>
+              </a:rPr>
+              <a:t>Objetivo general</a:t>
+            </a:r>
+            <a:endParaRPr lang="en-US" sz="3000" dirty="0"/>
+          </a:p>
+        </p:txBody>
+      </p:sp>
+      <p:sp>
+        <p:nvSpPr>
+          <p:cNvPr id="4" name="Shape 2"/>
+          <p:cNvSpPr/>
+          <p:nvPr/>
+        </p:nvSpPr>
+        <p:spPr>
+          <a:xfrm>
+            <a:off x="457200" y="4507992"/>
+            <a:ext cx="8229600" cy="0"/>
+          </a:xfrm>
+          <a:prstGeom prst="line">
+            <a:avLst/>
+          </a:prstGeom>
+          <a:noFill/>
+          <a:ln w="9525">
+            <a:solidFill>
+              <a:srgbClr val="D7DCEF"/>
+            </a:solidFill>
+            <a:prstDash val="solid"/>
+          </a:ln>
+        </p:spPr>
+      </p:sp>
+      <p:sp>
+        <p:nvSpPr>
+          <p:cNvPr id="5" name="Text 3"/>
+          <p:cNvSpPr txBox="1"/>
+          <p:nvPr/>
+        </p:nvSpPr>
+        <p:spPr>
+          <a:xfrm>
+            <a:off x="457200" y="4553712"/>
+            <a:ext cx="7818120" cy="502920"/>
+          </a:xfrm>
+          <a:prstGeom prst="rect">
+            <a:avLst/>
+          </a:prstGeom>
+          <a:noFill/>
+          <a:ln/>
+        </p:spPr>
+        <p:txBody>
+          <a:bodyPr wrap="square" lIns="0" tIns="0" rIns="0" bIns="0" rtlCol="0" anchor="ctr"/>
+          <a:lstStyle/>
+          <a:p>
+            <a:pPr indent="0" marL="0">
+              <a:buNone/>
+            </a:pPr>
+            <a:r>
+              <a:rPr lang="en-US" sz="900" dirty="0">
+                <a:solidFill>
+                  <a:srgbClr val="51597F"/>
+                </a:solidFill>
+                <a:latin typeface="Calibri" pitchFamily="34" charset="0"/>
+                <a:ea typeface="Calibri" pitchFamily="34" charset="-122"/>
+                <a:cs typeface="Calibri" pitchFamily="34" charset="-120"/>
+              </a:rPr>
+              <a:t>3. Howden BP, Giulieri SG, Wong Fok Lung T, Baines SL, Sharkey LK, Lee JYH, et al. Staphylococcus aureus host interactions and adaptation. Nat Rev Microbiol. 2023;21(6):380-95.</a:t>
+            </a:r>
+            <a:endParaRPr lang="en-US" sz="900" dirty="0"/>
+          </a:p>
+          <a:p>
+            <a:pPr indent="0" marL="0">
+              <a:buNone/>
+            </a:pPr>
+            <a:r>
+              <a:rPr lang="en-US" sz="900" dirty="0">
+                <a:solidFill>
+                  <a:srgbClr val="51597F"/>
+                </a:solidFill>
+                <a:latin typeface="Calibri" pitchFamily="34" charset="0"/>
+                <a:ea typeface="Calibri" pitchFamily="34" charset="-122"/>
+                <a:cs typeface="Calibri" pitchFamily="34" charset="-120"/>
+              </a:rPr>
+              <a:t>2. Brouwer S, Rivera-Hernandez T, Curren BF, Harbison-Price N, De Oliveira DMP, Jespersen MG, et al. Pathogenesis, epidemiology and control of Group A Streptococcus infection. Nat Rev Microbiol. 2023;21(7):431-47.</a:t>
+            </a:r>
+            <a:endParaRPr lang="en-US" sz="900" dirty="0"/>
+          </a:p>
+        </p:txBody>
+      </p:sp>
+      <p:sp>
+        <p:nvSpPr>
+          <p:cNvPr id="6" name="Shape 4"/>
+          <p:cNvSpPr/>
+          <p:nvPr/>
+        </p:nvSpPr>
+        <p:spPr>
+          <a:xfrm>
+            <a:off x="457200" y="1280160"/>
+            <a:ext cx="8229600" cy="1371600"/>
+          </a:xfrm>
+          <a:prstGeom prst="roundRect">
+            <a:avLst>
+              <a:gd name="adj" fmla="val 6667"/>
+            </a:avLst>
+          </a:prstGeom>
+          <a:solidFill>
+            <a:srgbClr val="A78BFA">
+              <a:alpha val="10000"/>
+            </a:srgbClr>
+          </a:solidFill>
+          <a:ln w="19050">
+            <a:solidFill>
+              <a:srgbClr val="A78BFA"/>
+            </a:solidFill>
+            <a:prstDash val="solid"/>
+          </a:ln>
+        </p:spPr>
+      </p:sp>
+      <p:sp>
+        <p:nvSpPr>
+          <p:cNvPr id="7" name="Text 5"/>
+          <p:cNvSpPr txBox="1"/>
+          <p:nvPr/>
+        </p:nvSpPr>
+        <p:spPr>
+          <a:xfrm>
+            <a:off x="822960" y="1371600"/>
+            <a:ext cx="7498080" cy="1188720"/>
+          </a:xfrm>
+          <a:prstGeom prst="rect">
+            <a:avLst/>
+          </a:prstGeom>
+          <a:noFill/>
+          <a:ln/>
+        </p:spPr>
+        <p:txBody>
+          <a:bodyPr wrap="square" lIns="0" tIns="0" rIns="0" bIns="0" rtlCol="0" anchor="ctr"/>
+          <a:lstStyle/>
+          <a:p>
+            <a:pPr indent="0" marL="0">
+              <a:buNone/>
+            </a:pPr>
+            <a:r>
+              <a:rPr lang="en-US" sz="2100" dirty="0">
+                <a:solidFill>
+                  <a:srgbClr val="15193A"/>
+                </a:solidFill>
+                <a:latin typeface="Calibri" pitchFamily="34" charset="0"/>
+                <a:ea typeface="Calibri" pitchFamily="34" charset="-122"/>
+                <a:cs typeface="Calibri" pitchFamily="34" charset="-120"/>
+              </a:rPr>
+              <a:t>Comprender los mecanismos fisiopatológicos de las infecciones por bacterias grampositivas, enfatizando la virulencia, la evasión inmunitaria y el daño tisular.</a:t>
+            </a:r>
+            <a:endParaRPr lang="en-US" sz="2100" dirty="0"/>
+          </a:p>
+        </p:txBody>
+      </p:sp>
+      <p:sp>
+        <p:nvSpPr>
+          <p:cNvPr id="8" name="Shape 6"/>
+          <p:cNvSpPr/>
+          <p:nvPr/>
+        </p:nvSpPr>
+        <p:spPr>
+          <a:xfrm>
+            <a:off x="457200" y="2880360"/>
+            <a:ext cx="2624328" cy="1417320"/>
+          </a:xfrm>
+          <a:prstGeom prst="roundRect">
+            <a:avLst>
+              <a:gd name="adj" fmla="val 6452"/>
+            </a:avLst>
+          </a:prstGeom>
+          <a:solidFill>
+            <a:srgbClr val="F4F6FD"/>
+          </a:solidFill>
+          <a:ln w="19050">
+            <a:solidFill>
+              <a:srgbClr val="F2B43C"/>
+            </a:solidFill>
+            <a:prstDash val="solid"/>
+          </a:ln>
+        </p:spPr>
+      </p:sp>
+      <p:sp>
+        <p:nvSpPr>
+          <p:cNvPr id="9" name="Shape 7"/>
+          <p:cNvSpPr/>
+          <p:nvPr/>
+        </p:nvSpPr>
+        <p:spPr>
+          <a:xfrm>
+            <a:off x="1408176" y="3017520"/>
+            <a:ext cx="731520" cy="731520"/>
+          </a:xfrm>
+          <a:prstGeom prst="ellipse">
+            <a:avLst/>
+          </a:prstGeom>
+          <a:solidFill>
+            <a:srgbClr val="F2B43C"/>
+          </a:solidFill>
+          <a:ln w="12700">
+            <a:solidFill>
+              <a:srgbClr val="F2B43C"/>
+            </a:solidFill>
+            <a:prstDash val="solid"/>
+          </a:ln>
+        </p:spPr>
+      </p:sp>
+      <p:pic>
+        <p:nvPicPr>
+          <p:cNvPr id="10" name="Image 0" descr="preencoded.png">    </p:cNvPr>
+          <p:cNvPicPr>
+            <a:picLocks noChangeAspect="1"/>
+          </p:cNvPicPr>
+          <p:nvPr/>
+        </p:nvPicPr>
+        <p:blipFill>
+          <a:blip r:embed="rId1"/>
+          <a:stretch>
+            <a:fillRect/>
+          </a:stretch>
+        </p:blipFill>
+        <p:spPr>
+          <a:xfrm>
+            <a:off x="1583741" y="3193085"/>
+            <a:ext cx="380390" cy="380390"/>
+          </a:xfrm>
+          <a:prstGeom prst="rect">
+            <a:avLst/>
+          </a:prstGeom>
+        </p:spPr>
+      </p:pic>
+      <p:sp>
+        <p:nvSpPr>
+          <p:cNvPr id="11" name="Text 8"/>
+          <p:cNvSpPr txBox="1"/>
+          <p:nvPr/>
+        </p:nvSpPr>
+        <p:spPr>
+          <a:xfrm>
+            <a:off x="457200" y="3840480"/>
+            <a:ext cx="2624328" cy="365760"/>
+          </a:xfrm>
+          <a:prstGeom prst="rect">
+            <a:avLst/>
+          </a:prstGeom>
+          <a:noFill/>
+          <a:ln/>
+        </p:spPr>
+        <p:txBody>
+          <a:bodyPr wrap="square" lIns="0" tIns="0" rIns="0" bIns="0" rtlCol="0" anchor="t"/>
+          <a:lstStyle/>
+          <a:p>
+            <a:pPr algn="ctr" indent="0" marL="0">
+              <a:buNone/>
+            </a:pPr>
+            <a:r>
+              <a:rPr lang="en-US" sz="1700" b="1" dirty="0">
+                <a:solidFill>
+                  <a:srgbClr val="A66A00"/>
+                </a:solidFill>
+                <a:latin typeface="Calibri" pitchFamily="34" charset="0"/>
+                <a:ea typeface="Calibri" pitchFamily="34" charset="-122"/>
+                <a:cs typeface="Calibri" pitchFamily="34" charset="-120"/>
+              </a:rPr>
+              <a:t>Virulencia</a:t>
+            </a:r>
+            <a:endParaRPr lang="en-US" sz="1700" dirty="0"/>
+          </a:p>
+        </p:txBody>
+      </p:sp>
+      <p:sp>
+        <p:nvSpPr>
+          <p:cNvPr id="12" name="Text 9"/>
+          <p:cNvSpPr txBox="1"/>
+          <p:nvPr/>
+        </p:nvSpPr>
+        <p:spPr>
+          <a:xfrm>
+            <a:off x="457200" y="4187952"/>
+            <a:ext cx="2624328" cy="274320"/>
+          </a:xfrm>
+          <a:prstGeom prst="rect">
+            <a:avLst/>
+          </a:prstGeom>
+          <a:noFill/>
+          <a:ln/>
+        </p:spPr>
+        <p:txBody>
+          <a:bodyPr wrap="square" lIns="0" tIns="0" rIns="0" bIns="0" rtlCol="0" anchor="t"/>
+          <a:lstStyle/>
+          <a:p>
+            <a:pPr algn="ctr" indent="0" marL="0">
+              <a:buNone/>
+            </a:pPr>
+            <a:r>
+              <a:rPr lang="en-US" sz="1300" dirty="0">
+                <a:solidFill>
+                  <a:srgbClr val="51597F"/>
+                </a:solidFill>
+                <a:latin typeface="Calibri" pitchFamily="34" charset="0"/>
+                <a:ea typeface="Calibri" pitchFamily="34" charset="-122"/>
+                <a:cs typeface="Calibri" pitchFamily="34" charset="-120"/>
+              </a:rPr>
+              <a:t>Cómo ataca</a:t>
+            </a:r>
+            <a:endParaRPr lang="en-US" sz="1300" dirty="0"/>
+          </a:p>
+        </p:txBody>
+      </p:sp>
+      <p:sp>
+        <p:nvSpPr>
+          <p:cNvPr id="13" name="Shape 10"/>
+          <p:cNvSpPr/>
+          <p:nvPr/>
+        </p:nvSpPr>
+        <p:spPr>
+          <a:xfrm>
+            <a:off x="3264408" y="2880360"/>
+            <a:ext cx="2624328" cy="1417320"/>
+          </a:xfrm>
+          <a:prstGeom prst="roundRect">
+            <a:avLst>
+              <a:gd name="adj" fmla="val 6452"/>
+            </a:avLst>
+          </a:prstGeom>
+          <a:solidFill>
+            <a:srgbClr val="F4F6FD"/>
+          </a:solidFill>
+          <a:ln w="19050">
+            <a:solidFill>
+              <a:srgbClr val="2EC4B6"/>
+            </a:solidFill>
+            <a:prstDash val="solid"/>
+          </a:ln>
+        </p:spPr>
+      </p:sp>
+      <p:sp>
+        <p:nvSpPr>
+          <p:cNvPr id="14" name="Shape 11"/>
+          <p:cNvSpPr/>
+          <p:nvPr/>
+        </p:nvSpPr>
+        <p:spPr>
+          <a:xfrm>
+            <a:off x="4215384" y="3017520"/>
+            <a:ext cx="731520" cy="731520"/>
+          </a:xfrm>
+          <a:prstGeom prst="ellipse">
+            <a:avLst/>
+          </a:prstGeom>
+          <a:solidFill>
+            <a:srgbClr val="2EC4B6"/>
+          </a:solidFill>
+          <a:ln w="12700">
+            <a:solidFill>
+              <a:srgbClr val="2EC4B6"/>
+            </a:solidFill>
+            <a:prstDash val="solid"/>
+          </a:ln>
+        </p:spPr>
+      </p:sp>
+      <p:pic>
+        <p:nvPicPr>
+          <p:cNvPr id="15" name="Image 1" descr="preencoded.png">    </p:cNvPr>
+          <p:cNvPicPr>
+            <a:picLocks noChangeAspect="1"/>
+          </p:cNvPicPr>
+          <p:nvPr/>
+        </p:nvPicPr>
+        <p:blipFill>
+          <a:blip r:embed="rId2"/>
+          <a:stretch>
+            <a:fillRect/>
+          </a:stretch>
+        </p:blipFill>
+        <p:spPr>
+          <a:xfrm>
+            <a:off x="4390949" y="3193085"/>
+            <a:ext cx="380390" cy="380390"/>
+          </a:xfrm>
+          <a:prstGeom prst="rect">
+            <a:avLst/>
+          </a:prstGeom>
+        </p:spPr>
+      </p:pic>
+      <p:sp>
+        <p:nvSpPr>
+          <p:cNvPr id="16" name="Text 12"/>
+          <p:cNvSpPr txBox="1"/>
+          <p:nvPr/>
+        </p:nvSpPr>
+        <p:spPr>
+          <a:xfrm>
+            <a:off x="3264408" y="3840480"/>
+            <a:ext cx="2624328" cy="365760"/>
+          </a:xfrm>
+          <a:prstGeom prst="rect">
+            <a:avLst/>
+          </a:prstGeom>
+          <a:noFill/>
+          <a:ln/>
+        </p:spPr>
+        <p:txBody>
+          <a:bodyPr wrap="square" lIns="0" tIns="0" rIns="0" bIns="0" rtlCol="0" anchor="t"/>
+          <a:lstStyle/>
+          <a:p>
+            <a:pPr algn="ctr" indent="0" marL="0">
+              <a:buNone/>
+            </a:pPr>
+            <a:r>
+              <a:rPr lang="en-US" sz="1700" b="1" dirty="0">
+                <a:solidFill>
+                  <a:srgbClr val="0C8368"/>
+                </a:solidFill>
+                <a:latin typeface="Calibri" pitchFamily="34" charset="0"/>
+                <a:ea typeface="Calibri" pitchFamily="34" charset="-122"/>
+                <a:cs typeface="Calibri" pitchFamily="34" charset="-120"/>
+              </a:rPr>
+              <a:t>Evasión inmunitaria</a:t>
+            </a:r>
+            <a:endParaRPr lang="en-US" sz="1700" dirty="0"/>
+          </a:p>
+        </p:txBody>
+      </p:sp>
+      <p:sp>
+        <p:nvSpPr>
+          <p:cNvPr id="17" name="Text 13"/>
+          <p:cNvSpPr txBox="1"/>
+          <p:nvPr/>
+        </p:nvSpPr>
+        <p:spPr>
+          <a:xfrm>
+            <a:off x="3264408" y="4187952"/>
+            <a:ext cx="2624328" cy="274320"/>
+          </a:xfrm>
+          <a:prstGeom prst="rect">
+            <a:avLst/>
+          </a:prstGeom>
+          <a:noFill/>
+          <a:ln/>
+        </p:spPr>
+        <p:txBody>
+          <a:bodyPr wrap="square" lIns="0" tIns="0" rIns="0" bIns="0" rtlCol="0" anchor="t"/>
+          <a:lstStyle/>
+          <a:p>
+            <a:pPr algn="ctr" indent="0" marL="0">
+              <a:buNone/>
+            </a:pPr>
+            <a:r>
+              <a:rPr lang="en-US" sz="1300" dirty="0">
+                <a:solidFill>
+                  <a:srgbClr val="51597F"/>
+                </a:solidFill>
+                <a:latin typeface="Calibri" pitchFamily="34" charset="0"/>
+                <a:ea typeface="Calibri" pitchFamily="34" charset="-122"/>
+                <a:cs typeface="Calibri" pitchFamily="34" charset="-120"/>
+              </a:rPr>
+              <a:t>Cómo escapa</a:t>
+            </a:r>
+            <a:endParaRPr lang="en-US" sz="1300" dirty="0"/>
+          </a:p>
+        </p:txBody>
+      </p:sp>
+      <p:sp>
+        <p:nvSpPr>
+          <p:cNvPr id="18" name="Shape 14"/>
+          <p:cNvSpPr/>
+          <p:nvPr/>
+        </p:nvSpPr>
+        <p:spPr>
+          <a:xfrm>
+            <a:off x="6071616" y="2880360"/>
+            <a:ext cx="2624328" cy="1417320"/>
+          </a:xfrm>
+          <a:prstGeom prst="roundRect">
+            <a:avLst>
+              <a:gd name="adj" fmla="val 6452"/>
+            </a:avLst>
+          </a:prstGeom>
+          <a:solidFill>
+            <a:srgbClr val="F4F6FD"/>
+          </a:solidFill>
+          <a:ln w="19050">
+            <a:solidFill>
+              <a:srgbClr val="F2546B"/>
+            </a:solidFill>
+            <a:prstDash val="solid"/>
+          </a:ln>
+        </p:spPr>
+      </p:sp>
+      <p:sp>
+        <p:nvSpPr>
+          <p:cNvPr id="19" name="Shape 15"/>
+          <p:cNvSpPr/>
+          <p:nvPr/>
+        </p:nvSpPr>
+        <p:spPr>
+          <a:xfrm>
+            <a:off x="7022592" y="3017520"/>
+            <a:ext cx="731520" cy="731520"/>
+          </a:xfrm>
+          <a:prstGeom prst="ellipse">
+            <a:avLst/>
+          </a:prstGeom>
+          <a:solidFill>
+            <a:srgbClr val="F2546B"/>
+          </a:solidFill>
+          <a:ln w="12700">
+            <a:solidFill>
+              <a:srgbClr val="F2546B"/>
+            </a:solidFill>
+            <a:prstDash val="solid"/>
+          </a:ln>
+        </p:spPr>
+      </p:sp>
+      <p:pic>
+        <p:nvPicPr>
+          <p:cNvPr id="20" name="Image 2" descr="preencoded.png">    </p:cNvPr>
+          <p:cNvPicPr>
+            <a:picLocks noChangeAspect="1"/>
+          </p:cNvPicPr>
+          <p:nvPr/>
+        </p:nvPicPr>
+        <p:blipFill>
+          <a:blip r:embed="rId3"/>
+          <a:stretch>
+            <a:fillRect/>
+          </a:stretch>
+        </p:blipFill>
+        <p:spPr>
+          <a:xfrm>
+            <a:off x="7198157" y="3193085"/>
+            <a:ext cx="380390" cy="380390"/>
+          </a:xfrm>
+          <a:prstGeom prst="rect">
+            <a:avLst/>
+          </a:prstGeom>
+        </p:spPr>
+      </p:pic>
+      <p:sp>
+        <p:nvSpPr>
+          <p:cNvPr id="21" name="Text 16"/>
+          <p:cNvSpPr txBox="1"/>
+          <p:nvPr/>
+        </p:nvSpPr>
+        <p:spPr>
+          <a:xfrm>
+            <a:off x="6071616" y="3840480"/>
+            <a:ext cx="2624328" cy="365760"/>
+          </a:xfrm>
+          <a:prstGeom prst="rect">
+            <a:avLst/>
+          </a:prstGeom>
+          <a:noFill/>
+          <a:ln/>
+        </p:spPr>
+        <p:txBody>
+          <a:bodyPr wrap="square" lIns="0" tIns="0" rIns="0" bIns="0" rtlCol="0" anchor="t"/>
+          <a:lstStyle/>
+          <a:p>
+            <a:pPr algn="ctr" indent="0" marL="0">
+              <a:buNone/>
+            </a:pPr>
+            <a:r>
+              <a:rPr lang="en-US" sz="1700" b="1" dirty="0">
+                <a:solidFill>
+                  <a:srgbClr val="C81E43"/>
+                </a:solidFill>
+                <a:latin typeface="Calibri" pitchFamily="34" charset="0"/>
+                <a:ea typeface="Calibri" pitchFamily="34" charset="-122"/>
+                <a:cs typeface="Calibri" pitchFamily="34" charset="-120"/>
+              </a:rPr>
+              <a:t>Daño tisular</a:t>
+            </a:r>
+            <a:endParaRPr lang="en-US" sz="1700" dirty="0"/>
+          </a:p>
+        </p:txBody>
+      </p:sp>
+      <p:sp>
+        <p:nvSpPr>
+          <p:cNvPr id="22" name="Text 17"/>
+          <p:cNvSpPr txBox="1"/>
+          <p:nvPr/>
+        </p:nvSpPr>
+        <p:spPr>
+          <a:xfrm>
+            <a:off x="6071616" y="4187952"/>
+            <a:ext cx="2624328" cy="274320"/>
+          </a:xfrm>
+          <a:prstGeom prst="rect">
+            <a:avLst/>
+          </a:prstGeom>
+          <a:noFill/>
+          <a:ln/>
+        </p:spPr>
+        <p:txBody>
+          <a:bodyPr wrap="square" lIns="0" tIns="0" rIns="0" bIns="0" rtlCol="0" anchor="t"/>
+          <a:lstStyle/>
+          <a:p>
+            <a:pPr algn="ctr" indent="0" marL="0">
+              <a:buNone/>
+            </a:pPr>
+            <a:r>
+              <a:rPr lang="en-US" sz="1300" dirty="0">
+                <a:solidFill>
+                  <a:srgbClr val="51597F"/>
+                </a:solidFill>
+                <a:latin typeface="Calibri" pitchFamily="34" charset="0"/>
+                <a:ea typeface="Calibri" pitchFamily="34" charset="-122"/>
+                <a:cs typeface="Calibri" pitchFamily="34" charset="-120"/>
+              </a:rPr>
+              <a:t>Cómo lesiona</a:t>
+            </a:r>
+            <a:endParaRPr lang="en-US" sz="1300" dirty="0"/>
+          </a:p>
+        </p:txBody>
+      </p:sp>
+      <p:sp>
+        <p:nvSpPr>
+          <p:cNvPr id="25" name="Slide Number Placeholder 0"/>
+          <p:cNvSpPr>
+            <a:spLocks noGrp="1"/>
+          </p:cNvSpPr>
+          <p:nvPr>
+            <p:ph type="sldNum" sz="quarter" idx="4294967295"/>
+          </p:nvPr>
+        </p:nvSpPr>
+        <p:spPr>
+          <a:xfrm>
+            <a:off x="8321040" y="4754880"/>
+            <a:ext cx="365760" cy="274320"/>
+          </a:xfrm>
+          <a:prstGeom prst="rect">
+            <a:avLst/>
+          </a:prstGeom>
+          <a:extLst>
+            <a:ext uri="{C572A759-6A51-4108-AA02-DFA0A04FC94B}">
+              <ma14:wrappingTextBoxFlag xmlns:ma14="http://schemas.microsoft.com/office/mac/drawingml/2011/main" val="0"/>
+            </a:ext>
+          </a:extLst>
+        </p:spPr>
+        <p:txBody>
+          <a:bodyPr/>
+          <a:lstStyle>
+            <a:lvl1pPr>
+              <a:defRPr sz="1100">
+                <a:solidFill>
+                  <a:srgbClr val="9AA0C0"/>
+                </a:solidFill>
+                <a:latin typeface="Calibri"/>
+                <a:ea typeface="Calibri"/>
+                <a:cs typeface="Calibri"/>
+              </a:defRPr>
+            </a:lvl1pPr>
+          </a:lstStyle>
+          <a:p>
+            <a:pPr algn="r"/>
+            <a:fld id="{F7021451-1387-4CA6-816F-3879F97B5CBC}" type="slidenum">
+              <a:rPr b="0" lang="en-US"/>
+              <a:t>4</a:t>
             </a:fld>
             <a:endParaRPr lang="en-US"/>
           </a:p>

</xml_diff>

<commit_message>
White gram-positive deck: dramatic black image separators + richer slides
Black separator slides with impactful glowing bacteria illustration
(right-biased so left text stays high-contrast), agenda cards with
icons, fuller cover and objective slides to reduce whitespace;
projector-legible contrast.

Co-Authored-By: Claude Opus 4.8 <noreply@anthropic.com>
Claude-Session: https://claude.ai/code/session_01Xvkr5H24hZZBXgabDYzMMQ
</commit_message>
<xml_diff>
--- a/Cocos_grampositivos_BLANCO.pptx
+++ b/Cocos_grampositivos_BLANCO.pptx
@@ -1246,8 +1246,33 @@
         </p:nvSpPr>
         <p:spPr>
           <a:xfrm>
-            <a:off x="6629400" y="1051560"/>
-            <a:ext cx="475488" cy="475488"/>
+            <a:off x="5943600" y="0"/>
+            <a:ext cx="3200400" cy="5143500"/>
+          </a:xfrm>
+          <a:prstGeom prst="roundRect">
+            <a:avLst/>
+          </a:prstGeom>
+          <a:solidFill>
+            <a:srgbClr val="F4F6FD"/>
+          </a:solidFill>
+          <a:ln w="12700">
+            <a:solidFill>
+              <a:srgbClr val="F4F6FD"/>
+            </a:solidFill>
+            <a:prstDash val="solid"/>
+          </a:ln>
+        </p:spPr>
+      </p:sp>
+      <p:sp>
+        <p:nvSpPr>
+          <p:cNvPr id="3" name="Shape 1"/>
+          <p:cNvSpPr/>
+          <p:nvPr/>
+        </p:nvSpPr>
+        <p:spPr>
+          <a:xfrm>
+            <a:off x="6675120" y="640080"/>
+            <a:ext cx="566928" cy="566928"/>
           </a:xfrm>
           <a:prstGeom prst="ellipse">
             <a:avLst/>
@@ -1255,24 +1280,24 @@
           <a:solidFill>
             <a:srgbClr val="F2B43C"/>
           </a:solidFill>
-          <a:ln w="12700">
-            <a:solidFill>
-              <a:srgbClr val="D7DCEF"/>
-            </a:solidFill>
-            <a:prstDash val="solid"/>
-          </a:ln>
-        </p:spPr>
-      </p:sp>
-      <p:sp>
-        <p:nvSpPr>
-          <p:cNvPr id="3" name="Shape 1"/>
-          <p:cNvSpPr/>
-          <p:nvPr/>
-        </p:nvSpPr>
-        <p:spPr>
-          <a:xfrm>
-            <a:off x="7086600" y="1143000"/>
-            <a:ext cx="475488" cy="475488"/>
+          <a:ln w="19050">
+            <a:solidFill>
+              <a:srgbClr val="FFFFFF"/>
+            </a:solidFill>
+            <a:prstDash val="solid"/>
+          </a:ln>
+        </p:spPr>
+      </p:sp>
+      <p:sp>
+        <p:nvSpPr>
+          <p:cNvPr id="4" name="Shape 2"/>
+          <p:cNvSpPr/>
+          <p:nvPr/>
+        </p:nvSpPr>
+        <p:spPr>
+          <a:xfrm>
+            <a:off x="7185355" y="725119"/>
+            <a:ext cx="538582" cy="538582"/>
           </a:xfrm>
           <a:prstGeom prst="ellipse">
             <a:avLst/>
@@ -1280,24 +1305,24 @@
           <a:solidFill>
             <a:srgbClr val="F2B43C"/>
           </a:solidFill>
-          <a:ln w="12700">
-            <a:solidFill>
-              <a:srgbClr val="D7DCEF"/>
-            </a:solidFill>
-            <a:prstDash val="solid"/>
-          </a:ln>
-        </p:spPr>
-      </p:sp>
-      <p:sp>
-        <p:nvSpPr>
-          <p:cNvPr id="4" name="Shape 2"/>
-          <p:cNvSpPr/>
-          <p:nvPr/>
-        </p:nvSpPr>
-        <p:spPr>
-          <a:xfrm>
-            <a:off x="6858000" y="1508760"/>
-            <a:ext cx="475488" cy="475488"/>
+          <a:ln w="19050">
+            <a:solidFill>
+              <a:srgbClr val="FFFFFF"/>
+            </a:solidFill>
+            <a:prstDash val="solid"/>
+          </a:ln>
+        </p:spPr>
+      </p:sp>
+      <p:sp>
+        <p:nvSpPr>
+          <p:cNvPr id="5" name="Shape 3"/>
+          <p:cNvSpPr/>
+          <p:nvPr/>
+        </p:nvSpPr>
+        <p:spPr>
+          <a:xfrm>
+            <a:off x="6930238" y="1093622"/>
+            <a:ext cx="566928" cy="566928"/>
           </a:xfrm>
           <a:prstGeom prst="ellipse">
             <a:avLst/>
@@ -1305,24 +1330,24 @@
           <a:solidFill>
             <a:srgbClr val="F2B43C"/>
           </a:solidFill>
-          <a:ln w="12700">
-            <a:solidFill>
-              <a:srgbClr val="D7DCEF"/>
-            </a:solidFill>
-            <a:prstDash val="solid"/>
-          </a:ln>
-        </p:spPr>
-      </p:sp>
-      <p:sp>
-        <p:nvSpPr>
-          <p:cNvPr id="5" name="Shape 3"/>
-          <p:cNvSpPr/>
-          <p:nvPr/>
-        </p:nvSpPr>
-        <p:spPr>
-          <a:xfrm>
-            <a:off x="7315200" y="1554480"/>
-            <a:ext cx="475488" cy="475488"/>
+          <a:ln w="19050">
+            <a:solidFill>
+              <a:srgbClr val="FFFFFF"/>
+            </a:solidFill>
+            <a:prstDash val="solid"/>
+          </a:ln>
+        </p:spPr>
+      </p:sp>
+      <p:sp>
+        <p:nvSpPr>
+          <p:cNvPr id="6" name="Shape 4"/>
+          <p:cNvSpPr/>
+          <p:nvPr/>
+        </p:nvSpPr>
+        <p:spPr>
+          <a:xfrm>
+            <a:off x="7383780" y="1121969"/>
+            <a:ext cx="510235" cy="510235"/>
           </a:xfrm>
           <a:prstGeom prst="ellipse">
             <a:avLst/>
@@ -1330,24 +1355,24 @@
           <a:solidFill>
             <a:srgbClr val="F2B43C"/>
           </a:solidFill>
-          <a:ln w="12700">
-            <a:solidFill>
-              <a:srgbClr val="D7DCEF"/>
-            </a:solidFill>
-            <a:prstDash val="solid"/>
-          </a:ln>
-        </p:spPr>
-      </p:sp>
-      <p:sp>
-        <p:nvSpPr>
-          <p:cNvPr id="6" name="Shape 4"/>
-          <p:cNvSpPr/>
-          <p:nvPr/>
-        </p:nvSpPr>
-        <p:spPr>
-          <a:xfrm>
-            <a:off x="6720840" y="1920240"/>
-            <a:ext cx="475488" cy="475488"/>
+          <a:ln w="19050">
+            <a:solidFill>
+              <a:srgbClr val="FFFFFF"/>
+            </a:solidFill>
+            <a:prstDash val="solid"/>
+          </a:ln>
+        </p:spPr>
+      </p:sp>
+      <p:sp>
+        <p:nvSpPr>
+          <p:cNvPr id="7" name="Shape 5"/>
+          <p:cNvSpPr/>
+          <p:nvPr/>
+        </p:nvSpPr>
+        <p:spPr>
+          <a:xfrm>
+            <a:off x="6618427" y="1121969"/>
+            <a:ext cx="481889" cy="481889"/>
           </a:xfrm>
           <a:prstGeom prst="ellipse">
             <a:avLst/>
@@ -1355,24 +1380,24 @@
           <a:solidFill>
             <a:srgbClr val="F2B43C"/>
           </a:solidFill>
-          <a:ln w="12700">
-            <a:solidFill>
-              <a:srgbClr val="D7DCEF"/>
-            </a:solidFill>
-            <a:prstDash val="solid"/>
-          </a:ln>
-        </p:spPr>
-      </p:sp>
-      <p:sp>
-        <p:nvSpPr>
-          <p:cNvPr id="7" name="Shape 5"/>
-          <p:cNvSpPr/>
-          <p:nvPr/>
-        </p:nvSpPr>
-        <p:spPr>
-          <a:xfrm>
-            <a:off x="7178040" y="1965960"/>
-            <a:ext cx="475488" cy="475488"/>
+          <a:ln w="19050">
+            <a:solidFill>
+              <a:srgbClr val="FFFFFF"/>
+            </a:solidFill>
+            <a:prstDash val="solid"/>
+          </a:ln>
+        </p:spPr>
+      </p:sp>
+      <p:sp>
+        <p:nvSpPr>
+          <p:cNvPr id="8" name="Shape 6"/>
+          <p:cNvSpPr/>
+          <p:nvPr/>
+        </p:nvSpPr>
+        <p:spPr>
+          <a:xfrm>
+            <a:off x="7553858" y="753466"/>
+            <a:ext cx="453542" cy="453542"/>
           </a:xfrm>
           <a:prstGeom prst="ellipse">
             <a:avLst/>
@@ -1380,24 +1405,24 @@
           <a:solidFill>
             <a:srgbClr val="F2B43C"/>
           </a:solidFill>
-          <a:ln w="12700">
-            <a:solidFill>
-              <a:srgbClr val="D7DCEF"/>
-            </a:solidFill>
-            <a:prstDash val="solid"/>
-          </a:ln>
-        </p:spPr>
-      </p:sp>
-      <p:sp>
-        <p:nvSpPr>
-          <p:cNvPr id="8" name="Shape 6"/>
-          <p:cNvSpPr/>
-          <p:nvPr/>
-        </p:nvSpPr>
-        <p:spPr>
-          <a:xfrm>
-            <a:off x="7498080" y="1234440"/>
-            <a:ext cx="475488" cy="475488"/>
+          <a:ln w="19050">
+            <a:solidFill>
+              <a:srgbClr val="FFFFFF"/>
+            </a:solidFill>
+            <a:prstDash val="solid"/>
+          </a:ln>
+        </p:spPr>
+      </p:sp>
+      <p:sp>
+        <p:nvSpPr>
+          <p:cNvPr id="9" name="Shape 7"/>
+          <p:cNvSpPr/>
+          <p:nvPr/>
+        </p:nvSpPr>
+        <p:spPr>
+          <a:xfrm>
+            <a:off x="7128662" y="1518818"/>
+            <a:ext cx="481889" cy="481889"/>
           </a:xfrm>
           <a:prstGeom prst="ellipse">
             <a:avLst/>
@@ -1405,24 +1430,24 @@
           <a:solidFill>
             <a:srgbClr val="F2B43C"/>
           </a:solidFill>
-          <a:ln w="12700">
-            <a:solidFill>
-              <a:srgbClr val="D7DCEF"/>
-            </a:solidFill>
-            <a:prstDash val="solid"/>
-          </a:ln>
-        </p:spPr>
-      </p:sp>
-      <p:sp>
-        <p:nvSpPr>
-          <p:cNvPr id="9" name="Shape 7"/>
-          <p:cNvSpPr/>
-          <p:nvPr/>
-        </p:nvSpPr>
-        <p:spPr>
-          <a:xfrm>
-            <a:off x="7543800" y="1737360"/>
-            <a:ext cx="475488" cy="475488"/>
+          <a:ln w="19050">
+            <a:solidFill>
+              <a:srgbClr val="FFFFFF"/>
+            </a:solidFill>
+            <a:prstDash val="solid"/>
+          </a:ln>
+        </p:spPr>
+      </p:sp>
+      <p:sp>
+        <p:nvSpPr>
+          <p:cNvPr id="10" name="Shape 8"/>
+          <p:cNvSpPr/>
+          <p:nvPr/>
+        </p:nvSpPr>
+        <p:spPr>
+          <a:xfrm>
+            <a:off x="7610551" y="1433779"/>
+            <a:ext cx="425196" cy="425196"/>
           </a:xfrm>
           <a:prstGeom prst="ellipse">
             <a:avLst/>
@@ -1430,49 +1455,99 @@
           <a:solidFill>
             <a:srgbClr val="F2B43C"/>
           </a:solidFill>
-          <a:ln w="12700">
-            <a:solidFill>
-              <a:srgbClr val="D7DCEF"/>
-            </a:solidFill>
-            <a:prstDash val="solid"/>
-          </a:ln>
-        </p:spPr>
-      </p:sp>
-      <p:sp>
-        <p:nvSpPr>
-          <p:cNvPr id="10" name="Shape 8"/>
-          <p:cNvSpPr/>
-          <p:nvPr/>
-        </p:nvSpPr>
-        <p:spPr>
-          <a:xfrm>
-            <a:off x="6537960" y="3200400"/>
-            <a:ext cx="402336" cy="402336"/>
+          <a:ln w="19050">
+            <a:solidFill>
+              <a:srgbClr val="FFFFFF"/>
+            </a:solidFill>
+            <a:prstDash val="solid"/>
+          </a:ln>
+        </p:spPr>
+      </p:sp>
+      <p:sp>
+        <p:nvSpPr>
+          <p:cNvPr id="11" name="Shape 9"/>
+          <p:cNvSpPr/>
+          <p:nvPr/>
+        </p:nvSpPr>
+        <p:spPr>
+          <a:xfrm>
+            <a:off x="6646774" y="1547165"/>
+            <a:ext cx="425196" cy="425196"/>
           </a:xfrm>
           <a:prstGeom prst="ellipse">
             <a:avLst/>
           </a:prstGeom>
           <a:solidFill>
+            <a:srgbClr val="F2B43C"/>
+          </a:solidFill>
+          <a:ln w="19050">
+            <a:solidFill>
+              <a:srgbClr val="FFFFFF"/>
+            </a:solidFill>
+            <a:prstDash val="solid"/>
+          </a:ln>
+        </p:spPr>
+      </p:sp>
+      <p:sp>
+        <p:nvSpPr>
+          <p:cNvPr id="12" name="Shape 10"/>
+          <p:cNvSpPr/>
+          <p:nvPr/>
+        </p:nvSpPr>
+        <p:spPr>
+          <a:xfrm>
+            <a:off x="6873545" y="1915668"/>
+            <a:ext cx="396850" cy="396850"/>
+          </a:xfrm>
+          <a:prstGeom prst="ellipse">
+            <a:avLst/>
+          </a:prstGeom>
+          <a:solidFill>
+            <a:srgbClr val="F2B43C"/>
+          </a:solidFill>
+          <a:ln w="19050">
+            <a:solidFill>
+              <a:srgbClr val="FFFFFF"/>
+            </a:solidFill>
+            <a:prstDash val="solid"/>
+          </a:ln>
+        </p:spPr>
+      </p:sp>
+      <p:sp>
+        <p:nvSpPr>
+          <p:cNvPr id="13" name="Shape 11"/>
+          <p:cNvSpPr/>
+          <p:nvPr/>
+        </p:nvSpPr>
+        <p:spPr>
+          <a:xfrm>
+            <a:off x="6263640" y="3611880"/>
+            <a:ext cx="457200" cy="457200"/>
+          </a:xfrm>
+          <a:prstGeom prst="ellipse">
+            <a:avLst/>
+          </a:prstGeom>
+          <a:solidFill>
             <a:srgbClr val="F2546B"/>
           </a:solidFill>
-          <a:ln w="12700">
-            <a:solidFill>
-              <a:srgbClr val="D7DCEF"/>
-            </a:solidFill>
-            <a:prstDash val="solid"/>
-          </a:ln>
-        </p:spPr>
-      </p:sp>
-      <p:sp>
-        <p:nvSpPr>
-          <p:cNvPr id="11" name="Shape 9"/>
-          <p:cNvSpPr/>
-          <p:nvPr/>
-        </p:nvSpPr>
-        <p:spPr>
-          <a:xfrm>
-            <a:off x="6812280" y="3364992"/>
-            <a:ext cx="402336" cy="402336"/>
+          <a:ln w="19050">
+            <a:solidFill>
+              <a:srgbClr val="FFFFFF"/>
+            </a:solidFill>
+            <a:prstDash val="solid"/>
+          </a:ln>
+        </p:spPr>
+      </p:sp>
+      <p:sp>
+        <p:nvSpPr>
+          <p:cNvPr id="14" name="Shape 12"/>
+          <p:cNvSpPr/>
+          <p:nvPr/>
+        </p:nvSpPr>
+        <p:spPr>
+          <a:xfrm>
+            <a:off x="6574536" y="3721608"/>
+            <a:ext cx="457200" cy="457200"/>
           </a:xfrm>
           <a:prstGeom prst="ellipse">
             <a:avLst/>
@@ -1480,24 +1555,24 @@
           <a:solidFill>
             <a:srgbClr val="F2546B"/>
           </a:solidFill>
-          <a:ln w="12700">
-            <a:solidFill>
-              <a:srgbClr val="D7DCEF"/>
-            </a:solidFill>
-            <a:prstDash val="solid"/>
-          </a:ln>
-        </p:spPr>
-      </p:sp>
-      <p:sp>
-        <p:nvSpPr>
-          <p:cNvPr id="12" name="Shape 10"/>
-          <p:cNvSpPr/>
-          <p:nvPr/>
-        </p:nvSpPr>
-        <p:spPr>
-          <a:xfrm>
-            <a:off x="7086600" y="3529584"/>
-            <a:ext cx="402336" cy="402336"/>
+          <a:ln w="19050">
+            <a:solidFill>
+              <a:srgbClr val="FFFFFF"/>
+            </a:solidFill>
+            <a:prstDash val="solid"/>
+          </a:ln>
+        </p:spPr>
+      </p:sp>
+      <p:sp>
+        <p:nvSpPr>
+          <p:cNvPr id="15" name="Shape 13"/>
+          <p:cNvSpPr/>
+          <p:nvPr/>
+        </p:nvSpPr>
+        <p:spPr>
+          <a:xfrm>
+            <a:off x="6885432" y="3831336"/>
+            <a:ext cx="457200" cy="457200"/>
           </a:xfrm>
           <a:prstGeom prst="ellipse">
             <a:avLst/>
@@ -1505,24 +1580,24 @@
           <a:solidFill>
             <a:srgbClr val="F2546B"/>
           </a:solidFill>
-          <a:ln w="12700">
-            <a:solidFill>
-              <a:srgbClr val="D7DCEF"/>
-            </a:solidFill>
-            <a:prstDash val="solid"/>
-          </a:ln>
-        </p:spPr>
-      </p:sp>
-      <p:sp>
-        <p:nvSpPr>
-          <p:cNvPr id="13" name="Shape 11"/>
-          <p:cNvSpPr/>
-          <p:nvPr/>
-        </p:nvSpPr>
-        <p:spPr>
-          <a:xfrm>
-            <a:off x="7360920" y="3694176"/>
-            <a:ext cx="402336" cy="402336"/>
+          <a:ln w="19050">
+            <a:solidFill>
+              <a:srgbClr val="FFFFFF"/>
+            </a:solidFill>
+            <a:prstDash val="solid"/>
+          </a:ln>
+        </p:spPr>
+      </p:sp>
+      <p:sp>
+        <p:nvSpPr>
+          <p:cNvPr id="16" name="Shape 14"/>
+          <p:cNvSpPr/>
+          <p:nvPr/>
+        </p:nvSpPr>
+        <p:spPr>
+          <a:xfrm>
+            <a:off x="7196328" y="3941064"/>
+            <a:ext cx="457200" cy="457200"/>
           </a:xfrm>
           <a:prstGeom prst="ellipse">
             <a:avLst/>
@@ -1530,24 +1605,24 @@
           <a:solidFill>
             <a:srgbClr val="F2546B"/>
           </a:solidFill>
-          <a:ln w="12700">
-            <a:solidFill>
-              <a:srgbClr val="D7DCEF"/>
-            </a:solidFill>
-            <a:prstDash val="solid"/>
-          </a:ln>
-        </p:spPr>
-      </p:sp>
-      <p:sp>
-        <p:nvSpPr>
-          <p:cNvPr id="14" name="Shape 12"/>
-          <p:cNvSpPr/>
-          <p:nvPr/>
-        </p:nvSpPr>
-        <p:spPr>
-          <a:xfrm>
-            <a:off x="7635240" y="3858768"/>
-            <a:ext cx="402336" cy="402336"/>
+          <a:ln w="19050">
+            <a:solidFill>
+              <a:srgbClr val="FFFFFF"/>
+            </a:solidFill>
+            <a:prstDash val="solid"/>
+          </a:ln>
+        </p:spPr>
+      </p:sp>
+      <p:sp>
+        <p:nvSpPr>
+          <p:cNvPr id="17" name="Shape 15"/>
+          <p:cNvSpPr/>
+          <p:nvPr/>
+        </p:nvSpPr>
+        <p:spPr>
+          <a:xfrm>
+            <a:off x="7507224" y="4050792"/>
+            <a:ext cx="457200" cy="457200"/>
           </a:xfrm>
           <a:prstGeom prst="ellipse">
             <a:avLst/>
@@ -1555,24 +1630,24 @@
           <a:solidFill>
             <a:srgbClr val="F2546B"/>
           </a:solidFill>
-          <a:ln w="12700">
-            <a:solidFill>
-              <a:srgbClr val="D7DCEF"/>
-            </a:solidFill>
-            <a:prstDash val="solid"/>
-          </a:ln>
-        </p:spPr>
-      </p:sp>
-      <p:sp>
-        <p:nvSpPr>
-          <p:cNvPr id="15" name="Shape 13"/>
-          <p:cNvSpPr/>
-          <p:nvPr/>
-        </p:nvSpPr>
-        <p:spPr>
-          <a:xfrm>
-            <a:off x="7909560" y="4023360"/>
-            <a:ext cx="402336" cy="402336"/>
+          <a:ln w="19050">
+            <a:solidFill>
+              <a:srgbClr val="FFFFFF"/>
+            </a:solidFill>
+            <a:prstDash val="solid"/>
+          </a:ln>
+        </p:spPr>
+      </p:sp>
+      <p:sp>
+        <p:nvSpPr>
+          <p:cNvPr id="18" name="Shape 16"/>
+          <p:cNvSpPr/>
+          <p:nvPr/>
+        </p:nvSpPr>
+        <p:spPr>
+          <a:xfrm>
+            <a:off x="7818120" y="4160520"/>
+            <a:ext cx="457200" cy="457200"/>
           </a:xfrm>
           <a:prstGeom prst="ellipse">
             <a:avLst/>
@@ -1580,24 +1655,24 @@
           <a:solidFill>
             <a:srgbClr val="F2546B"/>
           </a:solidFill>
-          <a:ln w="12700">
-            <a:solidFill>
-              <a:srgbClr val="D7DCEF"/>
-            </a:solidFill>
-            <a:prstDash val="solid"/>
-          </a:ln>
-        </p:spPr>
-      </p:sp>
-      <p:sp>
-        <p:nvSpPr>
-          <p:cNvPr id="16" name="Shape 14"/>
-          <p:cNvSpPr/>
-          <p:nvPr/>
-        </p:nvSpPr>
-        <p:spPr>
-          <a:xfrm>
-            <a:off x="8183880" y="4187952"/>
-            <a:ext cx="402336" cy="402336"/>
+          <a:ln w="19050">
+            <a:solidFill>
+              <a:srgbClr val="FFFFFF"/>
+            </a:solidFill>
+            <a:prstDash val="solid"/>
+          </a:ln>
+        </p:spPr>
+      </p:sp>
+      <p:sp>
+        <p:nvSpPr>
+          <p:cNvPr id="19" name="Shape 17"/>
+          <p:cNvSpPr/>
+          <p:nvPr/>
+        </p:nvSpPr>
+        <p:spPr>
+          <a:xfrm>
+            <a:off x="8129016" y="4270248"/>
+            <a:ext cx="457200" cy="457200"/>
           </a:xfrm>
           <a:prstGeom prst="ellipse">
             <a:avLst/>
@@ -1605,24 +1680,49 @@
           <a:solidFill>
             <a:srgbClr val="F2546B"/>
           </a:solidFill>
-          <a:ln w="12700">
-            <a:solidFill>
-              <a:srgbClr val="D7DCEF"/>
-            </a:solidFill>
-            <a:prstDash val="solid"/>
-          </a:ln>
-        </p:spPr>
-      </p:sp>
-      <p:sp>
-        <p:nvSpPr>
-          <p:cNvPr id="17" name="Text 15"/>
+          <a:ln w="19050">
+            <a:solidFill>
+              <a:srgbClr val="FFFFFF"/>
+            </a:solidFill>
+            <a:prstDash val="solid"/>
+          </a:ln>
+        </p:spPr>
+      </p:sp>
+      <p:sp>
+        <p:nvSpPr>
+          <p:cNvPr id="20" name="Shape 18"/>
+          <p:cNvSpPr/>
+          <p:nvPr/>
+        </p:nvSpPr>
+        <p:spPr>
+          <a:xfrm>
+            <a:off x="8439912" y="4379976"/>
+            <a:ext cx="457200" cy="457200"/>
+          </a:xfrm>
+          <a:prstGeom prst="ellipse">
+            <a:avLst/>
+          </a:prstGeom>
+          <a:solidFill>
+            <a:srgbClr val="F2546B"/>
+          </a:solidFill>
+          <a:ln w="19050">
+            <a:solidFill>
+              <a:srgbClr val="FFFFFF"/>
+            </a:solidFill>
+            <a:prstDash val="solid"/>
+          </a:ln>
+        </p:spPr>
+      </p:sp>
+      <p:sp>
+        <p:nvSpPr>
+          <p:cNvPr id="21" name="Text 19"/>
           <p:cNvSpPr txBox="1"/>
           <p:nvPr/>
         </p:nvSpPr>
         <p:spPr>
           <a:xfrm>
             <a:off x="548640" y="914400"/>
-            <a:ext cx="5760720" cy="365760"/>
+            <a:ext cx="5486400" cy="365760"/>
           </a:xfrm>
           <a:prstGeom prst="rect">
             <a:avLst/>
@@ -1654,14 +1754,14 @@
       </p:sp>
       <p:sp>
         <p:nvSpPr>
-          <p:cNvPr id="18" name="Text 16"/>
+          <p:cNvPr id="22" name="Text 20"/>
           <p:cNvSpPr txBox="1"/>
           <p:nvPr/>
         </p:nvSpPr>
         <p:spPr>
           <a:xfrm>
             <a:off x="548640" y="1325880"/>
-            <a:ext cx="5852160" cy="914400"/>
+            <a:ext cx="5486400" cy="914400"/>
           </a:xfrm>
           <a:prstGeom prst="rect">
             <a:avLst/>
@@ -1677,7 +1777,7 @@
               <a:buNone/>
             </a:pPr>
             <a:r>
-              <a:rPr lang="en-US" sz="5200" b="1" dirty="0">
+              <a:rPr lang="en-US" sz="5400" b="1" dirty="0">
                 <a:solidFill>
                   <a:srgbClr val="15193A"/>
                 </a:solidFill>
@@ -1687,20 +1787,20 @@
               </a:rPr>
               <a:t>Grampositivos</a:t>
             </a:r>
-            <a:endParaRPr lang="en-US" sz="5200" dirty="0"/>
-          </a:p>
-        </p:txBody>
-      </p:sp>
-      <p:sp>
-        <p:nvSpPr>
-          <p:cNvPr id="19" name="Text 17"/>
+            <a:endParaRPr lang="en-US" sz="5400" dirty="0"/>
+          </a:p>
+        </p:txBody>
+      </p:sp>
+      <p:sp>
+        <p:nvSpPr>
+          <p:cNvPr id="23" name="Text 21"/>
           <p:cNvSpPr txBox="1"/>
           <p:nvPr/>
         </p:nvSpPr>
         <p:spPr>
           <a:xfrm>
             <a:off x="548640" y="2377440"/>
-            <a:ext cx="5760720" cy="822960"/>
+            <a:ext cx="5394960" cy="822960"/>
           </a:xfrm>
           <a:prstGeom prst="rect">
             <a:avLst/>
@@ -1732,14 +1832,14 @@
       </p:sp>
       <p:sp>
         <p:nvSpPr>
-          <p:cNvPr id="20" name="Text 18"/>
+          <p:cNvPr id="24" name="Text 22"/>
           <p:cNvSpPr txBox="1"/>
           <p:nvPr/>
         </p:nvSpPr>
         <p:spPr>
           <a:xfrm>
-            <a:off x="548640" y="3794760"/>
-            <a:ext cx="5669280" cy="411480"/>
+            <a:off x="548640" y="3749040"/>
+            <a:ext cx="5394960" cy="411480"/>
           </a:xfrm>
           <a:prstGeom prst="rect">
             <a:avLst/>
@@ -1771,14 +1871,14 @@
       </p:sp>
       <p:sp>
         <p:nvSpPr>
-          <p:cNvPr id="21" name="Text 19"/>
+          <p:cNvPr id="25" name="Text 23"/>
           <p:cNvSpPr txBox="1"/>
           <p:nvPr/>
         </p:nvSpPr>
         <p:spPr>
           <a:xfrm>
-            <a:off x="548640" y="4187952"/>
-            <a:ext cx="5943600" cy="320040"/>
+            <a:off x="548640" y="4142232"/>
+            <a:ext cx="5486400" cy="320040"/>
           </a:xfrm>
           <a:prstGeom prst="rect">
             <a:avLst/>
@@ -1810,14 +1910,14 @@
       </p:sp>
       <p:sp>
         <p:nvSpPr>
-          <p:cNvPr id="22" name="Text 20"/>
+          <p:cNvPr id="26" name="Text 24"/>
           <p:cNvSpPr txBox="1"/>
           <p:nvPr/>
         </p:nvSpPr>
         <p:spPr>
           <a:xfrm>
-            <a:off x="548640" y="4480560"/>
-            <a:ext cx="5943600" cy="292608"/>
+            <a:off x="548640" y="4434840"/>
+            <a:ext cx="5486400" cy="292608"/>
           </a:xfrm>
           <a:prstGeom prst="rect">
             <a:avLst/>
@@ -1965,8 +2065,8 @@
         </p:nvSpPr>
         <p:spPr>
           <a:xfrm>
-            <a:off x="365760" y="1554480"/>
-            <a:ext cx="1572768" cy="1920240"/>
+            <a:off x="365760" y="1417320"/>
+            <a:ext cx="1572768" cy="2377440"/>
           </a:xfrm>
           <a:prstGeom prst="roundRect">
             <a:avLst>
@@ -1988,14 +2088,63 @@
       </p:sp>
       <p:sp>
         <p:nvSpPr>
-          <p:cNvPr id="5" name="Text 3"/>
+          <p:cNvPr id="5" name="Shape 3"/>
+          <p:cNvSpPr/>
+          <p:nvPr/>
+        </p:nvSpPr>
+        <p:spPr>
+          <a:xfrm>
+            <a:off x="877824" y="1645920"/>
+            <a:ext cx="548640" cy="548640"/>
+          </a:xfrm>
+          <a:prstGeom prst="ellipse">
+            <a:avLst/>
+          </a:prstGeom>
+          <a:solidFill>
+            <a:srgbClr val="A78BFA"/>
+          </a:solidFill>
+          <a:ln w="12700">
+            <a:solidFill>
+              <a:srgbClr val="A78BFA"/>
+            </a:solidFill>
+            <a:prstDash val="solid"/>
+          </a:ln>
+        </p:spPr>
+      </p:sp>
+      <p:pic>
+        <p:nvPicPr>
+          <p:cNvPr id="6" name="Image 0" descr="preencoded.png">    </p:cNvPr>
+          <p:cNvPicPr>
+            <a:picLocks noChangeAspect="1"/>
+          </p:cNvPicPr>
+          <p:nvPr/>
+        </p:nvPicPr>
+        <p:blipFill>
+          <a:blip r:embed="rId1"/>
+          <a:stretch>
+            <a:fillRect/>
+          </a:stretch>
+        </p:blipFill>
+        <p:spPr>
+          <a:xfrm>
+            <a:off x="1009498" y="1777594"/>
+            <a:ext cx="285293" cy="285293"/>
+          </a:xfrm>
+          <a:prstGeom prst="rect">
+            <a:avLst/>
+          </a:prstGeom>
+        </p:spPr>
+      </p:pic>
+      <p:sp>
+        <p:nvSpPr>
+          <p:cNvPr id="7" name="Text 4"/>
           <p:cNvSpPr txBox="1"/>
           <p:nvPr/>
         </p:nvSpPr>
         <p:spPr>
           <a:xfrm>
-            <a:off x="365760" y="1737360"/>
-            <a:ext cx="1572768" cy="731520"/>
+            <a:off x="475488" y="1481328"/>
+            <a:ext cx="914400" cy="274320"/>
           </a:xfrm>
           <a:prstGeom prst="rect">
             <a:avLst/>
@@ -2004,14 +2153,14 @@
           <a:ln/>
         </p:spPr>
         <p:txBody>
-          <a:bodyPr wrap="square" lIns="0" tIns="0" rIns="0" bIns="0" rtlCol="0" anchor="ctr"/>
+          <a:bodyPr wrap="square" lIns="0" tIns="0" rIns="0" bIns="0" rtlCol="0" anchor="t"/>
           <a:lstStyle/>
           <a:p>
-            <a:pPr algn="ctr" indent="0" marL="0">
+            <a:pPr indent="0" marL="0">
               <a:buNone/>
             </a:pPr>
             <a:r>
-              <a:rPr lang="en-US" sz="3800" b="1" dirty="0">
+              <a:rPr lang="en-US" sz="1300" b="1" dirty="0">
                 <a:solidFill>
                   <a:srgbClr val="6A4CCF"/>
                 </a:solidFill>
@@ -2021,20 +2170,20 @@
               </a:rPr>
               <a:t>01</a:t>
             </a:r>
-            <a:endParaRPr lang="en-US" sz="3800" dirty="0"/>
-          </a:p>
-        </p:txBody>
-      </p:sp>
-      <p:sp>
-        <p:nvSpPr>
-          <p:cNvPr id="6" name="Text 4"/>
+            <a:endParaRPr lang="en-US" sz="1300" dirty="0"/>
+          </a:p>
+        </p:txBody>
+      </p:sp>
+      <p:sp>
+        <p:nvSpPr>
+          <p:cNvPr id="8" name="Text 5"/>
           <p:cNvSpPr txBox="1"/>
           <p:nvPr/>
         </p:nvSpPr>
         <p:spPr>
           <a:xfrm>
-            <a:off x="347472" y="2514600"/>
-            <a:ext cx="1609344" cy="777240"/>
+            <a:off x="347472" y="2377440"/>
+            <a:ext cx="1609344" cy="457200"/>
           </a:xfrm>
           <a:prstGeom prst="rect">
             <a:avLst/>
@@ -2066,14 +2215,53 @@
       </p:sp>
       <p:sp>
         <p:nvSpPr>
-          <p:cNvPr id="7" name="Shape 5"/>
-          <p:cNvSpPr/>
-          <p:nvPr/>
-        </p:nvSpPr>
-        <p:spPr>
-          <a:xfrm>
-            <a:off x="2066544" y="1554480"/>
-            <a:ext cx="1572768" cy="1920240"/>
+          <p:cNvPr id="9" name="Text 6"/>
+          <p:cNvSpPr txBox="1"/>
+          <p:nvPr/>
+        </p:nvSpPr>
+        <p:spPr>
+          <a:xfrm>
+            <a:off x="384048" y="2834640"/>
+            <a:ext cx="1536192" cy="822960"/>
+          </a:xfrm>
+          <a:prstGeom prst="rect">
+            <a:avLst/>
+          </a:prstGeom>
+          <a:noFill/>
+          <a:ln/>
+        </p:spPr>
+        <p:txBody>
+          <a:bodyPr wrap="square" lIns="0" tIns="0" rIns="0" bIns="0" rtlCol="0" anchor="t"/>
+          <a:lstStyle/>
+          <a:p>
+            <a:pPr algn="ctr" indent="0" marL="0">
+              <a:buNone/>
+            </a:pPr>
+            <a:r>
+              <a:rPr lang="en-US" sz="1100" dirty="0">
+                <a:solidFill>
+                  <a:srgbClr val="51597F"/>
+                </a:solidFill>
+                <a:latin typeface="Calibri" pitchFamily="34" charset="0"/>
+                <a:ea typeface="Calibri" pitchFamily="34" charset="-122"/>
+                <a:cs typeface="Calibri" pitchFamily="34" charset="-120"/>
+              </a:rPr>
+              <a:t>Objetivo general</a:t>
+            </a:r>
+            <a:endParaRPr lang="en-US" sz="1100" dirty="0"/>
+          </a:p>
+        </p:txBody>
+      </p:sp>
+      <p:sp>
+        <p:nvSpPr>
+          <p:cNvPr id="10" name="Shape 7"/>
+          <p:cNvSpPr/>
+          <p:nvPr/>
+        </p:nvSpPr>
+        <p:spPr>
+          <a:xfrm>
+            <a:off x="2066544" y="1417320"/>
+            <a:ext cx="1572768" cy="2377440"/>
           </a:xfrm>
           <a:prstGeom prst="roundRect">
             <a:avLst>
@@ -2095,14 +2283,63 @@
       </p:sp>
       <p:sp>
         <p:nvSpPr>
-          <p:cNvPr id="8" name="Text 6"/>
+          <p:cNvPr id="11" name="Shape 8"/>
+          <p:cNvSpPr/>
+          <p:nvPr/>
+        </p:nvSpPr>
+        <p:spPr>
+          <a:xfrm>
+            <a:off x="2578608" y="1645920"/>
+            <a:ext cx="548640" cy="548640"/>
+          </a:xfrm>
+          <a:prstGeom prst="ellipse">
+            <a:avLst/>
+          </a:prstGeom>
+          <a:solidFill>
+            <a:srgbClr val="F2B43C"/>
+          </a:solidFill>
+          <a:ln w="12700">
+            <a:solidFill>
+              <a:srgbClr val="F2B43C"/>
+            </a:solidFill>
+            <a:prstDash val="solid"/>
+          </a:ln>
+        </p:spPr>
+      </p:sp>
+      <p:pic>
+        <p:nvPicPr>
+          <p:cNvPr id="12" name="Image 1" descr="preencoded.png">    </p:cNvPr>
+          <p:cNvPicPr>
+            <a:picLocks noChangeAspect="1"/>
+          </p:cNvPicPr>
+          <p:nvPr/>
+        </p:nvPicPr>
+        <p:blipFill>
+          <a:blip r:embed="rId2"/>
+          <a:stretch>
+            <a:fillRect/>
+          </a:stretch>
+        </p:blipFill>
+        <p:spPr>
+          <a:xfrm>
+            <a:off x="2710282" y="1777594"/>
+            <a:ext cx="285293" cy="285293"/>
+          </a:xfrm>
+          <a:prstGeom prst="rect">
+            <a:avLst/>
+          </a:prstGeom>
+        </p:spPr>
+      </p:pic>
+      <p:sp>
+        <p:nvSpPr>
+          <p:cNvPr id="13" name="Text 9"/>
           <p:cNvSpPr txBox="1"/>
           <p:nvPr/>
         </p:nvSpPr>
         <p:spPr>
           <a:xfrm>
-            <a:off x="2066544" y="1737360"/>
-            <a:ext cx="1572768" cy="731520"/>
+            <a:off x="2176272" y="1481328"/>
+            <a:ext cx="914400" cy="274320"/>
           </a:xfrm>
           <a:prstGeom prst="rect">
             <a:avLst/>
@@ -2111,14 +2348,14 @@
           <a:ln/>
         </p:spPr>
         <p:txBody>
-          <a:bodyPr wrap="square" lIns="0" tIns="0" rIns="0" bIns="0" rtlCol="0" anchor="ctr"/>
+          <a:bodyPr wrap="square" lIns="0" tIns="0" rIns="0" bIns="0" rtlCol="0" anchor="t"/>
           <a:lstStyle/>
           <a:p>
-            <a:pPr algn="ctr" indent="0" marL="0">
+            <a:pPr indent="0" marL="0">
               <a:buNone/>
             </a:pPr>
             <a:r>
-              <a:rPr lang="en-US" sz="3800" b="1" dirty="0">
+              <a:rPr lang="en-US" sz="1300" b="1" dirty="0">
                 <a:solidFill>
                   <a:srgbClr val="A66A00"/>
                 </a:solidFill>
@@ -2128,20 +2365,20 @@
               </a:rPr>
               <a:t>02</a:t>
             </a:r>
-            <a:endParaRPr lang="en-US" sz="3800" dirty="0"/>
-          </a:p>
-        </p:txBody>
-      </p:sp>
-      <p:sp>
-        <p:nvSpPr>
-          <p:cNvPr id="9" name="Text 7"/>
+            <a:endParaRPr lang="en-US" sz="1300" dirty="0"/>
+          </a:p>
+        </p:txBody>
+      </p:sp>
+      <p:sp>
+        <p:nvSpPr>
+          <p:cNvPr id="14" name="Text 10"/>
           <p:cNvSpPr txBox="1"/>
           <p:nvPr/>
         </p:nvSpPr>
         <p:spPr>
           <a:xfrm>
-            <a:off x="2048256" y="2514600"/>
-            <a:ext cx="1609344" cy="777240"/>
+            <a:off x="2048256" y="2377440"/>
+            <a:ext cx="1609344" cy="457200"/>
           </a:xfrm>
           <a:prstGeom prst="rect">
             <a:avLst/>
@@ -2173,14 +2410,53 @@
       </p:sp>
       <p:sp>
         <p:nvSpPr>
-          <p:cNvPr id="10" name="Shape 8"/>
-          <p:cNvSpPr/>
-          <p:nvPr/>
-        </p:nvSpPr>
-        <p:spPr>
-          <a:xfrm>
-            <a:off x="3767328" y="1554480"/>
-            <a:ext cx="1572768" cy="1920240"/>
+          <p:cNvPr id="15" name="Text 11"/>
+          <p:cNvSpPr txBox="1"/>
+          <p:nvPr/>
+        </p:nvSpPr>
+        <p:spPr>
+          <a:xfrm>
+            <a:off x="2084832" y="2834640"/>
+            <a:ext cx="1536192" cy="822960"/>
+          </a:xfrm>
+          <a:prstGeom prst="rect">
+            <a:avLst/>
+          </a:prstGeom>
+          <a:noFill/>
+          <a:ln/>
+        </p:spPr>
+        <p:txBody>
+          <a:bodyPr wrap="square" lIns="0" tIns="0" rIns="0" bIns="0" rtlCol="0" anchor="t"/>
+          <a:lstStyle/>
+          <a:p>
+            <a:pPr algn="ctr" indent="0" marL="0">
+              <a:buNone/>
+            </a:pPr>
+            <a:r>
+              <a:rPr lang="en-US" sz="1100" dirty="0">
+                <a:solidFill>
+                  <a:srgbClr val="51597F"/>
+                </a:solidFill>
+                <a:latin typeface="Calibri" pitchFamily="34" charset="0"/>
+                <a:ea typeface="Calibri" pitchFamily="34" charset="-122"/>
+                <a:cs typeface="Calibri" pitchFamily="34" charset="-120"/>
+              </a:rPr>
+              <a:t>Clasificación y pared</a:t>
+            </a:r>
+            <a:endParaRPr lang="en-US" sz="1100" dirty="0"/>
+          </a:p>
+        </p:txBody>
+      </p:sp>
+      <p:sp>
+        <p:nvSpPr>
+          <p:cNvPr id="16" name="Shape 12"/>
+          <p:cNvSpPr/>
+          <p:nvPr/>
+        </p:nvSpPr>
+        <p:spPr>
+          <a:xfrm>
+            <a:off x="3767328" y="1417320"/>
+            <a:ext cx="1572768" cy="2377440"/>
           </a:xfrm>
           <a:prstGeom prst="roundRect">
             <a:avLst>
@@ -2202,14 +2478,63 @@
       </p:sp>
       <p:sp>
         <p:nvSpPr>
-          <p:cNvPr id="11" name="Text 9"/>
+          <p:cNvPr id="17" name="Shape 13"/>
+          <p:cNvSpPr/>
+          <p:nvPr/>
+        </p:nvSpPr>
+        <p:spPr>
+          <a:xfrm>
+            <a:off x="4279392" y="1645920"/>
+            <a:ext cx="548640" cy="548640"/>
+          </a:xfrm>
+          <a:prstGeom prst="ellipse">
+            <a:avLst/>
+          </a:prstGeom>
+          <a:solidFill>
+            <a:srgbClr val="2EC4B6"/>
+          </a:solidFill>
+          <a:ln w="12700">
+            <a:solidFill>
+              <a:srgbClr val="2EC4B6"/>
+            </a:solidFill>
+            <a:prstDash val="solid"/>
+          </a:ln>
+        </p:spPr>
+      </p:sp>
+      <p:pic>
+        <p:nvPicPr>
+          <p:cNvPr id="18" name="Image 2" descr="preencoded.png">    </p:cNvPr>
+          <p:cNvPicPr>
+            <a:picLocks noChangeAspect="1"/>
+          </p:cNvPicPr>
+          <p:nvPr/>
+        </p:nvPicPr>
+        <p:blipFill>
+          <a:blip r:embed="rId3"/>
+          <a:stretch>
+            <a:fillRect/>
+          </a:stretch>
+        </p:blipFill>
+        <p:spPr>
+          <a:xfrm>
+            <a:off x="4411066" y="1777594"/>
+            <a:ext cx="285293" cy="285293"/>
+          </a:xfrm>
+          <a:prstGeom prst="rect">
+            <a:avLst/>
+          </a:prstGeom>
+        </p:spPr>
+      </p:pic>
+      <p:sp>
+        <p:nvSpPr>
+          <p:cNvPr id="19" name="Text 14"/>
           <p:cNvSpPr txBox="1"/>
           <p:nvPr/>
         </p:nvSpPr>
         <p:spPr>
           <a:xfrm>
-            <a:off x="3767328" y="1737360"/>
-            <a:ext cx="1572768" cy="731520"/>
+            <a:off x="3877056" y="1481328"/>
+            <a:ext cx="914400" cy="274320"/>
           </a:xfrm>
           <a:prstGeom prst="rect">
             <a:avLst/>
@@ -2218,14 +2543,14 @@
           <a:ln/>
         </p:spPr>
         <p:txBody>
-          <a:bodyPr wrap="square" lIns="0" tIns="0" rIns="0" bIns="0" rtlCol="0" anchor="ctr"/>
+          <a:bodyPr wrap="square" lIns="0" tIns="0" rIns="0" bIns="0" rtlCol="0" anchor="t"/>
           <a:lstStyle/>
           <a:p>
-            <a:pPr algn="ctr" indent="0" marL="0">
+            <a:pPr indent="0" marL="0">
               <a:buNone/>
             </a:pPr>
             <a:r>
-              <a:rPr lang="en-US" sz="3800" b="1" dirty="0">
+              <a:rPr lang="en-US" sz="1300" b="1" dirty="0">
                 <a:solidFill>
                   <a:srgbClr val="0C8368"/>
                 </a:solidFill>
@@ -2235,20 +2560,20 @@
               </a:rPr>
               <a:t>03</a:t>
             </a:r>
-            <a:endParaRPr lang="en-US" sz="3800" dirty="0"/>
-          </a:p>
-        </p:txBody>
-      </p:sp>
-      <p:sp>
-        <p:nvSpPr>
-          <p:cNvPr id="12" name="Text 10"/>
+            <a:endParaRPr lang="en-US" sz="1300" dirty="0"/>
+          </a:p>
+        </p:txBody>
+      </p:sp>
+      <p:sp>
+        <p:nvSpPr>
+          <p:cNvPr id="20" name="Text 15"/>
           <p:cNvSpPr txBox="1"/>
           <p:nvPr/>
         </p:nvSpPr>
         <p:spPr>
           <a:xfrm>
-            <a:off x="3749040" y="2514600"/>
-            <a:ext cx="1609344" cy="777240"/>
+            <a:off x="3749040" y="2377440"/>
+            <a:ext cx="1609344" cy="457200"/>
           </a:xfrm>
           <a:prstGeom prst="rect">
             <a:avLst/>
@@ -2280,14 +2605,53 @@
       </p:sp>
       <p:sp>
         <p:nvSpPr>
-          <p:cNvPr id="13" name="Shape 11"/>
-          <p:cNvSpPr/>
-          <p:nvPr/>
-        </p:nvSpPr>
-        <p:spPr>
-          <a:xfrm>
-            <a:off x="5468112" y="1554480"/>
-            <a:ext cx="1572768" cy="1920240"/>
+          <p:cNvPr id="21" name="Text 16"/>
+          <p:cNvSpPr txBox="1"/>
+          <p:nvPr/>
+        </p:nvSpPr>
+        <p:spPr>
+          <a:xfrm>
+            <a:off x="3785616" y="2834640"/>
+            <a:ext cx="1536192" cy="822960"/>
+          </a:xfrm>
+          <a:prstGeom prst="rect">
+            <a:avLst/>
+          </a:prstGeom>
+          <a:noFill/>
+          <a:ln/>
+        </p:spPr>
+        <p:txBody>
+          <a:bodyPr wrap="square" lIns="0" tIns="0" rIns="0" bIns="0" rtlCol="0" anchor="t"/>
+          <a:lstStyle/>
+          <a:p>
+            <a:pPr algn="ctr" indent="0" marL="0">
+              <a:buNone/>
+            </a:pPr>
+            <a:r>
+              <a:rPr lang="en-US" sz="1100" dirty="0">
+                <a:solidFill>
+                  <a:srgbClr val="51597F"/>
+                </a:solidFill>
+                <a:latin typeface="Calibri" pitchFamily="34" charset="0"/>
+                <a:ea typeface="Calibri" pitchFamily="34" charset="-122"/>
+                <a:cs typeface="Calibri" pitchFamily="34" charset="-120"/>
+              </a:rPr>
+              <a:t>Colonizar y regular</a:t>
+            </a:r>
+            <a:endParaRPr lang="en-US" sz="1100" dirty="0"/>
+          </a:p>
+        </p:txBody>
+      </p:sp>
+      <p:sp>
+        <p:nvSpPr>
+          <p:cNvPr id="22" name="Shape 17"/>
+          <p:cNvSpPr/>
+          <p:nvPr/>
+        </p:nvSpPr>
+        <p:spPr>
+          <a:xfrm>
+            <a:off x="5468112" y="1417320"/>
+            <a:ext cx="1572768" cy="2377440"/>
           </a:xfrm>
           <a:prstGeom prst="roundRect">
             <a:avLst>
@@ -2309,14 +2673,63 @@
       </p:sp>
       <p:sp>
         <p:nvSpPr>
-          <p:cNvPr id="14" name="Text 12"/>
+          <p:cNvPr id="23" name="Shape 18"/>
+          <p:cNvSpPr/>
+          <p:nvPr/>
+        </p:nvSpPr>
+        <p:spPr>
+          <a:xfrm>
+            <a:off x="5980176" y="1645920"/>
+            <a:ext cx="548640" cy="548640"/>
+          </a:xfrm>
+          <a:prstGeom prst="ellipse">
+            <a:avLst/>
+          </a:prstGeom>
+          <a:solidFill>
+            <a:srgbClr val="F2546B"/>
+          </a:solidFill>
+          <a:ln w="12700">
+            <a:solidFill>
+              <a:srgbClr val="F2546B"/>
+            </a:solidFill>
+            <a:prstDash val="solid"/>
+          </a:ln>
+        </p:spPr>
+      </p:sp>
+      <p:pic>
+        <p:nvPicPr>
+          <p:cNvPr id="24" name="Image 3" descr="preencoded.png">    </p:cNvPr>
+          <p:cNvPicPr>
+            <a:picLocks noChangeAspect="1"/>
+          </p:cNvPicPr>
+          <p:nvPr/>
+        </p:nvPicPr>
+        <p:blipFill>
+          <a:blip r:embed="rId4"/>
+          <a:stretch>
+            <a:fillRect/>
+          </a:stretch>
+        </p:blipFill>
+        <p:spPr>
+          <a:xfrm>
+            <a:off x="6111850" y="1777594"/>
+            <a:ext cx="285293" cy="285293"/>
+          </a:xfrm>
+          <a:prstGeom prst="rect">
+            <a:avLst/>
+          </a:prstGeom>
+        </p:spPr>
+      </p:pic>
+      <p:sp>
+        <p:nvSpPr>
+          <p:cNvPr id="25" name="Text 19"/>
           <p:cNvSpPr txBox="1"/>
           <p:nvPr/>
         </p:nvSpPr>
         <p:spPr>
           <a:xfrm>
-            <a:off x="5468112" y="1737360"/>
-            <a:ext cx="1572768" cy="731520"/>
+            <a:off x="5577840" y="1481328"/>
+            <a:ext cx="914400" cy="274320"/>
           </a:xfrm>
           <a:prstGeom prst="rect">
             <a:avLst/>
@@ -2325,14 +2738,14 @@
           <a:ln/>
         </p:spPr>
         <p:txBody>
-          <a:bodyPr wrap="square" lIns="0" tIns="0" rIns="0" bIns="0" rtlCol="0" anchor="ctr"/>
+          <a:bodyPr wrap="square" lIns="0" tIns="0" rIns="0" bIns="0" rtlCol="0" anchor="t"/>
           <a:lstStyle/>
           <a:p>
-            <a:pPr algn="ctr" indent="0" marL="0">
+            <a:pPr indent="0" marL="0">
               <a:buNone/>
             </a:pPr>
             <a:r>
-              <a:rPr lang="en-US" sz="3800" b="1" dirty="0">
+              <a:rPr lang="en-US" sz="1300" b="1" dirty="0">
                 <a:solidFill>
                   <a:srgbClr val="C81E43"/>
                 </a:solidFill>
@@ -2342,20 +2755,20 @@
               </a:rPr>
               <a:t>04</a:t>
             </a:r>
-            <a:endParaRPr lang="en-US" sz="3800" dirty="0"/>
-          </a:p>
-        </p:txBody>
-      </p:sp>
-      <p:sp>
-        <p:nvSpPr>
-          <p:cNvPr id="15" name="Text 13"/>
+            <a:endParaRPr lang="en-US" sz="1300" dirty="0"/>
+          </a:p>
+        </p:txBody>
+      </p:sp>
+      <p:sp>
+        <p:nvSpPr>
+          <p:cNvPr id="26" name="Text 20"/>
           <p:cNvSpPr txBox="1"/>
           <p:nvPr/>
         </p:nvSpPr>
         <p:spPr>
           <a:xfrm>
-            <a:off x="5449824" y="2514600"/>
-            <a:ext cx="1609344" cy="777240"/>
+            <a:off x="5449824" y="2377440"/>
+            <a:ext cx="1609344" cy="457200"/>
           </a:xfrm>
           <a:prstGeom prst="rect">
             <a:avLst/>
@@ -2387,14 +2800,53 @@
       </p:sp>
       <p:sp>
         <p:nvSpPr>
-          <p:cNvPr id="16" name="Shape 14"/>
-          <p:cNvSpPr/>
-          <p:nvPr/>
-        </p:nvSpPr>
-        <p:spPr>
-          <a:xfrm>
-            <a:off x="7168896" y="1554480"/>
-            <a:ext cx="1572768" cy="1920240"/>
+          <p:cNvPr id="27" name="Text 21"/>
+          <p:cNvSpPr txBox="1"/>
+          <p:nvPr/>
+        </p:nvSpPr>
+        <p:spPr>
+          <a:xfrm>
+            <a:off x="5486400" y="2834640"/>
+            <a:ext cx="1536192" cy="822960"/>
+          </a:xfrm>
+          <a:prstGeom prst="rect">
+            <a:avLst/>
+          </a:prstGeom>
+          <a:noFill/>
+          <a:ln/>
+        </p:spPr>
+        <p:txBody>
+          <a:bodyPr wrap="square" lIns="0" tIns="0" rIns="0" bIns="0" rtlCol="0" anchor="t"/>
+          <a:lstStyle/>
+          <a:p>
+            <a:pPr algn="ctr" indent="0" marL="0">
+              <a:buNone/>
+            </a:pPr>
+            <a:r>
+              <a:rPr lang="en-US" sz="1100" dirty="0">
+                <a:solidFill>
+                  <a:srgbClr val="51597F"/>
+                </a:solidFill>
+                <a:latin typeface="Calibri" pitchFamily="34" charset="0"/>
+                <a:ea typeface="Calibri" pitchFamily="34" charset="-122"/>
+                <a:cs typeface="Calibri" pitchFamily="34" charset="-120"/>
+              </a:rPr>
+              <a:t>Virulencia y daño</a:t>
+            </a:r>
+            <a:endParaRPr lang="en-US" sz="1100" dirty="0"/>
+          </a:p>
+        </p:txBody>
+      </p:sp>
+      <p:sp>
+        <p:nvSpPr>
+          <p:cNvPr id="28" name="Shape 22"/>
+          <p:cNvSpPr/>
+          <p:nvPr/>
+        </p:nvSpPr>
+        <p:spPr>
+          <a:xfrm>
+            <a:off x="7168896" y="1417320"/>
+            <a:ext cx="1572768" cy="2377440"/>
           </a:xfrm>
           <a:prstGeom prst="roundRect">
             <a:avLst>
@@ -2416,14 +2868,63 @@
       </p:sp>
       <p:sp>
         <p:nvSpPr>
-          <p:cNvPr id="17" name="Text 15"/>
+          <p:cNvPr id="29" name="Shape 23"/>
+          <p:cNvSpPr/>
+          <p:nvPr/>
+        </p:nvSpPr>
+        <p:spPr>
+          <a:xfrm>
+            <a:off x="7680960" y="1645920"/>
+            <a:ext cx="548640" cy="548640"/>
+          </a:xfrm>
+          <a:prstGeom prst="ellipse">
+            <a:avLst/>
+          </a:prstGeom>
+          <a:solidFill>
+            <a:srgbClr val="4CC9F0"/>
+          </a:solidFill>
+          <a:ln w="12700">
+            <a:solidFill>
+              <a:srgbClr val="4CC9F0"/>
+            </a:solidFill>
+            <a:prstDash val="solid"/>
+          </a:ln>
+        </p:spPr>
+      </p:sp>
+      <p:pic>
+        <p:nvPicPr>
+          <p:cNvPr id="30" name="Image 4" descr="preencoded.png">    </p:cNvPr>
+          <p:cNvPicPr>
+            <a:picLocks noChangeAspect="1"/>
+          </p:cNvPicPr>
+          <p:nvPr/>
+        </p:nvPicPr>
+        <p:blipFill>
+          <a:blip r:embed="rId5"/>
+          <a:stretch>
+            <a:fillRect/>
+          </a:stretch>
+        </p:blipFill>
+        <p:spPr>
+          <a:xfrm>
+            <a:off x="7812634" y="1777594"/>
+            <a:ext cx="285293" cy="285293"/>
+          </a:xfrm>
+          <a:prstGeom prst="rect">
+            <a:avLst/>
+          </a:prstGeom>
+        </p:spPr>
+      </p:pic>
+      <p:sp>
+        <p:nvSpPr>
+          <p:cNvPr id="31" name="Text 24"/>
           <p:cNvSpPr txBox="1"/>
           <p:nvPr/>
         </p:nvSpPr>
         <p:spPr>
           <a:xfrm>
-            <a:off x="7168896" y="1737360"/>
-            <a:ext cx="1572768" cy="731520"/>
+            <a:off x="7278624" y="1481328"/>
+            <a:ext cx="914400" cy="274320"/>
           </a:xfrm>
           <a:prstGeom prst="rect">
             <a:avLst/>
@@ -2432,14 +2933,14 @@
           <a:ln/>
         </p:spPr>
         <p:txBody>
-          <a:bodyPr wrap="square" lIns="0" tIns="0" rIns="0" bIns="0" rtlCol="0" anchor="ctr"/>
+          <a:bodyPr wrap="square" lIns="0" tIns="0" rIns="0" bIns="0" rtlCol="0" anchor="t"/>
           <a:lstStyle/>
           <a:p>
-            <a:pPr algn="ctr" indent="0" marL="0">
+            <a:pPr indent="0" marL="0">
               <a:buNone/>
             </a:pPr>
             <a:r>
-              <a:rPr lang="en-US" sz="3800" b="1" dirty="0">
+              <a:rPr lang="en-US" sz="1300" b="1" dirty="0">
                 <a:solidFill>
                   <a:srgbClr val="0A6F98"/>
                 </a:solidFill>
@@ -2449,20 +2950,20 @@
               </a:rPr>
               <a:t>05</a:t>
             </a:r>
-            <a:endParaRPr lang="en-US" sz="3800" dirty="0"/>
-          </a:p>
-        </p:txBody>
-      </p:sp>
-      <p:sp>
-        <p:nvSpPr>
-          <p:cNvPr id="18" name="Text 16"/>
+            <a:endParaRPr lang="en-US" sz="1300" dirty="0"/>
+          </a:p>
+        </p:txBody>
+      </p:sp>
+      <p:sp>
+        <p:nvSpPr>
+          <p:cNvPr id="32" name="Text 25"/>
           <p:cNvSpPr txBox="1"/>
           <p:nvPr/>
         </p:nvSpPr>
         <p:spPr>
           <a:xfrm>
-            <a:off x="7150608" y="2514600"/>
-            <a:ext cx="1609344" cy="777240"/>
+            <a:off x="7150608" y="2377440"/>
+            <a:ext cx="1609344" cy="457200"/>
           </a:xfrm>
           <a:prstGeom prst="rect">
             <a:avLst/>
@@ -2494,6 +2995,45 @@
       </p:sp>
       <p:sp>
         <p:nvSpPr>
+          <p:cNvPr id="33" name="Text 26"/>
+          <p:cNvSpPr txBox="1"/>
+          <p:nvPr/>
+        </p:nvSpPr>
+        <p:spPr>
+          <a:xfrm>
+            <a:off x="7187184" y="2834640"/>
+            <a:ext cx="1536192" cy="822960"/>
+          </a:xfrm>
+          <a:prstGeom prst="rect">
+            <a:avLst/>
+          </a:prstGeom>
+          <a:noFill/>
+          <a:ln/>
+        </p:spPr>
+        <p:txBody>
+          <a:bodyPr wrap="square" lIns="0" tIns="0" rIns="0" bIns="0" rtlCol="0" anchor="t"/>
+          <a:lstStyle/>
+          <a:p>
+            <a:pPr algn="ctr" indent="0" marL="0">
+              <a:buNone/>
+            </a:pPr>
+            <a:r>
+              <a:rPr lang="en-US" sz="1100" dirty="0">
+                <a:solidFill>
+                  <a:srgbClr val="51597F"/>
+                </a:solidFill>
+                <a:latin typeface="Calibri" pitchFamily="34" charset="0"/>
+                <a:ea typeface="Calibri" pitchFamily="34" charset="-122"/>
+                <a:cs typeface="Calibri" pitchFamily="34" charset="-120"/>
+              </a:rPr>
+              <a:t>Ideas clave</a:t>
+            </a:r>
+            <a:endParaRPr lang="en-US" sz="1100" dirty="0"/>
+          </a:p>
+        </p:txBody>
+      </p:sp>
+      <p:sp>
+        <p:nvSpPr>
           <p:cNvPr id="25" name="Slide Number Placeholder 0"/>
           <p:cNvSpPr>
             <a:spLocks noGrp="1"/>
@@ -2554,7 +3094,7 @@
     <p:bg>
       <p:bgPr>
         <a:solidFill>
-          <a:srgbClr val="FFFFFF"/>
+          <a:srgbClr val="05070F"/>
         </a:solidFill>
       </p:bgPr>
     </p:bg>
@@ -2572,16 +3112,40 @@
           <a:chExt cx="0" cy="0"/>
         </a:xfrm>
       </p:grpSpPr>
-      <p:sp>
-        <p:nvSpPr>
-          <p:cNvPr id="2" name="Shape 0"/>
-          <p:cNvSpPr/>
-          <p:nvPr/>
-        </p:nvSpPr>
-        <p:spPr>
-          <a:xfrm>
-            <a:off x="548640" y="1828800"/>
-            <a:ext cx="109728" cy="1280160"/>
+      <p:pic>
+        <p:nvPicPr>
+          <p:cNvPr id="2" name="Image 0" descr="preencoded.png">    </p:cNvPr>
+          <p:cNvPicPr>
+            <a:picLocks noChangeAspect="1"/>
+          </p:cNvPicPr>
+          <p:nvPr/>
+        </p:nvPicPr>
+        <p:blipFill>
+          <a:blip r:embed="rId1"/>
+          <a:stretch>
+            <a:fillRect/>
+          </a:stretch>
+        </p:blipFill>
+        <p:spPr>
+          <a:xfrm>
+            <a:off x="0" y="0"/>
+            <a:ext cx="9144000" cy="5143500"/>
+          </a:xfrm>
+          <a:prstGeom prst="rect">
+            <a:avLst/>
+          </a:prstGeom>
+        </p:spPr>
+      </p:pic>
+      <p:sp>
+        <p:nvSpPr>
+          <p:cNvPr id="3" name="Shape 0"/>
+          <p:cNvSpPr/>
+          <p:nvPr/>
+        </p:nvSpPr>
+        <p:spPr>
+          <a:xfrm>
+            <a:off x="594360" y="1234440"/>
+            <a:ext cx="128016" cy="2331720"/>
           </a:xfrm>
           <a:prstGeom prst="rect">
             <a:avLst/>
@@ -2599,14 +3163,14 @@
       </p:sp>
       <p:sp>
         <p:nvSpPr>
-          <p:cNvPr id="3" name="Text 1"/>
+          <p:cNvPr id="4" name="Text 1"/>
           <p:cNvSpPr txBox="1"/>
           <p:nvPr/>
         </p:nvSpPr>
         <p:spPr>
           <a:xfrm>
-            <a:off x="868680" y="1280160"/>
-            <a:ext cx="3657600" cy="914400"/>
+            <a:off x="914400" y="1097280"/>
+            <a:ext cx="3657600" cy="1005840"/>
           </a:xfrm>
           <a:prstGeom prst="rect">
             <a:avLst/>
@@ -2622,9 +3186,9 @@
               <a:buNone/>
             </a:pPr>
             <a:r>
-              <a:rPr lang="en-US" sz="5600" b="1" dirty="0">
+              <a:rPr lang="en-US" sz="6400" b="1" dirty="0">
                 <a:solidFill>
-                  <a:srgbClr val="6A4CCF"/>
+                  <a:srgbClr val="A78BFA"/>
                 </a:solidFill>
                 <a:latin typeface="Calibri" pitchFamily="34" charset="0"/>
                 <a:ea typeface="Calibri" pitchFamily="34" charset="-122"/>
@@ -2632,20 +3196,20 @@
               </a:rPr>
               <a:t>01</a:t>
             </a:r>
-            <a:endParaRPr lang="en-US" sz="5600" dirty="0"/>
-          </a:p>
-        </p:txBody>
-      </p:sp>
-      <p:sp>
-        <p:nvSpPr>
-          <p:cNvPr id="4" name="Text 2"/>
+            <a:endParaRPr lang="en-US" sz="6400" dirty="0"/>
+          </a:p>
+        </p:txBody>
+      </p:sp>
+      <p:sp>
+        <p:nvSpPr>
+          <p:cNvPr id="5" name="Text 2"/>
           <p:cNvSpPr txBox="1"/>
           <p:nvPr/>
         </p:nvSpPr>
         <p:spPr>
           <a:xfrm>
-            <a:off x="868680" y="2194560"/>
-            <a:ext cx="7498080" cy="914400"/>
+            <a:off x="914400" y="2148840"/>
+            <a:ext cx="7589520" cy="1051560"/>
           </a:xfrm>
           <a:prstGeom prst="rect">
             <a:avLst/>
@@ -2661,9 +3225,9 @@
               <a:buNone/>
             </a:pPr>
             <a:r>
-              <a:rPr lang="en-US" sz="4800" b="1" dirty="0">
+              <a:rPr lang="en-US" sz="6000" b="1" dirty="0">
                 <a:solidFill>
-                  <a:srgbClr val="15193A"/>
+                  <a:srgbClr val="F4F6FF"/>
                 </a:solidFill>
                 <a:latin typeface="Calibri" pitchFamily="34" charset="0"/>
                 <a:ea typeface="Calibri" pitchFamily="34" charset="-122"/>
@@ -2671,20 +3235,20 @@
               </a:rPr>
               <a:t>Objetivo</a:t>
             </a:r>
-            <a:endParaRPr lang="en-US" sz="4800" dirty="0"/>
-          </a:p>
-        </p:txBody>
-      </p:sp>
-      <p:sp>
-        <p:nvSpPr>
-          <p:cNvPr id="5" name="Text 3"/>
+            <a:endParaRPr lang="en-US" sz="6000" dirty="0"/>
+          </a:p>
+        </p:txBody>
+      </p:sp>
+      <p:sp>
+        <p:nvSpPr>
+          <p:cNvPr id="6" name="Text 3"/>
           <p:cNvSpPr txBox="1"/>
           <p:nvPr/>
         </p:nvSpPr>
         <p:spPr>
           <a:xfrm>
-            <a:off x="886968" y="3200400"/>
-            <a:ext cx="6858000" cy="640080"/>
+            <a:off x="941832" y="3291840"/>
+            <a:ext cx="6949440" cy="640080"/>
           </a:xfrm>
           <a:prstGeom prst="rect">
             <a:avLst/>
@@ -2700,9 +3264,9 @@
               <a:buNone/>
             </a:pPr>
             <a:r>
-              <a:rPr lang="en-US" sz="2000" dirty="0">
+              <a:rPr lang="en-US" sz="2200" dirty="0">
                 <a:solidFill>
-                  <a:srgbClr val="51597F"/>
+                  <a:srgbClr val="B9C2E2"/>
                 </a:solidFill>
                 <a:latin typeface="Calibri" pitchFamily="34" charset="0"/>
                 <a:ea typeface="Calibri" pitchFamily="34" charset="-122"/>
@@ -2710,7 +3274,7 @@
               </a:rPr>
               <a:t>Qué queremos comprender</a:t>
             </a:r>
-            <a:endParaRPr lang="en-US" sz="2000" dirty="0"/>
+            <a:endParaRPr lang="en-US" sz="2200" dirty="0"/>
           </a:p>
         </p:txBody>
       </p:sp>
@@ -2912,11 +3476,11 @@
         <p:spPr>
           <a:xfrm>
             <a:off x="457200" y="1280160"/>
-            <a:ext cx="8229600" cy="1371600"/>
+            <a:ext cx="5486400" cy="3017520"/>
           </a:xfrm>
           <a:prstGeom prst="roundRect">
             <a:avLst>
-              <a:gd name="adj" fmla="val 6667"/>
+              <a:gd name="adj" fmla="val 3030"/>
             </a:avLst>
           </a:prstGeom>
           <a:solidFill>
@@ -2940,8 +3504,8 @@
         </p:nvSpPr>
         <p:spPr>
           <a:xfrm>
-            <a:off x="822960" y="1371600"/>
-            <a:ext cx="7498080" cy="1188720"/>
+            <a:off x="685800" y="1463040"/>
+            <a:ext cx="5029200" cy="914400"/>
           </a:xfrm>
           <a:prstGeom prst="rect">
             <a:avLst/>
@@ -2950,14 +3514,14 @@
           <a:ln/>
         </p:spPr>
         <p:txBody>
-          <a:bodyPr wrap="square" lIns="0" tIns="0" rIns="0" bIns="0" rtlCol="0" anchor="ctr"/>
+          <a:bodyPr wrap="square" lIns="0" tIns="0" rIns="0" bIns="0" rtlCol="0" anchor="t"/>
           <a:lstStyle/>
           <a:p>
             <a:pPr indent="0" marL="0">
               <a:buNone/>
             </a:pPr>
             <a:r>
-              <a:rPr lang="en-US" sz="2100" dirty="0">
+              <a:rPr lang="en-US" sz="1900" dirty="0">
                 <a:solidFill>
                   <a:srgbClr val="15193A"/>
                 </a:solidFill>
@@ -2965,9 +3529,9 @@
                 <a:ea typeface="Calibri" pitchFamily="34" charset="-122"/>
                 <a:cs typeface="Calibri" pitchFamily="34" charset="-120"/>
               </a:rPr>
-              <a:t>Comprender los mecanismos fisiopatológicos de las infecciones por bacterias grampositivas, enfatizando la virulencia, la evasión inmunitaria y el daño tisular.</a:t>
+              <a:t>Comprender los mecanismos fisiopatológicos de las infecciones por bacterias grampositivas, enfatizando:</a:t>
             </a:r>
-            <a:endParaRPr lang="en-US" sz="2100" dirty="0"/>
+            <a:endParaRPr lang="en-US" sz="1900" dirty="0"/>
           </a:p>
         </p:txBody>
       </p:sp>
@@ -2979,35 +3543,8 @@
         </p:nvSpPr>
         <p:spPr>
           <a:xfrm>
-            <a:off x="457200" y="2880360"/>
-            <a:ext cx="2624328" cy="1417320"/>
-          </a:xfrm>
-          <a:prstGeom prst="roundRect">
-            <a:avLst>
-              <a:gd name="adj" fmla="val 6452"/>
-            </a:avLst>
-          </a:prstGeom>
-          <a:solidFill>
-            <a:srgbClr val="F4F6FD"/>
-          </a:solidFill>
-          <a:ln w="19050">
-            <a:solidFill>
-              <a:srgbClr val="F2B43C"/>
-            </a:solidFill>
-            <a:prstDash val="solid"/>
-          </a:ln>
-        </p:spPr>
-      </p:sp>
-      <p:sp>
-        <p:nvSpPr>
-          <p:cNvPr id="9" name="Shape 7"/>
-          <p:cNvSpPr/>
-          <p:nvPr/>
-        </p:nvSpPr>
-        <p:spPr>
-          <a:xfrm>
-            <a:off x="1408176" y="3017520"/>
-            <a:ext cx="731520" cy="731520"/>
+            <a:off x="685800" y="2514600"/>
+            <a:ext cx="502920" cy="502920"/>
           </a:xfrm>
           <a:prstGeom prst="ellipse">
             <a:avLst/>
@@ -3025,7 +3562,7 @@
       </p:sp>
       <p:pic>
         <p:nvPicPr>
-          <p:cNvPr id="10" name="Image 0" descr="preencoded.png">    </p:cNvPr>
+          <p:cNvPr id="9" name="Image 0" descr="preencoded.png">    </p:cNvPr>
           <p:cNvPicPr>
             <a:picLocks noChangeAspect="1"/>
           </p:cNvPicPr>
@@ -3039,8 +3576,8 @@
         </p:blipFill>
         <p:spPr>
           <a:xfrm>
-            <a:off x="1583741" y="3193085"/>
-            <a:ext cx="380390" cy="380390"/>
+            <a:off x="806501" y="2635301"/>
+            <a:ext cx="261518" cy="261518"/>
           </a:xfrm>
           <a:prstGeom prst="rect">
             <a:avLst/>
@@ -3049,14 +3586,14 @@
       </p:pic>
       <p:sp>
         <p:nvSpPr>
-          <p:cNvPr id="11" name="Text 8"/>
+          <p:cNvPr id="10" name="Text 7"/>
           <p:cNvSpPr txBox="1"/>
           <p:nvPr/>
         </p:nvSpPr>
         <p:spPr>
           <a:xfrm>
-            <a:off x="457200" y="3840480"/>
-            <a:ext cx="2624328" cy="365760"/>
+            <a:off x="1371600" y="2496312"/>
+            <a:ext cx="4480560" cy="320040"/>
           </a:xfrm>
           <a:prstGeom prst="rect">
             <a:avLst/>
@@ -3068,11 +3605,11 @@
           <a:bodyPr wrap="square" lIns="0" tIns="0" rIns="0" bIns="0" rtlCol="0" anchor="t"/>
           <a:lstStyle/>
           <a:p>
-            <a:pPr algn="ctr" indent="0" marL="0">
+            <a:pPr indent="0" marL="0">
               <a:buNone/>
             </a:pPr>
             <a:r>
-              <a:rPr lang="en-US" sz="1700" b="1" dirty="0">
+              <a:rPr lang="en-US" sz="1600" b="1" dirty="0">
                 <a:solidFill>
                   <a:srgbClr val="A66A00"/>
                 </a:solidFill>
@@ -3082,20 +3619,20 @@
               </a:rPr>
               <a:t>Virulencia</a:t>
             </a:r>
-            <a:endParaRPr lang="en-US" sz="1700" dirty="0"/>
-          </a:p>
-        </p:txBody>
-      </p:sp>
-      <p:sp>
-        <p:nvSpPr>
-          <p:cNvPr id="12" name="Text 9"/>
+            <a:endParaRPr lang="en-US" sz="1600" dirty="0"/>
+          </a:p>
+        </p:txBody>
+      </p:sp>
+      <p:sp>
+        <p:nvSpPr>
+          <p:cNvPr id="11" name="Text 8"/>
           <p:cNvSpPr txBox="1"/>
           <p:nvPr/>
         </p:nvSpPr>
         <p:spPr>
           <a:xfrm>
-            <a:off x="457200" y="4187952"/>
-            <a:ext cx="2624328" cy="274320"/>
+            <a:off x="1371600" y="2807208"/>
+            <a:ext cx="4480560" cy="274320"/>
           </a:xfrm>
           <a:prstGeom prst="rect">
             <a:avLst/>
@@ -3107,7 +3644,7 @@
           <a:bodyPr wrap="square" lIns="0" tIns="0" rIns="0" bIns="0" rtlCol="0" anchor="t"/>
           <a:lstStyle/>
           <a:p>
-            <a:pPr algn="ctr" indent="0" marL="0">
+            <a:pPr indent="0" marL="0">
               <a:buNone/>
             </a:pPr>
             <a:r>
@@ -3127,41 +3664,14 @@
       </p:sp>
       <p:sp>
         <p:nvSpPr>
-          <p:cNvPr id="13" name="Shape 10"/>
-          <p:cNvSpPr/>
-          <p:nvPr/>
-        </p:nvSpPr>
-        <p:spPr>
-          <a:xfrm>
-            <a:off x="3264408" y="2880360"/>
-            <a:ext cx="2624328" cy="1417320"/>
-          </a:xfrm>
-          <a:prstGeom prst="roundRect">
-            <a:avLst>
-              <a:gd name="adj" fmla="val 6452"/>
-            </a:avLst>
-          </a:prstGeom>
-          <a:solidFill>
-            <a:srgbClr val="F4F6FD"/>
-          </a:solidFill>
-          <a:ln w="19050">
-            <a:solidFill>
-              <a:srgbClr val="2EC4B6"/>
-            </a:solidFill>
-            <a:prstDash val="solid"/>
-          </a:ln>
-        </p:spPr>
-      </p:sp>
-      <p:sp>
-        <p:nvSpPr>
-          <p:cNvPr id="14" name="Shape 11"/>
-          <p:cNvSpPr/>
-          <p:nvPr/>
-        </p:nvSpPr>
-        <p:spPr>
-          <a:xfrm>
-            <a:off x="4215384" y="3017520"/>
-            <a:ext cx="731520" cy="731520"/>
+          <p:cNvPr id="12" name="Shape 9"/>
+          <p:cNvSpPr/>
+          <p:nvPr/>
+        </p:nvSpPr>
+        <p:spPr>
+          <a:xfrm>
+            <a:off x="685800" y="3136392"/>
+            <a:ext cx="502920" cy="502920"/>
           </a:xfrm>
           <a:prstGeom prst="ellipse">
             <a:avLst/>
@@ -3179,7 +3689,7 @@
       </p:sp>
       <p:pic>
         <p:nvPicPr>
-          <p:cNvPr id="15" name="Image 1" descr="preencoded.png">    </p:cNvPr>
+          <p:cNvPr id="13" name="Image 1" descr="preencoded.png">    </p:cNvPr>
           <p:cNvPicPr>
             <a:picLocks noChangeAspect="1"/>
           </p:cNvPicPr>
@@ -3193,8 +3703,8 @@
         </p:blipFill>
         <p:spPr>
           <a:xfrm>
-            <a:off x="4390949" y="3193085"/>
-            <a:ext cx="380390" cy="380390"/>
+            <a:off x="806501" y="3257093"/>
+            <a:ext cx="261518" cy="261518"/>
           </a:xfrm>
           <a:prstGeom prst="rect">
             <a:avLst/>
@@ -3203,14 +3713,14 @@
       </p:pic>
       <p:sp>
         <p:nvSpPr>
-          <p:cNvPr id="16" name="Text 12"/>
+          <p:cNvPr id="14" name="Text 10"/>
           <p:cNvSpPr txBox="1"/>
           <p:nvPr/>
         </p:nvSpPr>
         <p:spPr>
           <a:xfrm>
-            <a:off x="3264408" y="3840480"/>
-            <a:ext cx="2624328" cy="365760"/>
+            <a:off x="1371600" y="3118104"/>
+            <a:ext cx="4480560" cy="320040"/>
           </a:xfrm>
           <a:prstGeom prst="rect">
             <a:avLst/>
@@ -3222,11 +3732,11 @@
           <a:bodyPr wrap="square" lIns="0" tIns="0" rIns="0" bIns="0" rtlCol="0" anchor="t"/>
           <a:lstStyle/>
           <a:p>
-            <a:pPr algn="ctr" indent="0" marL="0">
+            <a:pPr indent="0" marL="0">
               <a:buNone/>
             </a:pPr>
             <a:r>
-              <a:rPr lang="en-US" sz="1700" b="1" dirty="0">
+              <a:rPr lang="en-US" sz="1600" b="1" dirty="0">
                 <a:solidFill>
                   <a:srgbClr val="0C8368"/>
                 </a:solidFill>
@@ -3236,20 +3746,20 @@
               </a:rPr>
               <a:t>Evasión inmunitaria</a:t>
             </a:r>
-            <a:endParaRPr lang="en-US" sz="1700" dirty="0"/>
-          </a:p>
-        </p:txBody>
-      </p:sp>
-      <p:sp>
-        <p:nvSpPr>
-          <p:cNvPr id="17" name="Text 13"/>
+            <a:endParaRPr lang="en-US" sz="1600" dirty="0"/>
+          </a:p>
+        </p:txBody>
+      </p:sp>
+      <p:sp>
+        <p:nvSpPr>
+          <p:cNvPr id="15" name="Text 11"/>
           <p:cNvSpPr txBox="1"/>
           <p:nvPr/>
         </p:nvSpPr>
         <p:spPr>
           <a:xfrm>
-            <a:off x="3264408" y="4187952"/>
-            <a:ext cx="2624328" cy="274320"/>
+            <a:off x="1371600" y="3429000"/>
+            <a:ext cx="4480560" cy="274320"/>
           </a:xfrm>
           <a:prstGeom prst="rect">
             <a:avLst/>
@@ -3261,7 +3771,7 @@
           <a:bodyPr wrap="square" lIns="0" tIns="0" rIns="0" bIns="0" rtlCol="0" anchor="t"/>
           <a:lstStyle/>
           <a:p>
-            <a:pPr algn="ctr" indent="0" marL="0">
+            <a:pPr indent="0" marL="0">
               <a:buNone/>
             </a:pPr>
             <a:r>
@@ -3273,7 +3783,7 @@
                 <a:ea typeface="Calibri" pitchFamily="34" charset="-122"/>
                 <a:cs typeface="Calibri" pitchFamily="34" charset="-120"/>
               </a:rPr>
-              <a:t>Cómo escapa</a:t>
+              <a:t>Cómo escapa al sistema inmune</a:t>
             </a:r>
             <a:endParaRPr lang="en-US" sz="1300" dirty="0"/>
           </a:p>
@@ -3281,41 +3791,14 @@
       </p:sp>
       <p:sp>
         <p:nvSpPr>
-          <p:cNvPr id="18" name="Shape 14"/>
-          <p:cNvSpPr/>
-          <p:nvPr/>
-        </p:nvSpPr>
-        <p:spPr>
-          <a:xfrm>
-            <a:off x="6071616" y="2880360"/>
-            <a:ext cx="2624328" cy="1417320"/>
-          </a:xfrm>
-          <a:prstGeom prst="roundRect">
-            <a:avLst>
-              <a:gd name="adj" fmla="val 6452"/>
-            </a:avLst>
-          </a:prstGeom>
-          <a:solidFill>
-            <a:srgbClr val="F4F6FD"/>
-          </a:solidFill>
-          <a:ln w="19050">
-            <a:solidFill>
-              <a:srgbClr val="F2546B"/>
-            </a:solidFill>
-            <a:prstDash val="solid"/>
-          </a:ln>
-        </p:spPr>
-      </p:sp>
-      <p:sp>
-        <p:nvSpPr>
-          <p:cNvPr id="19" name="Shape 15"/>
-          <p:cNvSpPr/>
-          <p:nvPr/>
-        </p:nvSpPr>
-        <p:spPr>
-          <a:xfrm>
-            <a:off x="7022592" y="3017520"/>
-            <a:ext cx="731520" cy="731520"/>
+          <p:cNvPr id="16" name="Shape 12"/>
+          <p:cNvSpPr/>
+          <p:nvPr/>
+        </p:nvSpPr>
+        <p:spPr>
+          <a:xfrm>
+            <a:off x="685800" y="3758184"/>
+            <a:ext cx="502920" cy="502920"/>
           </a:xfrm>
           <a:prstGeom prst="ellipse">
             <a:avLst/>
@@ -3333,7 +3816,7 @@
       </p:sp>
       <p:pic>
         <p:nvPicPr>
-          <p:cNvPr id="20" name="Image 2" descr="preencoded.png">    </p:cNvPr>
+          <p:cNvPr id="17" name="Image 2" descr="preencoded.png">    </p:cNvPr>
           <p:cNvPicPr>
             <a:picLocks noChangeAspect="1"/>
           </p:cNvPicPr>
@@ -3347,8 +3830,8 @@
         </p:blipFill>
         <p:spPr>
           <a:xfrm>
-            <a:off x="7198157" y="3193085"/>
-            <a:ext cx="380390" cy="380390"/>
+            <a:off x="806501" y="3878885"/>
+            <a:ext cx="261518" cy="261518"/>
           </a:xfrm>
           <a:prstGeom prst="rect">
             <a:avLst/>
@@ -3357,14 +3840,14 @@
       </p:pic>
       <p:sp>
         <p:nvSpPr>
-          <p:cNvPr id="21" name="Text 16"/>
+          <p:cNvPr id="18" name="Text 13"/>
           <p:cNvSpPr txBox="1"/>
           <p:nvPr/>
         </p:nvSpPr>
         <p:spPr>
           <a:xfrm>
-            <a:off x="6071616" y="3840480"/>
-            <a:ext cx="2624328" cy="365760"/>
+            <a:off x="1371600" y="3739896"/>
+            <a:ext cx="4480560" cy="320040"/>
           </a:xfrm>
           <a:prstGeom prst="rect">
             <a:avLst/>
@@ -3376,11 +3859,11 @@
           <a:bodyPr wrap="square" lIns="0" tIns="0" rIns="0" bIns="0" rtlCol="0" anchor="t"/>
           <a:lstStyle/>
           <a:p>
-            <a:pPr algn="ctr" indent="0" marL="0">
+            <a:pPr indent="0" marL="0">
               <a:buNone/>
             </a:pPr>
             <a:r>
-              <a:rPr lang="en-US" sz="1700" b="1" dirty="0">
+              <a:rPr lang="en-US" sz="1600" b="1" dirty="0">
                 <a:solidFill>
                   <a:srgbClr val="C81E43"/>
                 </a:solidFill>
@@ -3390,20 +3873,20 @@
               </a:rPr>
               <a:t>Daño tisular</a:t>
             </a:r>
-            <a:endParaRPr lang="en-US" sz="1700" dirty="0"/>
-          </a:p>
-        </p:txBody>
-      </p:sp>
-      <p:sp>
-        <p:nvSpPr>
-          <p:cNvPr id="22" name="Text 17"/>
+            <a:endParaRPr lang="en-US" sz="1600" dirty="0"/>
+          </a:p>
+        </p:txBody>
+      </p:sp>
+      <p:sp>
+        <p:nvSpPr>
+          <p:cNvPr id="19" name="Text 14"/>
           <p:cNvSpPr txBox="1"/>
           <p:nvPr/>
         </p:nvSpPr>
         <p:spPr>
           <a:xfrm>
-            <a:off x="6071616" y="4187952"/>
-            <a:ext cx="2624328" cy="274320"/>
+            <a:off x="1371600" y="4050792"/>
+            <a:ext cx="4480560" cy="274320"/>
           </a:xfrm>
           <a:prstGeom prst="rect">
             <a:avLst/>
@@ -3415,7 +3898,7 @@
           <a:bodyPr wrap="square" lIns="0" tIns="0" rIns="0" bIns="0" rtlCol="0" anchor="t"/>
           <a:lstStyle/>
           <a:p>
-            <a:pPr algn="ctr" indent="0" marL="0">
+            <a:pPr indent="0" marL="0">
               <a:buNone/>
             </a:pPr>
             <a:r>
@@ -3427,11 +3910,338 @@
                 <a:ea typeface="Calibri" pitchFamily="34" charset="-122"/>
                 <a:cs typeface="Calibri" pitchFamily="34" charset="-120"/>
               </a:rPr>
-              <a:t>Cómo lesiona</a:t>
+              <a:t>Cómo lesiona los tejidos</a:t>
             </a:r>
             <a:endParaRPr lang="en-US" sz="1300" dirty="0"/>
           </a:p>
         </p:txBody>
+      </p:sp>
+      <p:sp>
+        <p:nvSpPr>
+          <p:cNvPr id="20" name="Shape 15"/>
+          <p:cNvSpPr/>
+          <p:nvPr/>
+        </p:nvSpPr>
+        <p:spPr>
+          <a:xfrm>
+            <a:off x="6172200" y="1280160"/>
+            <a:ext cx="2514600" cy="3017520"/>
+          </a:xfrm>
+          <a:prstGeom prst="roundRect">
+            <a:avLst>
+              <a:gd name="adj" fmla="val 3636"/>
+            </a:avLst>
+          </a:prstGeom>
+          <a:solidFill>
+            <a:srgbClr val="0A0E1F"/>
+          </a:solidFill>
+          <a:ln w="12700">
+            <a:solidFill>
+              <a:srgbClr val="0A0E1F"/>
+            </a:solidFill>
+            <a:prstDash val="solid"/>
+          </a:ln>
+        </p:spPr>
+      </p:sp>
+      <p:sp>
+        <p:nvSpPr>
+          <p:cNvPr id="21" name="Shape 16"/>
+          <p:cNvSpPr/>
+          <p:nvPr/>
+        </p:nvSpPr>
+        <p:spPr>
+          <a:xfrm>
+            <a:off x="6858000" y="1737360"/>
+            <a:ext cx="512064" cy="512064"/>
+          </a:xfrm>
+          <a:prstGeom prst="ellipse">
+            <a:avLst/>
+          </a:prstGeom>
+          <a:solidFill>
+            <a:srgbClr val="F2B43C"/>
+          </a:solidFill>
+          <a:ln w="19050">
+            <a:solidFill>
+              <a:srgbClr val="FFFFFF"/>
+            </a:solidFill>
+            <a:prstDash val="solid"/>
+          </a:ln>
+        </p:spPr>
+      </p:sp>
+      <p:sp>
+        <p:nvSpPr>
+          <p:cNvPr id="22" name="Shape 17"/>
+          <p:cNvSpPr/>
+          <p:nvPr/>
+        </p:nvSpPr>
+        <p:spPr>
+          <a:xfrm>
+            <a:off x="7351776" y="1819656"/>
+            <a:ext cx="512064" cy="512064"/>
+          </a:xfrm>
+          <a:prstGeom prst="ellipse">
+            <a:avLst/>
+          </a:prstGeom>
+          <a:solidFill>
+            <a:srgbClr val="F2B43C"/>
+          </a:solidFill>
+          <a:ln w="19050">
+            <a:solidFill>
+              <a:srgbClr val="FFFFFF"/>
+            </a:solidFill>
+            <a:prstDash val="solid"/>
+          </a:ln>
+        </p:spPr>
+      </p:sp>
+      <p:sp>
+        <p:nvSpPr>
+          <p:cNvPr id="23" name="Shape 18"/>
+          <p:cNvSpPr/>
+          <p:nvPr/>
+        </p:nvSpPr>
+        <p:spPr>
+          <a:xfrm>
+            <a:off x="7104888" y="2203704"/>
+            <a:ext cx="512064" cy="512064"/>
+          </a:xfrm>
+          <a:prstGeom prst="ellipse">
+            <a:avLst/>
+          </a:prstGeom>
+          <a:solidFill>
+            <a:srgbClr val="F2B43C"/>
+          </a:solidFill>
+          <a:ln w="19050">
+            <a:solidFill>
+              <a:srgbClr val="FFFFFF"/>
+            </a:solidFill>
+            <a:prstDash val="solid"/>
+          </a:ln>
+        </p:spPr>
+      </p:sp>
+      <p:sp>
+        <p:nvSpPr>
+          <p:cNvPr id="24" name="Shape 19"/>
+          <p:cNvSpPr/>
+          <p:nvPr/>
+        </p:nvSpPr>
+        <p:spPr>
+          <a:xfrm>
+            <a:off x="7543800" y="2231136"/>
+            <a:ext cx="512064" cy="512064"/>
+          </a:xfrm>
+          <a:prstGeom prst="ellipse">
+            <a:avLst/>
+          </a:prstGeom>
+          <a:solidFill>
+            <a:srgbClr val="F2B43C"/>
+          </a:solidFill>
+          <a:ln w="19050">
+            <a:solidFill>
+              <a:srgbClr val="FFFFFF"/>
+            </a:solidFill>
+            <a:prstDash val="solid"/>
+          </a:ln>
+        </p:spPr>
+      </p:sp>
+      <p:sp>
+        <p:nvSpPr>
+          <p:cNvPr id="25" name="Shape 20"/>
+          <p:cNvSpPr/>
+          <p:nvPr/>
+        </p:nvSpPr>
+        <p:spPr>
+          <a:xfrm>
+            <a:off x="6830568" y="2258568"/>
+            <a:ext cx="512064" cy="512064"/>
+          </a:xfrm>
+          <a:prstGeom prst="ellipse">
+            <a:avLst/>
+          </a:prstGeom>
+          <a:solidFill>
+            <a:srgbClr val="F2B43C"/>
+          </a:solidFill>
+          <a:ln w="19050">
+            <a:solidFill>
+              <a:srgbClr val="FFFFFF"/>
+            </a:solidFill>
+            <a:prstDash val="solid"/>
+          </a:ln>
+        </p:spPr>
+      </p:sp>
+      <p:sp>
+        <p:nvSpPr>
+          <p:cNvPr id="26" name="Shape 21"/>
+          <p:cNvSpPr/>
+          <p:nvPr/>
+        </p:nvSpPr>
+        <p:spPr>
+          <a:xfrm>
+            <a:off x="7296912" y="2670048"/>
+            <a:ext cx="512064" cy="512064"/>
+          </a:xfrm>
+          <a:prstGeom prst="ellipse">
+            <a:avLst/>
+          </a:prstGeom>
+          <a:solidFill>
+            <a:srgbClr val="F2B43C"/>
+          </a:solidFill>
+          <a:ln w="19050">
+            <a:solidFill>
+              <a:srgbClr val="FFFFFF"/>
+            </a:solidFill>
+            <a:prstDash val="solid"/>
+          </a:ln>
+        </p:spPr>
+      </p:sp>
+      <p:sp>
+        <p:nvSpPr>
+          <p:cNvPr id="27" name="Shape 22"/>
+          <p:cNvSpPr/>
+          <p:nvPr/>
+        </p:nvSpPr>
+        <p:spPr>
+          <a:xfrm>
+            <a:off x="6355080" y="3703320"/>
+            <a:ext cx="384048" cy="384048"/>
+          </a:xfrm>
+          <a:prstGeom prst="ellipse">
+            <a:avLst/>
+          </a:prstGeom>
+          <a:solidFill>
+            <a:srgbClr val="F2546B"/>
+          </a:solidFill>
+          <a:ln w="19050">
+            <a:solidFill>
+              <a:srgbClr val="FFFFFF"/>
+            </a:solidFill>
+            <a:prstDash val="solid"/>
+          </a:ln>
+        </p:spPr>
+      </p:sp>
+      <p:sp>
+        <p:nvSpPr>
+          <p:cNvPr id="28" name="Shape 23"/>
+          <p:cNvSpPr/>
+          <p:nvPr/>
+        </p:nvSpPr>
+        <p:spPr>
+          <a:xfrm>
+            <a:off x="6629400" y="3730752"/>
+            <a:ext cx="384048" cy="384048"/>
+          </a:xfrm>
+          <a:prstGeom prst="ellipse">
+            <a:avLst/>
+          </a:prstGeom>
+          <a:solidFill>
+            <a:srgbClr val="F2546B"/>
+          </a:solidFill>
+          <a:ln w="19050">
+            <a:solidFill>
+              <a:srgbClr val="FFFFFF"/>
+            </a:solidFill>
+            <a:prstDash val="solid"/>
+          </a:ln>
+        </p:spPr>
+      </p:sp>
+      <p:sp>
+        <p:nvSpPr>
+          <p:cNvPr id="29" name="Shape 24"/>
+          <p:cNvSpPr/>
+          <p:nvPr/>
+        </p:nvSpPr>
+        <p:spPr>
+          <a:xfrm>
+            <a:off x="6903720" y="3758184"/>
+            <a:ext cx="384048" cy="384048"/>
+          </a:xfrm>
+          <a:prstGeom prst="ellipse">
+            <a:avLst/>
+          </a:prstGeom>
+          <a:solidFill>
+            <a:srgbClr val="F2546B"/>
+          </a:solidFill>
+          <a:ln w="19050">
+            <a:solidFill>
+              <a:srgbClr val="FFFFFF"/>
+            </a:solidFill>
+            <a:prstDash val="solid"/>
+          </a:ln>
+        </p:spPr>
+      </p:sp>
+      <p:sp>
+        <p:nvSpPr>
+          <p:cNvPr id="30" name="Shape 25"/>
+          <p:cNvSpPr/>
+          <p:nvPr/>
+        </p:nvSpPr>
+        <p:spPr>
+          <a:xfrm>
+            <a:off x="7178040" y="3785616"/>
+            <a:ext cx="384048" cy="384048"/>
+          </a:xfrm>
+          <a:prstGeom prst="ellipse">
+            <a:avLst/>
+          </a:prstGeom>
+          <a:solidFill>
+            <a:srgbClr val="F2546B"/>
+          </a:solidFill>
+          <a:ln w="19050">
+            <a:solidFill>
+              <a:srgbClr val="FFFFFF"/>
+            </a:solidFill>
+            <a:prstDash val="solid"/>
+          </a:ln>
+        </p:spPr>
+      </p:sp>
+      <p:sp>
+        <p:nvSpPr>
+          <p:cNvPr id="31" name="Shape 26"/>
+          <p:cNvSpPr/>
+          <p:nvPr/>
+        </p:nvSpPr>
+        <p:spPr>
+          <a:xfrm>
+            <a:off x="7452360" y="3813048"/>
+            <a:ext cx="384048" cy="384048"/>
+          </a:xfrm>
+          <a:prstGeom prst="ellipse">
+            <a:avLst/>
+          </a:prstGeom>
+          <a:solidFill>
+            <a:srgbClr val="F2546B"/>
+          </a:solidFill>
+          <a:ln w="19050">
+            <a:solidFill>
+              <a:srgbClr val="FFFFFF"/>
+            </a:solidFill>
+            <a:prstDash val="solid"/>
+          </a:ln>
+        </p:spPr>
+      </p:sp>
+      <p:sp>
+        <p:nvSpPr>
+          <p:cNvPr id="32" name="Shape 27"/>
+          <p:cNvSpPr/>
+          <p:nvPr/>
+        </p:nvSpPr>
+        <p:spPr>
+          <a:xfrm>
+            <a:off x="7726680" y="3840480"/>
+            <a:ext cx="384048" cy="384048"/>
+          </a:xfrm>
+          <a:prstGeom prst="ellipse">
+            <a:avLst/>
+          </a:prstGeom>
+          <a:solidFill>
+            <a:srgbClr val="F2546B"/>
+          </a:solidFill>
+          <a:ln w="19050">
+            <a:solidFill>
+              <a:srgbClr val="FFFFFF"/>
+            </a:solidFill>
+            <a:prstDash val="solid"/>
+          </a:ln>
+        </p:spPr>
       </p:sp>
       <p:sp>
         <p:nvSpPr>

</xml_diff>